<commit_message>
Restructure Index and slide titles based on content; refine cover layout
</commit_message>
<xml_diff>
--- a/bank_industry_presentation.pptx
+++ b/bank_industry_presentation.pptx
@@ -3172,8 +3172,8 @@
         </p:nvSpPr>
         <p:spPr>
           <a:xfrm>
-            <a:off x="457200" y="2286000"/>
-            <a:ext cx="5486400" cy="1828800"/>
+            <a:off x="457200" y="1645920"/>
+            <a:ext cx="10972800" cy="1828800"/>
           </a:xfrm>
           <a:prstGeom prst="rect">
             <a:avLst/>
@@ -3201,7 +3201,7 @@
           </a:p>
           <a:p>
             <a:pPr>
-              <a:defRPr sz="2400">
+              <a:defRPr sz="2000">
                 <a:solidFill>
                   <a:srgbClr val="E6D0A4"/>
                 </a:solidFill>
@@ -3222,7 +3222,7 @@
         </p:nvSpPr>
         <p:spPr>
           <a:xfrm>
-            <a:off x="457200" y="2011680"/>
+            <a:off x="457200" y="1371600"/>
             <a:ext cx="914400" cy="91440"/>
           </a:xfrm>
           <a:prstGeom prst="rect">
@@ -3391,7 +3391,7 @@
               </a:defRPr>
             </a:pPr>
             <a:r>
-              <a:t>収益の源泉：利ざやと信用創造</a:t>
+              <a:t>4. 収益の源泉：利ざやと信用創造</a:t>
             </a:r>
           </a:p>
         </p:txBody>
@@ -3677,7 +3677,7 @@
               </a:defRPr>
             </a:pPr>
             <a:r>
-              <a:t>現状の課題：かつてない逆風</a:t>
+              <a:t>5. 業界を取り巻く現状と直面する課題</a:t>
             </a:r>
           </a:p>
         </p:txBody>
@@ -3979,7 +3979,7 @@
               </a:defRPr>
             </a:pPr>
             <a:r>
-              <a:t>今後の展望：変革と新たな価値提供</a:t>
+              <a:t>6. 未来への展望：DXと新たな金融の形</a:t>
             </a:r>
           </a:p>
         </p:txBody>
@@ -4631,7 +4631,7 @@
               </a:defRPr>
             </a:pPr>
             <a:r>
-              <a:t>1. 銀行の本質的役割</a:t>
+              <a:t>1. 銀行の本質的役割と定義</a:t>
             </a:r>
           </a:p>
           <a:p>
@@ -4647,7 +4647,7 @@
               </a:defRPr>
             </a:pPr>
             <a:r>
-              <a:t>2. 歴史が紡ぐ「信頼」の重み</a:t>
+              <a:t>2. 銀行の歴史：中世から現代までの変遷</a:t>
             </a:r>
           </a:p>
           <a:p>
@@ -4663,7 +4663,7 @@
               </a:defRPr>
             </a:pPr>
             <a:r>
-              <a:t>3. 現代の銀行プレイヤーたち</a:t>
+              <a:t>3. 銀行の種類：役割に応じた多様なプレイヤー</a:t>
             </a:r>
           </a:p>
           <a:p>
@@ -4679,7 +4679,7 @@
               </a:defRPr>
             </a:pPr>
             <a:r>
-              <a:t>4. ビジネスモデルと収益の仕組み</a:t>
+              <a:t>4. 3大業務と銀行収益の仕組み</a:t>
             </a:r>
           </a:p>
           <a:p>
@@ -4695,7 +4695,7 @@
               </a:defRPr>
             </a:pPr>
             <a:r>
-              <a:t>5. 業界が直面する大きな課題</a:t>
+              <a:t>5. 業界を取り巻く現状と直面する課題</a:t>
             </a:r>
           </a:p>
           <a:p>
@@ -4711,7 +4711,7 @@
               </a:defRPr>
             </a:pPr>
             <a:r>
-              <a:t>6. 銀行の明日：デジタルとの融合</a:t>
+              <a:t>6. 未来への展望：DXと新たな金融の形</a:t>
             </a:r>
           </a:p>
         </p:txBody>
@@ -4853,7 +4853,7 @@
               </a:defRPr>
             </a:pPr>
             <a:r>
-              <a:t>1. 銀行とは何か - 経済の心臓</a:t>
+              <a:t>1. 銀行の本質的役割と定義</a:t>
             </a:r>
           </a:p>
         </p:txBody>
@@ -5155,7 +5155,7 @@
               </a:defRPr>
             </a:pPr>
             <a:r>
-              <a:t>銀行の歴史：起源と中世ヨーロッパ</a:t>
+              <a:t>2. 銀行の歴史：中世から現代までの変遷</a:t>
             </a:r>
           </a:p>
         </p:txBody>
@@ -5441,7 +5441,7 @@
               </a:defRPr>
             </a:pPr>
             <a:r>
-              <a:t>日本における成立：近代化の礎</a:t>
+              <a:t>2. 銀行の歴史（日本における成立）</a:t>
             </a:r>
           </a:p>
         </p:txBody>
@@ -5727,7 +5727,7 @@
               </a:defRPr>
             </a:pPr>
             <a:r>
-              <a:t>激動の現代史：成長と壊滅、そして再編</a:t>
+              <a:t>2. 銀行の歴史（高度成長〜平成再編）</a:t>
             </a:r>
           </a:p>
         </p:txBody>
@@ -6045,7 +6045,7 @@
               </a:defRPr>
             </a:pPr>
             <a:r>
-              <a:t>銀行の種類：それぞれの役割と特性</a:t>
+              <a:t>3. 銀行の種類：役割に応じた多様なプレイヤー</a:t>
             </a:r>
           </a:p>
         </p:txBody>
@@ -6347,7 +6347,7 @@
               </a:defRPr>
             </a:pPr>
             <a:r>
-              <a:t>多様化するプレイヤー：デジタルへの傾斜</a:t>
+              <a:t>3. 銀行の種類（デジタル・専門特化）</a:t>
             </a:r>
           </a:p>
         </p:txBody>
@@ -6649,7 +6649,7 @@
               </a:defRPr>
             </a:pPr>
             <a:r>
-              <a:t>銀行の3大業務：社会を回す3つの柱</a:t>
+              <a:t>4. 3大業務と銀行収益の仕組み</a:t>
             </a:r>
           </a:p>
         </p:txBody>

</xml_diff>

<commit_message>
Add transition slides (section dividers) for each chapter
</commit_message>
<xml_diff>
--- a/bank_industry_presentation.pptx
+++ b/bank_industry_presentation.pptx
@@ -18,6 +18,12 @@
     <p:sldId id="266" r:id="rId17"/>
     <p:sldId id="267" r:id="rId18"/>
     <p:sldId id="268" r:id="rId19"/>
+    <p:sldId id="269" r:id="rId20"/>
+    <p:sldId id="270" r:id="rId21"/>
+    <p:sldId id="271" r:id="rId22"/>
+    <p:sldId id="272" r:id="rId23"/>
+    <p:sldId id="273" r:id="rId24"/>
+    <p:sldId id="274" r:id="rId25"/>
   </p:sldIdLst>
   <p:sldSz cx="12191695" cy="6858000" type="screen4x3"/>
   <p:notesSz cx="6858000" cy="9144000"/>
@@ -3391,7 +3397,7 @@
               </a:defRPr>
             </a:pPr>
             <a:r>
-              <a:t>4. 収益の源泉：利ざやと信用創造</a:t>
+              <a:t>3. 銀行の種類：役割に応じた多様なプレイヤー</a:t>
             </a:r>
           </a:p>
         </p:txBody>
@@ -3471,7 +3477,7 @@
               </a:defRPr>
             </a:pPr>
             <a:r>
-              <a:t>■ 「利ざや」の仕組み</a:t>
+              <a:t>■ 日本銀行（中央銀行）</a:t>
             </a:r>
           </a:p>
           <a:p>
@@ -3487,7 +3493,7 @@
               </a:defRPr>
             </a:pPr>
             <a:r>
-              <a:t>・貸出金利（受取）と預金利息（支払）の差額こそが利益。</a:t>
+              <a:t>・「銀行の銀行」「政府の銀行」「発券銀行」。</a:t>
             </a:r>
           </a:p>
           <a:p>
@@ -3503,7 +3509,7 @@
               </a:defRPr>
             </a:pPr>
             <a:r>
-              <a:t>■ 信用創造機能</a:t>
+              <a:t>■ 都市銀行（メガバンク）</a:t>
             </a:r>
           </a:p>
           <a:p>
@@ -3519,7 +3525,23 @@
               </a:defRPr>
             </a:pPr>
             <a:r>
-              <a:t>・預金と貸出を繰り返すことで、世の中の通貨量を増大させる。</a:t>
+              <a:t>・三菱UFJ、三井住友、みずほ. 巨大な資本力で国・世界を支える。</a:t>
+            </a:r>
+          </a:p>
+          <a:p>
+            <a:pPr>
+              <a:spcAft>
+                <a:spcPts val="1200"/>
+              </a:spcAft>
+              <a:defRPr sz="2000">
+                <a:solidFill>
+                  <a:srgbClr val="333333"/>
+                </a:solidFill>
+                <a:latin typeface="Hiragino Sans"/>
+              </a:defRPr>
+            </a:pPr>
+            <a:r>
+              <a:t>■ 地方銀行・第二地銀</a:t>
             </a:r>
           </a:p>
           <a:p>
@@ -3535,7 +3557,7 @@
               </a:defRPr>
             </a:pPr>
             <a:r>
-              <a:t>・支払準備制度により安全性を担保しつつ、経済を膨らませる機能。</a:t>
+              <a:t>・「地域密着」。地元企業との信頼関係（リレーションシップ）が命。</a:t>
             </a:r>
           </a:p>
         </p:txBody>
@@ -3677,7 +3699,7 @@
               </a:defRPr>
             </a:pPr>
             <a:r>
-              <a:t>5. 業界を取り巻く現状と直面する課題</a:t>
+              <a:t>3. 銀行の種類（デジタル・専門特化）</a:t>
             </a:r>
           </a:p>
         </p:txBody>
@@ -3757,7 +3779,7 @@
               </a:defRPr>
             </a:pPr>
             <a:r>
-              <a:t>■ 超低金利環境の長期化</a:t>
+              <a:t>■ ネット銀行</a:t>
             </a:r>
           </a:p>
           <a:p>
@@ -3773,7 +3795,7 @@
               </a:defRPr>
             </a:pPr>
             <a:r>
-              <a:t>・利ざやの縮小により、旧来の預貸モデルの限界が露呈。</a:t>
+              <a:t>・楽天、住信SBIなど。店舗を持たず利便性と低コストを追求。</a:t>
             </a:r>
           </a:p>
           <a:p>
@@ -3789,7 +3811,7 @@
               </a:defRPr>
             </a:pPr>
             <a:r>
-              <a:t>■ プラットフォーマーとの競争</a:t>
+              <a:t>■ 信託銀行</a:t>
             </a:r>
           </a:p>
           <a:p>
@@ -3805,7 +3827,7 @@
               </a:defRPr>
             </a:pPr>
             <a:r>
-              <a:t>・PayPayや楽天ポイントなど、銀行を通さない経済圏の拡大。</a:t>
+              <a:t>・遺言、不動産、年金など「管理」をコアとする専門性。</a:t>
             </a:r>
           </a:p>
           <a:p>
@@ -3821,7 +3843,7 @@
               </a:defRPr>
             </a:pPr>
             <a:r>
-              <a:t>■ 顧客喪失への危機感</a:t>
+              <a:t>■ 信用金庫・信用組合</a:t>
             </a:r>
           </a:p>
           <a:p>
@@ -3837,7 +3859,7 @@
               </a:defRPr>
             </a:pPr>
             <a:r>
-              <a:t>・「銀行は必要だが、銀行員はいらなくなる？」という問い。</a:t>
+              <a:t>・地域の相互扶助。利益より地域貢献を優先する非営利組織。</a:t>
             </a:r>
           </a:p>
         </p:txBody>
@@ -3853,14 +3875,6 @@
 <file path=ppt/slides/slide12.xml><?xml version="1.0" encoding="utf-8"?>
 <p:sld xmlns:a="http://schemas.openxmlformats.org/drawingml/2006/main" xmlns:p="http://schemas.openxmlformats.org/presentationml/2006/main" xmlns:r="http://schemas.openxmlformats.org/officeDocument/2006/relationships">
   <p:cSld>
-    <p:bg>
-      <p:bgPr>
-        <a:solidFill>
-          <a:srgbClr val="FEFEFE"/>
-        </a:solidFill>
-        <a:effectLst/>
-      </p:bgPr>
-    </p:bg>
     <p:spTree>
       <p:nvGrpSpPr>
         <p:cNvPr id="1" name=""/>
@@ -3877,7 +3891,7 @@
         <p:spPr>
           <a:xfrm>
             <a:off x="0" y="0"/>
-            <a:ext cx="12191695" cy="45720"/>
+            <a:ext cx="12191695" cy="6858000"/>
           </a:xfrm>
           <a:prstGeom prst="rect">
             <a:avLst/>
@@ -3910,20 +3924,57 @@
       </p:sp>
       <p:sp>
         <p:nvSpPr>
-          <p:cNvPr id="3" name="Rectangle 2"/>
+          <p:cNvPr id="3" name="TextBox 2"/>
+          <p:cNvSpPr txBox="1"/>
+          <p:nvPr/>
+        </p:nvSpPr>
+        <p:spPr>
+          <a:xfrm>
+            <a:off x="0" y="2011680"/>
+            <a:ext cx="12191695" cy="914400"/>
+          </a:xfrm>
+          <a:prstGeom prst="rect">
+            <a:avLst/>
+          </a:prstGeom>
+          <a:noFill/>
+        </p:spPr>
+        <p:txBody>
+          <a:bodyPr wrap="none">
+            <a:spAutoFit/>
+          </a:bodyPr>
+          <a:lstStyle/>
+          <a:p/>
+          <a:p>
+            <a:pPr algn="ctr">
+              <a:defRPr sz="2800">
+                <a:solidFill>
+                  <a:srgbClr val="E6D0A4"/>
+                </a:solidFill>
+                <a:latin typeface="Hiragino Sans"/>
+              </a:defRPr>
+            </a:pPr>
+            <a:r>
+              <a:t>Section 04</a:t>
+            </a:r>
+          </a:p>
+        </p:txBody>
+      </p:sp>
+      <p:sp>
+        <p:nvSpPr>
+          <p:cNvPr id="4" name="Rectangle 3"/>
           <p:cNvSpPr/>
           <p:nvPr/>
         </p:nvSpPr>
         <p:spPr>
           <a:xfrm>
-            <a:off x="457200" y="6492240"/>
-            <a:ext cx="11277295" cy="9144"/>
+            <a:off x="4876678" y="2926080"/>
+            <a:ext cx="2438339" cy="18288"/>
           </a:xfrm>
           <a:prstGeom prst="rect">
             <a:avLst/>
           </a:prstGeom>
           <a:solidFill>
-            <a:srgbClr val="143D98"/>
+            <a:srgbClr val="E6D0A4"/>
           </a:solidFill>
         </p:spPr>
         <p:style>
@@ -3950,14 +4001,14 @@
       </p:sp>
       <p:sp>
         <p:nvSpPr>
-          <p:cNvPr id="4" name="TextBox 3"/>
+          <p:cNvPr id="5" name="TextBox 4"/>
           <p:cNvSpPr txBox="1"/>
           <p:nvPr/>
         </p:nvSpPr>
         <p:spPr>
           <a:xfrm>
-            <a:off x="457200" y="365760"/>
-            <a:ext cx="10972800" cy="914400"/>
+            <a:off x="0" y="3291840"/>
+            <a:ext cx="12191695" cy="1371600"/>
           </a:xfrm>
           <a:prstGeom prst="rect">
             <a:avLst/>
@@ -3969,177 +4020,18 @@
             <a:spAutoFit/>
           </a:bodyPr>
           <a:lstStyle/>
-          <a:p>
-            <a:pPr algn="l">
-              <a:defRPr sz="3200" b="1">
-                <a:solidFill>
-                  <a:srgbClr val="143D98"/>
-                </a:solidFill>
-                <a:latin typeface="Hiragino Sans"/>
-              </a:defRPr>
-            </a:pPr>
-            <a:r>
-              <a:t>6. 未来への展望：DXと新たな金融の形</a:t>
-            </a:r>
-          </a:p>
-        </p:txBody>
-      </p:sp>
-      <p:sp>
-        <p:nvSpPr>
-          <p:cNvPr id="5" name="Rectangle 4"/>
-          <p:cNvSpPr/>
-          <p:nvPr/>
-        </p:nvSpPr>
-        <p:spPr>
-          <a:xfrm>
-            <a:off x="457200" y="1188720"/>
-            <a:ext cx="1371600" cy="45720"/>
-          </a:xfrm>
-          <a:prstGeom prst="rect">
-            <a:avLst/>
-          </a:prstGeom>
-          <a:solidFill>
-            <a:srgbClr val="E6D0A4"/>
-          </a:solidFill>
-        </p:spPr>
-        <p:style>
-          <a:lnRef idx="1">
-            <a:schemeClr val="accent1"/>
-          </a:lnRef>
-          <a:fillRef idx="3">
-            <a:schemeClr val="accent1"/>
-          </a:fillRef>
-          <a:effectRef idx="2">
-            <a:schemeClr val="accent1"/>
-          </a:effectRef>
-          <a:fontRef idx="minor">
-            <a:schemeClr val="lt1"/>
-          </a:fontRef>
-        </p:style>
-        <p:txBody>
-          <a:bodyPr rtlCol="0" anchor="ctr"/>
-          <a:lstStyle/>
-          <a:p>
-            <a:pPr algn="ctr"/>
-          </a:p>
-        </p:txBody>
-      </p:sp>
-      <p:sp>
-        <p:nvSpPr>
-          <p:cNvPr id="6" name="TextBox 5"/>
-          <p:cNvSpPr txBox="1"/>
-          <p:nvPr/>
-        </p:nvSpPr>
-        <p:spPr>
-          <a:xfrm>
-            <a:off x="731520" y="1645920"/>
-            <a:ext cx="10728655" cy="4572000"/>
-          </a:xfrm>
-          <a:prstGeom prst="rect">
-            <a:avLst/>
-          </a:prstGeom>
-          <a:noFill/>
-        </p:spPr>
-        <p:txBody>
-          <a:bodyPr wrap="square">
-            <a:spAutoFit/>
-          </a:bodyPr>
-          <a:lstStyle/>
           <a:p/>
           <a:p>
-            <a:pPr>
-              <a:spcAft>
-                <a:spcPts val="1200"/>
-              </a:spcAft>
-              <a:defRPr sz="2000">
-                <a:solidFill>
-                  <a:srgbClr val="333333"/>
-                </a:solidFill>
-                <a:latin typeface="Hiragino Sans"/>
-              </a:defRPr>
-            </a:pPr>
-            <a:r>
-              <a:t>■ バンキング・アズ・ア・サービス(BaaS)</a:t>
-            </a:r>
-          </a:p>
-          <a:p>
-            <a:pPr lvl="1">
-              <a:spcAft>
-                <a:spcPts val="1200"/>
-              </a:spcAft>
-              <a:defRPr sz="2000">
-                <a:solidFill>
-                  <a:srgbClr val="333333"/>
-                </a:solidFill>
-                <a:latin typeface="Hiragino Sans"/>
-              </a:defRPr>
-            </a:pPr>
-            <a:r>
-              <a:t>・金融機能をパーツとして他業種に提供するプラットフォーム化。</a:t>
-            </a:r>
-          </a:p>
-          <a:p>
-            <a:pPr>
-              <a:spcAft>
-                <a:spcPts val="1200"/>
-              </a:spcAft>
-              <a:defRPr sz="2000">
-                <a:solidFill>
-                  <a:srgbClr val="333333"/>
-                </a:solidFill>
-                <a:latin typeface="Hiragino Sans"/>
-              </a:defRPr>
-            </a:pPr>
-            <a:r>
-              <a:t>■ 融合するテクノロジー：Olive、デジタル通貨</a:t>
-            </a:r>
-          </a:p>
-          <a:p>
-            <a:pPr lvl="1">
-              <a:spcAft>
-                <a:spcPts val="1200"/>
-              </a:spcAft>
-              <a:defRPr sz="2000">
-                <a:solidFill>
-                  <a:srgbClr val="333333"/>
-                </a:solidFill>
-                <a:latin typeface="Hiragino Sans"/>
-              </a:defRPr>
-            </a:pPr>
-            <a:r>
-              <a:t>・銀行口座と決済アプリの完全統合。さらにCBDC（デジタル円）の可能性。</a:t>
-            </a:r>
-          </a:p>
-          <a:p>
-            <a:pPr>
-              <a:spcAft>
-                <a:spcPts val="1200"/>
-              </a:spcAft>
-              <a:defRPr sz="2000">
-                <a:solidFill>
-                  <a:srgbClr val="333333"/>
-                </a:solidFill>
-                <a:latin typeface="Hiragino Sans"/>
-              </a:defRPr>
-            </a:pPr>
-            <a:r>
-              <a:t>■ コンサルタントへの進化</a:t>
-            </a:r>
-          </a:p>
-          <a:p>
-            <a:pPr lvl="1">
-              <a:spcAft>
-                <a:spcPts val="1200"/>
-              </a:spcAft>
-              <a:defRPr sz="2000">
-                <a:solidFill>
-                  <a:srgbClr val="333333"/>
-                </a:solidFill>
-                <a:latin typeface="Hiragino Sans"/>
-              </a:defRPr>
-            </a:pPr>
-            <a:r>
-              <a:t>・「金貸し」から、顧客の経営課題を解決するパートナーへ。</a:t>
+            <a:pPr algn="ctr">
+              <a:defRPr sz="4000" b="1">
+                <a:solidFill>
+                  <a:srgbClr val="FEFEFE"/>
+                </a:solidFill>
+                <a:latin typeface="Hiragino Sans"/>
+              </a:defRPr>
+            </a:pPr>
+            <a:r>
+              <a:t>3大業務と銀行収益の仕組み</a:t>
             </a:r>
           </a:p>
         </p:txBody>
@@ -4281,6 +4173,1510 @@
               </a:defRPr>
             </a:pPr>
             <a:r>
+              <a:t>4. 3大業務と銀行収益の仕組み</a:t>
+            </a:r>
+          </a:p>
+        </p:txBody>
+      </p:sp>
+      <p:sp>
+        <p:nvSpPr>
+          <p:cNvPr id="5" name="Rectangle 4"/>
+          <p:cNvSpPr/>
+          <p:nvPr/>
+        </p:nvSpPr>
+        <p:spPr>
+          <a:xfrm>
+            <a:off x="457200" y="1188720"/>
+            <a:ext cx="1371600" cy="45720"/>
+          </a:xfrm>
+          <a:prstGeom prst="rect">
+            <a:avLst/>
+          </a:prstGeom>
+          <a:solidFill>
+            <a:srgbClr val="E6D0A4"/>
+          </a:solidFill>
+        </p:spPr>
+        <p:style>
+          <a:lnRef idx="1">
+            <a:schemeClr val="accent1"/>
+          </a:lnRef>
+          <a:fillRef idx="3">
+            <a:schemeClr val="accent1"/>
+          </a:fillRef>
+          <a:effectRef idx="2">
+            <a:schemeClr val="accent1"/>
+          </a:effectRef>
+          <a:fontRef idx="minor">
+            <a:schemeClr val="lt1"/>
+          </a:fontRef>
+        </p:style>
+        <p:txBody>
+          <a:bodyPr rtlCol="0" anchor="ctr"/>
+          <a:lstStyle/>
+          <a:p>
+            <a:pPr algn="ctr"/>
+          </a:p>
+        </p:txBody>
+      </p:sp>
+      <p:sp>
+        <p:nvSpPr>
+          <p:cNvPr id="6" name="TextBox 5"/>
+          <p:cNvSpPr txBox="1"/>
+          <p:nvPr/>
+        </p:nvSpPr>
+        <p:spPr>
+          <a:xfrm>
+            <a:off x="731520" y="1645920"/>
+            <a:ext cx="10728655" cy="4572000"/>
+          </a:xfrm>
+          <a:prstGeom prst="rect">
+            <a:avLst/>
+          </a:prstGeom>
+          <a:noFill/>
+        </p:spPr>
+        <p:txBody>
+          <a:bodyPr wrap="square">
+            <a:spAutoFit/>
+          </a:bodyPr>
+          <a:lstStyle/>
+          <a:p/>
+          <a:p>
+            <a:pPr>
+              <a:spcAft>
+                <a:spcPts val="1200"/>
+              </a:spcAft>
+              <a:defRPr sz="2000">
+                <a:solidFill>
+                  <a:srgbClr val="333333"/>
+                </a:solidFill>
+                <a:latin typeface="Hiragino Sans"/>
+              </a:defRPr>
+            </a:pPr>
+            <a:r>
+              <a:t>1. 預金業務：大切な資産を安全に預かる。</a:t>
+            </a:r>
+          </a:p>
+          <a:p>
+            <a:pPr>
+              <a:spcAft>
+                <a:spcPts val="1200"/>
+              </a:spcAft>
+              <a:defRPr sz="2000">
+                <a:solidFill>
+                  <a:srgbClr val="333333"/>
+                </a:solidFill>
+                <a:latin typeface="Hiragino Sans"/>
+              </a:defRPr>
+            </a:pPr>
+            <a:r>
+              <a:t>2. 貸出業務：成長を望む企業や個人へ資金を貸し付ける。</a:t>
+            </a:r>
+          </a:p>
+          <a:p>
+            <a:pPr lvl="1">
+              <a:spcAft>
+                <a:spcPts val="1200"/>
+              </a:spcAft>
+              <a:defRPr sz="2000">
+                <a:solidFill>
+                  <a:srgbClr val="333333"/>
+                </a:solidFill>
+                <a:latin typeface="Hiragino Sans"/>
+              </a:defRPr>
+            </a:pPr>
+            <a:r>
+              <a:t>・証書貸付、手形割引など。</a:t>
+            </a:r>
+          </a:p>
+          <a:p>
+            <a:pPr>
+              <a:spcAft>
+                <a:spcPts val="1200"/>
+              </a:spcAft>
+              <a:defRPr sz="2000">
+                <a:solidFill>
+                  <a:srgbClr val="333333"/>
+                </a:solidFill>
+                <a:latin typeface="Hiragino Sans"/>
+              </a:defRPr>
+            </a:pPr>
+            <a:r>
+              <a:t>3. 為替業務：現金を運ばず、安全・迅速に決済を完了させる。</a:t>
+            </a:r>
+          </a:p>
+        </p:txBody>
+      </p:sp>
+    </p:spTree>
+  </p:cSld>
+  <p:clrMapOvr>
+    <a:masterClrMapping/>
+  </p:clrMapOvr>
+</p:sld>
+</file>
+
+<file path=ppt/slides/slide14.xml><?xml version="1.0" encoding="utf-8"?>
+<p:sld xmlns:a="http://schemas.openxmlformats.org/drawingml/2006/main" xmlns:p="http://schemas.openxmlformats.org/presentationml/2006/main" xmlns:r="http://schemas.openxmlformats.org/officeDocument/2006/relationships">
+  <p:cSld>
+    <p:bg>
+      <p:bgPr>
+        <a:solidFill>
+          <a:srgbClr val="FEFEFE"/>
+        </a:solidFill>
+        <a:effectLst/>
+      </p:bgPr>
+    </p:bg>
+    <p:spTree>
+      <p:nvGrpSpPr>
+        <p:cNvPr id="1" name=""/>
+        <p:cNvGrpSpPr/>
+        <p:nvPr/>
+      </p:nvGrpSpPr>
+      <p:grpSpPr/>
+      <p:sp>
+        <p:nvSpPr>
+          <p:cNvPr id="2" name="Rectangle 1"/>
+          <p:cNvSpPr/>
+          <p:nvPr/>
+        </p:nvSpPr>
+        <p:spPr>
+          <a:xfrm>
+            <a:off x="0" y="0"/>
+            <a:ext cx="12191695" cy="45720"/>
+          </a:xfrm>
+          <a:prstGeom prst="rect">
+            <a:avLst/>
+          </a:prstGeom>
+          <a:solidFill>
+            <a:srgbClr val="143D98"/>
+          </a:solidFill>
+        </p:spPr>
+        <p:style>
+          <a:lnRef idx="1">
+            <a:schemeClr val="accent1"/>
+          </a:lnRef>
+          <a:fillRef idx="3">
+            <a:schemeClr val="accent1"/>
+          </a:fillRef>
+          <a:effectRef idx="2">
+            <a:schemeClr val="accent1"/>
+          </a:effectRef>
+          <a:fontRef idx="minor">
+            <a:schemeClr val="lt1"/>
+          </a:fontRef>
+        </p:style>
+        <p:txBody>
+          <a:bodyPr rtlCol="0" anchor="ctr"/>
+          <a:lstStyle/>
+          <a:p>
+            <a:pPr algn="ctr"/>
+          </a:p>
+        </p:txBody>
+      </p:sp>
+      <p:sp>
+        <p:nvSpPr>
+          <p:cNvPr id="3" name="Rectangle 2"/>
+          <p:cNvSpPr/>
+          <p:nvPr/>
+        </p:nvSpPr>
+        <p:spPr>
+          <a:xfrm>
+            <a:off x="457200" y="6492240"/>
+            <a:ext cx="11277295" cy="9144"/>
+          </a:xfrm>
+          <a:prstGeom prst="rect">
+            <a:avLst/>
+          </a:prstGeom>
+          <a:solidFill>
+            <a:srgbClr val="143D98"/>
+          </a:solidFill>
+        </p:spPr>
+        <p:style>
+          <a:lnRef idx="1">
+            <a:schemeClr val="accent1"/>
+          </a:lnRef>
+          <a:fillRef idx="3">
+            <a:schemeClr val="accent1"/>
+          </a:fillRef>
+          <a:effectRef idx="2">
+            <a:schemeClr val="accent1"/>
+          </a:effectRef>
+          <a:fontRef idx="minor">
+            <a:schemeClr val="lt1"/>
+          </a:fontRef>
+        </p:style>
+        <p:txBody>
+          <a:bodyPr rtlCol="0" anchor="ctr"/>
+          <a:lstStyle/>
+          <a:p>
+            <a:pPr algn="ctr"/>
+          </a:p>
+        </p:txBody>
+      </p:sp>
+      <p:sp>
+        <p:nvSpPr>
+          <p:cNvPr id="4" name="TextBox 3"/>
+          <p:cNvSpPr txBox="1"/>
+          <p:nvPr/>
+        </p:nvSpPr>
+        <p:spPr>
+          <a:xfrm>
+            <a:off x="457200" y="365760"/>
+            <a:ext cx="10972800" cy="914400"/>
+          </a:xfrm>
+          <a:prstGeom prst="rect">
+            <a:avLst/>
+          </a:prstGeom>
+          <a:noFill/>
+        </p:spPr>
+        <p:txBody>
+          <a:bodyPr wrap="none">
+            <a:spAutoFit/>
+          </a:bodyPr>
+          <a:lstStyle/>
+          <a:p>
+            <a:pPr algn="l">
+              <a:defRPr sz="3200" b="1">
+                <a:solidFill>
+                  <a:srgbClr val="143D98"/>
+                </a:solidFill>
+                <a:latin typeface="Hiragino Sans"/>
+              </a:defRPr>
+            </a:pPr>
+            <a:r>
+              <a:t>4. 収益の源泉：利ざやと信用創造</a:t>
+            </a:r>
+          </a:p>
+        </p:txBody>
+      </p:sp>
+      <p:sp>
+        <p:nvSpPr>
+          <p:cNvPr id="5" name="Rectangle 4"/>
+          <p:cNvSpPr/>
+          <p:nvPr/>
+        </p:nvSpPr>
+        <p:spPr>
+          <a:xfrm>
+            <a:off x="457200" y="1188720"/>
+            <a:ext cx="1371600" cy="45720"/>
+          </a:xfrm>
+          <a:prstGeom prst="rect">
+            <a:avLst/>
+          </a:prstGeom>
+          <a:solidFill>
+            <a:srgbClr val="E6D0A4"/>
+          </a:solidFill>
+        </p:spPr>
+        <p:style>
+          <a:lnRef idx="1">
+            <a:schemeClr val="accent1"/>
+          </a:lnRef>
+          <a:fillRef idx="3">
+            <a:schemeClr val="accent1"/>
+          </a:fillRef>
+          <a:effectRef idx="2">
+            <a:schemeClr val="accent1"/>
+          </a:effectRef>
+          <a:fontRef idx="minor">
+            <a:schemeClr val="lt1"/>
+          </a:fontRef>
+        </p:style>
+        <p:txBody>
+          <a:bodyPr rtlCol="0" anchor="ctr"/>
+          <a:lstStyle/>
+          <a:p>
+            <a:pPr algn="ctr"/>
+          </a:p>
+        </p:txBody>
+      </p:sp>
+      <p:sp>
+        <p:nvSpPr>
+          <p:cNvPr id="6" name="TextBox 5"/>
+          <p:cNvSpPr txBox="1"/>
+          <p:nvPr/>
+        </p:nvSpPr>
+        <p:spPr>
+          <a:xfrm>
+            <a:off x="731520" y="1645920"/>
+            <a:ext cx="10728655" cy="4572000"/>
+          </a:xfrm>
+          <a:prstGeom prst="rect">
+            <a:avLst/>
+          </a:prstGeom>
+          <a:noFill/>
+        </p:spPr>
+        <p:txBody>
+          <a:bodyPr wrap="square">
+            <a:spAutoFit/>
+          </a:bodyPr>
+          <a:lstStyle/>
+          <a:p/>
+          <a:p>
+            <a:pPr>
+              <a:spcAft>
+                <a:spcPts val="1200"/>
+              </a:spcAft>
+              <a:defRPr sz="2000">
+                <a:solidFill>
+                  <a:srgbClr val="333333"/>
+                </a:solidFill>
+                <a:latin typeface="Hiragino Sans"/>
+              </a:defRPr>
+            </a:pPr>
+            <a:r>
+              <a:t>■ 「利ざや」の仕組み</a:t>
+            </a:r>
+          </a:p>
+          <a:p>
+            <a:pPr lvl="1">
+              <a:spcAft>
+                <a:spcPts val="1200"/>
+              </a:spcAft>
+              <a:defRPr sz="2000">
+                <a:solidFill>
+                  <a:srgbClr val="333333"/>
+                </a:solidFill>
+                <a:latin typeface="Hiragino Sans"/>
+              </a:defRPr>
+            </a:pPr>
+            <a:r>
+              <a:t>・貸出金利（受取）と預金利息（支払）の差額こそが利益。</a:t>
+            </a:r>
+          </a:p>
+          <a:p>
+            <a:pPr>
+              <a:spcAft>
+                <a:spcPts val="1200"/>
+              </a:spcAft>
+              <a:defRPr sz="2000">
+                <a:solidFill>
+                  <a:srgbClr val="333333"/>
+                </a:solidFill>
+                <a:latin typeface="Hiragino Sans"/>
+              </a:defRPr>
+            </a:pPr>
+            <a:r>
+              <a:t>■ 信用創造機能</a:t>
+            </a:r>
+          </a:p>
+          <a:p>
+            <a:pPr lvl="1">
+              <a:spcAft>
+                <a:spcPts val="1200"/>
+              </a:spcAft>
+              <a:defRPr sz="2000">
+                <a:solidFill>
+                  <a:srgbClr val="333333"/>
+                </a:solidFill>
+                <a:latin typeface="Hiragino Sans"/>
+              </a:defRPr>
+            </a:pPr>
+            <a:r>
+              <a:t>・預金と貸出を繰り返すことで、世の中の通貨量を増大させる。</a:t>
+            </a:r>
+          </a:p>
+          <a:p>
+            <a:pPr lvl="1">
+              <a:spcAft>
+                <a:spcPts val="1200"/>
+              </a:spcAft>
+              <a:defRPr sz="2000">
+                <a:solidFill>
+                  <a:srgbClr val="333333"/>
+                </a:solidFill>
+                <a:latin typeface="Hiragino Sans"/>
+              </a:defRPr>
+            </a:pPr>
+            <a:r>
+              <a:t>・支払準備制度により安全性を担保しつつ、経済を膨らませる機能。</a:t>
+            </a:r>
+          </a:p>
+        </p:txBody>
+      </p:sp>
+    </p:spTree>
+  </p:cSld>
+  <p:clrMapOvr>
+    <a:masterClrMapping/>
+  </p:clrMapOvr>
+</p:sld>
+</file>
+
+<file path=ppt/slides/slide15.xml><?xml version="1.0" encoding="utf-8"?>
+<p:sld xmlns:a="http://schemas.openxmlformats.org/drawingml/2006/main" xmlns:p="http://schemas.openxmlformats.org/presentationml/2006/main" xmlns:r="http://schemas.openxmlformats.org/officeDocument/2006/relationships">
+  <p:cSld>
+    <p:spTree>
+      <p:nvGrpSpPr>
+        <p:cNvPr id="1" name=""/>
+        <p:cNvGrpSpPr/>
+        <p:nvPr/>
+      </p:nvGrpSpPr>
+      <p:grpSpPr/>
+      <p:sp>
+        <p:nvSpPr>
+          <p:cNvPr id="2" name="Rectangle 1"/>
+          <p:cNvSpPr/>
+          <p:nvPr/>
+        </p:nvSpPr>
+        <p:spPr>
+          <a:xfrm>
+            <a:off x="0" y="0"/>
+            <a:ext cx="12191695" cy="6858000"/>
+          </a:xfrm>
+          <a:prstGeom prst="rect">
+            <a:avLst/>
+          </a:prstGeom>
+          <a:solidFill>
+            <a:srgbClr val="143D98"/>
+          </a:solidFill>
+        </p:spPr>
+        <p:style>
+          <a:lnRef idx="1">
+            <a:schemeClr val="accent1"/>
+          </a:lnRef>
+          <a:fillRef idx="3">
+            <a:schemeClr val="accent1"/>
+          </a:fillRef>
+          <a:effectRef idx="2">
+            <a:schemeClr val="accent1"/>
+          </a:effectRef>
+          <a:fontRef idx="minor">
+            <a:schemeClr val="lt1"/>
+          </a:fontRef>
+        </p:style>
+        <p:txBody>
+          <a:bodyPr rtlCol="0" anchor="ctr"/>
+          <a:lstStyle/>
+          <a:p>
+            <a:pPr algn="ctr"/>
+          </a:p>
+        </p:txBody>
+      </p:sp>
+      <p:sp>
+        <p:nvSpPr>
+          <p:cNvPr id="3" name="TextBox 2"/>
+          <p:cNvSpPr txBox="1"/>
+          <p:nvPr/>
+        </p:nvSpPr>
+        <p:spPr>
+          <a:xfrm>
+            <a:off x="0" y="2011680"/>
+            <a:ext cx="12191695" cy="914400"/>
+          </a:xfrm>
+          <a:prstGeom prst="rect">
+            <a:avLst/>
+          </a:prstGeom>
+          <a:noFill/>
+        </p:spPr>
+        <p:txBody>
+          <a:bodyPr wrap="none">
+            <a:spAutoFit/>
+          </a:bodyPr>
+          <a:lstStyle/>
+          <a:p/>
+          <a:p>
+            <a:pPr algn="ctr">
+              <a:defRPr sz="2800">
+                <a:solidFill>
+                  <a:srgbClr val="E6D0A4"/>
+                </a:solidFill>
+                <a:latin typeface="Hiragino Sans"/>
+              </a:defRPr>
+            </a:pPr>
+            <a:r>
+              <a:t>Section 05</a:t>
+            </a:r>
+          </a:p>
+        </p:txBody>
+      </p:sp>
+      <p:sp>
+        <p:nvSpPr>
+          <p:cNvPr id="4" name="Rectangle 3"/>
+          <p:cNvSpPr/>
+          <p:nvPr/>
+        </p:nvSpPr>
+        <p:spPr>
+          <a:xfrm>
+            <a:off x="4876678" y="2926080"/>
+            <a:ext cx="2438339" cy="18288"/>
+          </a:xfrm>
+          <a:prstGeom prst="rect">
+            <a:avLst/>
+          </a:prstGeom>
+          <a:solidFill>
+            <a:srgbClr val="E6D0A4"/>
+          </a:solidFill>
+        </p:spPr>
+        <p:style>
+          <a:lnRef idx="1">
+            <a:schemeClr val="accent1"/>
+          </a:lnRef>
+          <a:fillRef idx="3">
+            <a:schemeClr val="accent1"/>
+          </a:fillRef>
+          <a:effectRef idx="2">
+            <a:schemeClr val="accent1"/>
+          </a:effectRef>
+          <a:fontRef idx="minor">
+            <a:schemeClr val="lt1"/>
+          </a:fontRef>
+        </p:style>
+        <p:txBody>
+          <a:bodyPr rtlCol="0" anchor="ctr"/>
+          <a:lstStyle/>
+          <a:p>
+            <a:pPr algn="ctr"/>
+          </a:p>
+        </p:txBody>
+      </p:sp>
+      <p:sp>
+        <p:nvSpPr>
+          <p:cNvPr id="5" name="TextBox 4"/>
+          <p:cNvSpPr txBox="1"/>
+          <p:nvPr/>
+        </p:nvSpPr>
+        <p:spPr>
+          <a:xfrm>
+            <a:off x="0" y="3291840"/>
+            <a:ext cx="12191695" cy="1371600"/>
+          </a:xfrm>
+          <a:prstGeom prst="rect">
+            <a:avLst/>
+          </a:prstGeom>
+          <a:noFill/>
+        </p:spPr>
+        <p:txBody>
+          <a:bodyPr wrap="none">
+            <a:spAutoFit/>
+          </a:bodyPr>
+          <a:lstStyle/>
+          <a:p/>
+          <a:p>
+            <a:pPr algn="ctr">
+              <a:defRPr sz="4000" b="1">
+                <a:solidFill>
+                  <a:srgbClr val="FEFEFE"/>
+                </a:solidFill>
+                <a:latin typeface="Hiragino Sans"/>
+              </a:defRPr>
+            </a:pPr>
+            <a:r>
+              <a:t>業界を取り巻く現状と直面する課題</a:t>
+            </a:r>
+          </a:p>
+        </p:txBody>
+      </p:sp>
+    </p:spTree>
+  </p:cSld>
+  <p:clrMapOvr>
+    <a:masterClrMapping/>
+  </p:clrMapOvr>
+</p:sld>
+</file>
+
+<file path=ppt/slides/slide16.xml><?xml version="1.0" encoding="utf-8"?>
+<p:sld xmlns:a="http://schemas.openxmlformats.org/drawingml/2006/main" xmlns:p="http://schemas.openxmlformats.org/presentationml/2006/main" xmlns:r="http://schemas.openxmlformats.org/officeDocument/2006/relationships">
+  <p:cSld>
+    <p:bg>
+      <p:bgPr>
+        <a:solidFill>
+          <a:srgbClr val="FEFEFE"/>
+        </a:solidFill>
+        <a:effectLst/>
+      </p:bgPr>
+    </p:bg>
+    <p:spTree>
+      <p:nvGrpSpPr>
+        <p:cNvPr id="1" name=""/>
+        <p:cNvGrpSpPr/>
+        <p:nvPr/>
+      </p:nvGrpSpPr>
+      <p:grpSpPr/>
+      <p:sp>
+        <p:nvSpPr>
+          <p:cNvPr id="2" name="Rectangle 1"/>
+          <p:cNvSpPr/>
+          <p:nvPr/>
+        </p:nvSpPr>
+        <p:spPr>
+          <a:xfrm>
+            <a:off x="0" y="0"/>
+            <a:ext cx="12191695" cy="45720"/>
+          </a:xfrm>
+          <a:prstGeom prst="rect">
+            <a:avLst/>
+          </a:prstGeom>
+          <a:solidFill>
+            <a:srgbClr val="143D98"/>
+          </a:solidFill>
+        </p:spPr>
+        <p:style>
+          <a:lnRef idx="1">
+            <a:schemeClr val="accent1"/>
+          </a:lnRef>
+          <a:fillRef idx="3">
+            <a:schemeClr val="accent1"/>
+          </a:fillRef>
+          <a:effectRef idx="2">
+            <a:schemeClr val="accent1"/>
+          </a:effectRef>
+          <a:fontRef idx="minor">
+            <a:schemeClr val="lt1"/>
+          </a:fontRef>
+        </p:style>
+        <p:txBody>
+          <a:bodyPr rtlCol="0" anchor="ctr"/>
+          <a:lstStyle/>
+          <a:p>
+            <a:pPr algn="ctr"/>
+          </a:p>
+        </p:txBody>
+      </p:sp>
+      <p:sp>
+        <p:nvSpPr>
+          <p:cNvPr id="3" name="Rectangle 2"/>
+          <p:cNvSpPr/>
+          <p:nvPr/>
+        </p:nvSpPr>
+        <p:spPr>
+          <a:xfrm>
+            <a:off x="457200" y="6492240"/>
+            <a:ext cx="11277295" cy="9144"/>
+          </a:xfrm>
+          <a:prstGeom prst="rect">
+            <a:avLst/>
+          </a:prstGeom>
+          <a:solidFill>
+            <a:srgbClr val="143D98"/>
+          </a:solidFill>
+        </p:spPr>
+        <p:style>
+          <a:lnRef idx="1">
+            <a:schemeClr val="accent1"/>
+          </a:lnRef>
+          <a:fillRef idx="3">
+            <a:schemeClr val="accent1"/>
+          </a:fillRef>
+          <a:effectRef idx="2">
+            <a:schemeClr val="accent1"/>
+          </a:effectRef>
+          <a:fontRef idx="minor">
+            <a:schemeClr val="lt1"/>
+          </a:fontRef>
+        </p:style>
+        <p:txBody>
+          <a:bodyPr rtlCol="0" anchor="ctr"/>
+          <a:lstStyle/>
+          <a:p>
+            <a:pPr algn="ctr"/>
+          </a:p>
+        </p:txBody>
+      </p:sp>
+      <p:sp>
+        <p:nvSpPr>
+          <p:cNvPr id="4" name="TextBox 3"/>
+          <p:cNvSpPr txBox="1"/>
+          <p:nvPr/>
+        </p:nvSpPr>
+        <p:spPr>
+          <a:xfrm>
+            <a:off x="457200" y="365760"/>
+            <a:ext cx="10972800" cy="914400"/>
+          </a:xfrm>
+          <a:prstGeom prst="rect">
+            <a:avLst/>
+          </a:prstGeom>
+          <a:noFill/>
+        </p:spPr>
+        <p:txBody>
+          <a:bodyPr wrap="none">
+            <a:spAutoFit/>
+          </a:bodyPr>
+          <a:lstStyle/>
+          <a:p>
+            <a:pPr algn="l">
+              <a:defRPr sz="3200" b="1">
+                <a:solidFill>
+                  <a:srgbClr val="143D98"/>
+                </a:solidFill>
+                <a:latin typeface="Hiragino Sans"/>
+              </a:defRPr>
+            </a:pPr>
+            <a:r>
+              <a:t>5. 業界を取り巻く現状と直面する課題</a:t>
+            </a:r>
+          </a:p>
+        </p:txBody>
+      </p:sp>
+      <p:sp>
+        <p:nvSpPr>
+          <p:cNvPr id="5" name="Rectangle 4"/>
+          <p:cNvSpPr/>
+          <p:nvPr/>
+        </p:nvSpPr>
+        <p:spPr>
+          <a:xfrm>
+            <a:off x="457200" y="1188720"/>
+            <a:ext cx="1371600" cy="45720"/>
+          </a:xfrm>
+          <a:prstGeom prst="rect">
+            <a:avLst/>
+          </a:prstGeom>
+          <a:solidFill>
+            <a:srgbClr val="E6D0A4"/>
+          </a:solidFill>
+        </p:spPr>
+        <p:style>
+          <a:lnRef idx="1">
+            <a:schemeClr val="accent1"/>
+          </a:lnRef>
+          <a:fillRef idx="3">
+            <a:schemeClr val="accent1"/>
+          </a:fillRef>
+          <a:effectRef idx="2">
+            <a:schemeClr val="accent1"/>
+          </a:effectRef>
+          <a:fontRef idx="minor">
+            <a:schemeClr val="lt1"/>
+          </a:fontRef>
+        </p:style>
+        <p:txBody>
+          <a:bodyPr rtlCol="0" anchor="ctr"/>
+          <a:lstStyle/>
+          <a:p>
+            <a:pPr algn="ctr"/>
+          </a:p>
+        </p:txBody>
+      </p:sp>
+      <p:sp>
+        <p:nvSpPr>
+          <p:cNvPr id="6" name="TextBox 5"/>
+          <p:cNvSpPr txBox="1"/>
+          <p:nvPr/>
+        </p:nvSpPr>
+        <p:spPr>
+          <a:xfrm>
+            <a:off x="731520" y="1645920"/>
+            <a:ext cx="10728655" cy="4572000"/>
+          </a:xfrm>
+          <a:prstGeom prst="rect">
+            <a:avLst/>
+          </a:prstGeom>
+          <a:noFill/>
+        </p:spPr>
+        <p:txBody>
+          <a:bodyPr wrap="square">
+            <a:spAutoFit/>
+          </a:bodyPr>
+          <a:lstStyle/>
+          <a:p/>
+          <a:p>
+            <a:pPr>
+              <a:spcAft>
+                <a:spcPts val="1200"/>
+              </a:spcAft>
+              <a:defRPr sz="2000">
+                <a:solidFill>
+                  <a:srgbClr val="333333"/>
+                </a:solidFill>
+                <a:latin typeface="Hiragino Sans"/>
+              </a:defRPr>
+            </a:pPr>
+            <a:r>
+              <a:t>■ 超低金利環境の長期化</a:t>
+            </a:r>
+          </a:p>
+          <a:p>
+            <a:pPr lvl="1">
+              <a:spcAft>
+                <a:spcPts val="1200"/>
+              </a:spcAft>
+              <a:defRPr sz="2000">
+                <a:solidFill>
+                  <a:srgbClr val="333333"/>
+                </a:solidFill>
+                <a:latin typeface="Hiragino Sans"/>
+              </a:defRPr>
+            </a:pPr>
+            <a:r>
+              <a:t>・利ざやの縮小により、旧来の預貸モデルの限界が露呈。</a:t>
+            </a:r>
+          </a:p>
+          <a:p>
+            <a:pPr>
+              <a:spcAft>
+                <a:spcPts val="1200"/>
+              </a:spcAft>
+              <a:defRPr sz="2000">
+                <a:solidFill>
+                  <a:srgbClr val="333333"/>
+                </a:solidFill>
+                <a:latin typeface="Hiragino Sans"/>
+              </a:defRPr>
+            </a:pPr>
+            <a:r>
+              <a:t>■ プラットフォーマーとの競争</a:t>
+            </a:r>
+          </a:p>
+          <a:p>
+            <a:pPr lvl="1">
+              <a:spcAft>
+                <a:spcPts val="1200"/>
+              </a:spcAft>
+              <a:defRPr sz="2000">
+                <a:solidFill>
+                  <a:srgbClr val="333333"/>
+                </a:solidFill>
+                <a:latin typeface="Hiragino Sans"/>
+              </a:defRPr>
+            </a:pPr>
+            <a:r>
+              <a:t>・PayPayや楽天ポイントなど、銀行を通さない経済圏の拡大。</a:t>
+            </a:r>
+          </a:p>
+          <a:p>
+            <a:pPr>
+              <a:spcAft>
+                <a:spcPts val="1200"/>
+              </a:spcAft>
+              <a:defRPr sz="2000">
+                <a:solidFill>
+                  <a:srgbClr val="333333"/>
+                </a:solidFill>
+                <a:latin typeface="Hiragino Sans"/>
+              </a:defRPr>
+            </a:pPr>
+            <a:r>
+              <a:t>■ 顧客喪失への危機感</a:t>
+            </a:r>
+          </a:p>
+          <a:p>
+            <a:pPr lvl="1">
+              <a:spcAft>
+                <a:spcPts val="1200"/>
+              </a:spcAft>
+              <a:defRPr sz="2000">
+                <a:solidFill>
+                  <a:srgbClr val="333333"/>
+                </a:solidFill>
+                <a:latin typeface="Hiragino Sans"/>
+              </a:defRPr>
+            </a:pPr>
+            <a:r>
+              <a:t>・「銀行は必要だが、銀行員はいらなくなる？」という問い。</a:t>
+            </a:r>
+          </a:p>
+        </p:txBody>
+      </p:sp>
+    </p:spTree>
+  </p:cSld>
+  <p:clrMapOvr>
+    <a:masterClrMapping/>
+  </p:clrMapOvr>
+</p:sld>
+</file>
+
+<file path=ppt/slides/slide17.xml><?xml version="1.0" encoding="utf-8"?>
+<p:sld xmlns:a="http://schemas.openxmlformats.org/drawingml/2006/main" xmlns:p="http://schemas.openxmlformats.org/presentationml/2006/main" xmlns:r="http://schemas.openxmlformats.org/officeDocument/2006/relationships">
+  <p:cSld>
+    <p:spTree>
+      <p:nvGrpSpPr>
+        <p:cNvPr id="1" name=""/>
+        <p:cNvGrpSpPr/>
+        <p:nvPr/>
+      </p:nvGrpSpPr>
+      <p:grpSpPr/>
+      <p:sp>
+        <p:nvSpPr>
+          <p:cNvPr id="2" name="Rectangle 1"/>
+          <p:cNvSpPr/>
+          <p:nvPr/>
+        </p:nvSpPr>
+        <p:spPr>
+          <a:xfrm>
+            <a:off x="0" y="0"/>
+            <a:ext cx="12191695" cy="6858000"/>
+          </a:xfrm>
+          <a:prstGeom prst="rect">
+            <a:avLst/>
+          </a:prstGeom>
+          <a:solidFill>
+            <a:srgbClr val="143D98"/>
+          </a:solidFill>
+        </p:spPr>
+        <p:style>
+          <a:lnRef idx="1">
+            <a:schemeClr val="accent1"/>
+          </a:lnRef>
+          <a:fillRef idx="3">
+            <a:schemeClr val="accent1"/>
+          </a:fillRef>
+          <a:effectRef idx="2">
+            <a:schemeClr val="accent1"/>
+          </a:effectRef>
+          <a:fontRef idx="minor">
+            <a:schemeClr val="lt1"/>
+          </a:fontRef>
+        </p:style>
+        <p:txBody>
+          <a:bodyPr rtlCol="0" anchor="ctr"/>
+          <a:lstStyle/>
+          <a:p>
+            <a:pPr algn="ctr"/>
+          </a:p>
+        </p:txBody>
+      </p:sp>
+      <p:sp>
+        <p:nvSpPr>
+          <p:cNvPr id="3" name="TextBox 2"/>
+          <p:cNvSpPr txBox="1"/>
+          <p:nvPr/>
+        </p:nvSpPr>
+        <p:spPr>
+          <a:xfrm>
+            <a:off x="0" y="2011680"/>
+            <a:ext cx="12191695" cy="914400"/>
+          </a:xfrm>
+          <a:prstGeom prst="rect">
+            <a:avLst/>
+          </a:prstGeom>
+          <a:noFill/>
+        </p:spPr>
+        <p:txBody>
+          <a:bodyPr wrap="none">
+            <a:spAutoFit/>
+          </a:bodyPr>
+          <a:lstStyle/>
+          <a:p/>
+          <a:p>
+            <a:pPr algn="ctr">
+              <a:defRPr sz="2800">
+                <a:solidFill>
+                  <a:srgbClr val="E6D0A4"/>
+                </a:solidFill>
+                <a:latin typeface="Hiragino Sans"/>
+              </a:defRPr>
+            </a:pPr>
+            <a:r>
+              <a:t>Section 06</a:t>
+            </a:r>
+          </a:p>
+        </p:txBody>
+      </p:sp>
+      <p:sp>
+        <p:nvSpPr>
+          <p:cNvPr id="4" name="Rectangle 3"/>
+          <p:cNvSpPr/>
+          <p:nvPr/>
+        </p:nvSpPr>
+        <p:spPr>
+          <a:xfrm>
+            <a:off x="4876678" y="2926080"/>
+            <a:ext cx="2438339" cy="18288"/>
+          </a:xfrm>
+          <a:prstGeom prst="rect">
+            <a:avLst/>
+          </a:prstGeom>
+          <a:solidFill>
+            <a:srgbClr val="E6D0A4"/>
+          </a:solidFill>
+        </p:spPr>
+        <p:style>
+          <a:lnRef idx="1">
+            <a:schemeClr val="accent1"/>
+          </a:lnRef>
+          <a:fillRef idx="3">
+            <a:schemeClr val="accent1"/>
+          </a:fillRef>
+          <a:effectRef idx="2">
+            <a:schemeClr val="accent1"/>
+          </a:effectRef>
+          <a:fontRef idx="minor">
+            <a:schemeClr val="lt1"/>
+          </a:fontRef>
+        </p:style>
+        <p:txBody>
+          <a:bodyPr rtlCol="0" anchor="ctr"/>
+          <a:lstStyle/>
+          <a:p>
+            <a:pPr algn="ctr"/>
+          </a:p>
+        </p:txBody>
+      </p:sp>
+      <p:sp>
+        <p:nvSpPr>
+          <p:cNvPr id="5" name="TextBox 4"/>
+          <p:cNvSpPr txBox="1"/>
+          <p:nvPr/>
+        </p:nvSpPr>
+        <p:spPr>
+          <a:xfrm>
+            <a:off x="0" y="3291840"/>
+            <a:ext cx="12191695" cy="1371600"/>
+          </a:xfrm>
+          <a:prstGeom prst="rect">
+            <a:avLst/>
+          </a:prstGeom>
+          <a:noFill/>
+        </p:spPr>
+        <p:txBody>
+          <a:bodyPr wrap="none">
+            <a:spAutoFit/>
+          </a:bodyPr>
+          <a:lstStyle/>
+          <a:p/>
+          <a:p>
+            <a:pPr algn="ctr">
+              <a:defRPr sz="4000" b="1">
+                <a:solidFill>
+                  <a:srgbClr val="FEFEFE"/>
+                </a:solidFill>
+                <a:latin typeface="Hiragino Sans"/>
+              </a:defRPr>
+            </a:pPr>
+            <a:r>
+              <a:t>未来への展望：DXと新たな金融の形</a:t>
+            </a:r>
+          </a:p>
+        </p:txBody>
+      </p:sp>
+    </p:spTree>
+  </p:cSld>
+  <p:clrMapOvr>
+    <a:masterClrMapping/>
+  </p:clrMapOvr>
+</p:sld>
+</file>
+
+<file path=ppt/slides/slide18.xml><?xml version="1.0" encoding="utf-8"?>
+<p:sld xmlns:a="http://schemas.openxmlformats.org/drawingml/2006/main" xmlns:p="http://schemas.openxmlformats.org/presentationml/2006/main" xmlns:r="http://schemas.openxmlformats.org/officeDocument/2006/relationships">
+  <p:cSld>
+    <p:bg>
+      <p:bgPr>
+        <a:solidFill>
+          <a:srgbClr val="FEFEFE"/>
+        </a:solidFill>
+        <a:effectLst/>
+      </p:bgPr>
+    </p:bg>
+    <p:spTree>
+      <p:nvGrpSpPr>
+        <p:cNvPr id="1" name=""/>
+        <p:cNvGrpSpPr/>
+        <p:nvPr/>
+      </p:nvGrpSpPr>
+      <p:grpSpPr/>
+      <p:sp>
+        <p:nvSpPr>
+          <p:cNvPr id="2" name="Rectangle 1"/>
+          <p:cNvSpPr/>
+          <p:nvPr/>
+        </p:nvSpPr>
+        <p:spPr>
+          <a:xfrm>
+            <a:off x="0" y="0"/>
+            <a:ext cx="12191695" cy="45720"/>
+          </a:xfrm>
+          <a:prstGeom prst="rect">
+            <a:avLst/>
+          </a:prstGeom>
+          <a:solidFill>
+            <a:srgbClr val="143D98"/>
+          </a:solidFill>
+        </p:spPr>
+        <p:style>
+          <a:lnRef idx="1">
+            <a:schemeClr val="accent1"/>
+          </a:lnRef>
+          <a:fillRef idx="3">
+            <a:schemeClr val="accent1"/>
+          </a:fillRef>
+          <a:effectRef idx="2">
+            <a:schemeClr val="accent1"/>
+          </a:effectRef>
+          <a:fontRef idx="minor">
+            <a:schemeClr val="lt1"/>
+          </a:fontRef>
+        </p:style>
+        <p:txBody>
+          <a:bodyPr rtlCol="0" anchor="ctr"/>
+          <a:lstStyle/>
+          <a:p>
+            <a:pPr algn="ctr"/>
+          </a:p>
+        </p:txBody>
+      </p:sp>
+      <p:sp>
+        <p:nvSpPr>
+          <p:cNvPr id="3" name="Rectangle 2"/>
+          <p:cNvSpPr/>
+          <p:nvPr/>
+        </p:nvSpPr>
+        <p:spPr>
+          <a:xfrm>
+            <a:off x="457200" y="6492240"/>
+            <a:ext cx="11277295" cy="9144"/>
+          </a:xfrm>
+          <a:prstGeom prst="rect">
+            <a:avLst/>
+          </a:prstGeom>
+          <a:solidFill>
+            <a:srgbClr val="143D98"/>
+          </a:solidFill>
+        </p:spPr>
+        <p:style>
+          <a:lnRef idx="1">
+            <a:schemeClr val="accent1"/>
+          </a:lnRef>
+          <a:fillRef idx="3">
+            <a:schemeClr val="accent1"/>
+          </a:fillRef>
+          <a:effectRef idx="2">
+            <a:schemeClr val="accent1"/>
+          </a:effectRef>
+          <a:fontRef idx="minor">
+            <a:schemeClr val="lt1"/>
+          </a:fontRef>
+        </p:style>
+        <p:txBody>
+          <a:bodyPr rtlCol="0" anchor="ctr"/>
+          <a:lstStyle/>
+          <a:p>
+            <a:pPr algn="ctr"/>
+          </a:p>
+        </p:txBody>
+      </p:sp>
+      <p:sp>
+        <p:nvSpPr>
+          <p:cNvPr id="4" name="TextBox 3"/>
+          <p:cNvSpPr txBox="1"/>
+          <p:nvPr/>
+        </p:nvSpPr>
+        <p:spPr>
+          <a:xfrm>
+            <a:off x="457200" y="365760"/>
+            <a:ext cx="10972800" cy="914400"/>
+          </a:xfrm>
+          <a:prstGeom prst="rect">
+            <a:avLst/>
+          </a:prstGeom>
+          <a:noFill/>
+        </p:spPr>
+        <p:txBody>
+          <a:bodyPr wrap="none">
+            <a:spAutoFit/>
+          </a:bodyPr>
+          <a:lstStyle/>
+          <a:p>
+            <a:pPr algn="l">
+              <a:defRPr sz="3200" b="1">
+                <a:solidFill>
+                  <a:srgbClr val="143D98"/>
+                </a:solidFill>
+                <a:latin typeface="Hiragino Sans"/>
+              </a:defRPr>
+            </a:pPr>
+            <a:r>
+              <a:t>6. 未来への展望：DXと新たな金融の形</a:t>
+            </a:r>
+          </a:p>
+        </p:txBody>
+      </p:sp>
+      <p:sp>
+        <p:nvSpPr>
+          <p:cNvPr id="5" name="Rectangle 4"/>
+          <p:cNvSpPr/>
+          <p:nvPr/>
+        </p:nvSpPr>
+        <p:spPr>
+          <a:xfrm>
+            <a:off x="457200" y="1188720"/>
+            <a:ext cx="1371600" cy="45720"/>
+          </a:xfrm>
+          <a:prstGeom prst="rect">
+            <a:avLst/>
+          </a:prstGeom>
+          <a:solidFill>
+            <a:srgbClr val="E6D0A4"/>
+          </a:solidFill>
+        </p:spPr>
+        <p:style>
+          <a:lnRef idx="1">
+            <a:schemeClr val="accent1"/>
+          </a:lnRef>
+          <a:fillRef idx="3">
+            <a:schemeClr val="accent1"/>
+          </a:fillRef>
+          <a:effectRef idx="2">
+            <a:schemeClr val="accent1"/>
+          </a:effectRef>
+          <a:fontRef idx="minor">
+            <a:schemeClr val="lt1"/>
+          </a:fontRef>
+        </p:style>
+        <p:txBody>
+          <a:bodyPr rtlCol="0" anchor="ctr"/>
+          <a:lstStyle/>
+          <a:p>
+            <a:pPr algn="ctr"/>
+          </a:p>
+        </p:txBody>
+      </p:sp>
+      <p:sp>
+        <p:nvSpPr>
+          <p:cNvPr id="6" name="TextBox 5"/>
+          <p:cNvSpPr txBox="1"/>
+          <p:nvPr/>
+        </p:nvSpPr>
+        <p:spPr>
+          <a:xfrm>
+            <a:off x="731520" y="1645920"/>
+            <a:ext cx="10728655" cy="4572000"/>
+          </a:xfrm>
+          <a:prstGeom prst="rect">
+            <a:avLst/>
+          </a:prstGeom>
+          <a:noFill/>
+        </p:spPr>
+        <p:txBody>
+          <a:bodyPr wrap="square">
+            <a:spAutoFit/>
+          </a:bodyPr>
+          <a:lstStyle/>
+          <a:p/>
+          <a:p>
+            <a:pPr>
+              <a:spcAft>
+                <a:spcPts val="1200"/>
+              </a:spcAft>
+              <a:defRPr sz="2000">
+                <a:solidFill>
+                  <a:srgbClr val="333333"/>
+                </a:solidFill>
+                <a:latin typeface="Hiragino Sans"/>
+              </a:defRPr>
+            </a:pPr>
+            <a:r>
+              <a:t>■ バンキング・アズ・ア・サービス(BaaS)</a:t>
+            </a:r>
+          </a:p>
+          <a:p>
+            <a:pPr lvl="1">
+              <a:spcAft>
+                <a:spcPts val="1200"/>
+              </a:spcAft>
+              <a:defRPr sz="2000">
+                <a:solidFill>
+                  <a:srgbClr val="333333"/>
+                </a:solidFill>
+                <a:latin typeface="Hiragino Sans"/>
+              </a:defRPr>
+            </a:pPr>
+            <a:r>
+              <a:t>・金融機能をパーツとして他業種に提供するプラットフォーム化。</a:t>
+            </a:r>
+          </a:p>
+          <a:p>
+            <a:pPr>
+              <a:spcAft>
+                <a:spcPts val="1200"/>
+              </a:spcAft>
+              <a:defRPr sz="2000">
+                <a:solidFill>
+                  <a:srgbClr val="333333"/>
+                </a:solidFill>
+                <a:latin typeface="Hiragino Sans"/>
+              </a:defRPr>
+            </a:pPr>
+            <a:r>
+              <a:t>■ 融合するテクノロジー：Olive、デジタル通貨</a:t>
+            </a:r>
+          </a:p>
+          <a:p>
+            <a:pPr lvl="1">
+              <a:spcAft>
+                <a:spcPts val="1200"/>
+              </a:spcAft>
+              <a:defRPr sz="2000">
+                <a:solidFill>
+                  <a:srgbClr val="333333"/>
+                </a:solidFill>
+                <a:latin typeface="Hiragino Sans"/>
+              </a:defRPr>
+            </a:pPr>
+            <a:r>
+              <a:t>・銀行口座と決済アプリの完全統合。さらにCBDC（デジタル円）の可能性。</a:t>
+            </a:r>
+          </a:p>
+          <a:p>
+            <a:pPr>
+              <a:spcAft>
+                <a:spcPts val="1200"/>
+              </a:spcAft>
+              <a:defRPr sz="2000">
+                <a:solidFill>
+                  <a:srgbClr val="333333"/>
+                </a:solidFill>
+                <a:latin typeface="Hiragino Sans"/>
+              </a:defRPr>
+            </a:pPr>
+            <a:r>
+              <a:t>■ コンサルタントへの進化</a:t>
+            </a:r>
+          </a:p>
+          <a:p>
+            <a:pPr lvl="1">
+              <a:spcAft>
+                <a:spcPts val="1200"/>
+              </a:spcAft>
+              <a:defRPr sz="2000">
+                <a:solidFill>
+                  <a:srgbClr val="333333"/>
+                </a:solidFill>
+                <a:latin typeface="Hiragino Sans"/>
+              </a:defRPr>
+            </a:pPr>
+            <a:r>
+              <a:t>・「金貸し」から、顧客の経営課題を解決するパートナーへ。</a:t>
+            </a:r>
+          </a:p>
+        </p:txBody>
+      </p:sp>
+    </p:spTree>
+  </p:cSld>
+  <p:clrMapOvr>
+    <a:masterClrMapping/>
+  </p:clrMapOvr>
+</p:sld>
+</file>
+
+<file path=ppt/slides/slide19.xml><?xml version="1.0" encoding="utf-8"?>
+<p:sld xmlns:a="http://schemas.openxmlformats.org/drawingml/2006/main" xmlns:p="http://schemas.openxmlformats.org/presentationml/2006/main" xmlns:r="http://schemas.openxmlformats.org/officeDocument/2006/relationships">
+  <p:cSld>
+    <p:bg>
+      <p:bgPr>
+        <a:solidFill>
+          <a:srgbClr val="FEFEFE"/>
+        </a:solidFill>
+        <a:effectLst/>
+      </p:bgPr>
+    </p:bg>
+    <p:spTree>
+      <p:nvGrpSpPr>
+        <p:cNvPr id="1" name=""/>
+        <p:cNvGrpSpPr/>
+        <p:nvPr/>
+      </p:nvGrpSpPr>
+      <p:grpSpPr/>
+      <p:sp>
+        <p:nvSpPr>
+          <p:cNvPr id="2" name="Rectangle 1"/>
+          <p:cNvSpPr/>
+          <p:nvPr/>
+        </p:nvSpPr>
+        <p:spPr>
+          <a:xfrm>
+            <a:off x="0" y="0"/>
+            <a:ext cx="12191695" cy="45720"/>
+          </a:xfrm>
+          <a:prstGeom prst="rect">
+            <a:avLst/>
+          </a:prstGeom>
+          <a:solidFill>
+            <a:srgbClr val="143D98"/>
+          </a:solidFill>
+        </p:spPr>
+        <p:style>
+          <a:lnRef idx="1">
+            <a:schemeClr val="accent1"/>
+          </a:lnRef>
+          <a:fillRef idx="3">
+            <a:schemeClr val="accent1"/>
+          </a:fillRef>
+          <a:effectRef idx="2">
+            <a:schemeClr val="accent1"/>
+          </a:effectRef>
+          <a:fontRef idx="minor">
+            <a:schemeClr val="lt1"/>
+          </a:fontRef>
+        </p:style>
+        <p:txBody>
+          <a:bodyPr rtlCol="0" anchor="ctr"/>
+          <a:lstStyle/>
+          <a:p>
+            <a:pPr algn="ctr"/>
+          </a:p>
+        </p:txBody>
+      </p:sp>
+      <p:sp>
+        <p:nvSpPr>
+          <p:cNvPr id="3" name="Rectangle 2"/>
+          <p:cNvSpPr/>
+          <p:nvPr/>
+        </p:nvSpPr>
+        <p:spPr>
+          <a:xfrm>
+            <a:off x="457200" y="6492240"/>
+            <a:ext cx="11277295" cy="9144"/>
+          </a:xfrm>
+          <a:prstGeom prst="rect">
+            <a:avLst/>
+          </a:prstGeom>
+          <a:solidFill>
+            <a:srgbClr val="143D98"/>
+          </a:solidFill>
+        </p:spPr>
+        <p:style>
+          <a:lnRef idx="1">
+            <a:schemeClr val="accent1"/>
+          </a:lnRef>
+          <a:fillRef idx="3">
+            <a:schemeClr val="accent1"/>
+          </a:fillRef>
+          <a:effectRef idx="2">
+            <a:schemeClr val="accent1"/>
+          </a:effectRef>
+          <a:fontRef idx="minor">
+            <a:schemeClr val="lt1"/>
+          </a:fontRef>
+        </p:style>
+        <p:txBody>
+          <a:bodyPr rtlCol="0" anchor="ctr"/>
+          <a:lstStyle/>
+          <a:p>
+            <a:pPr algn="ctr"/>
+          </a:p>
+        </p:txBody>
+      </p:sp>
+      <p:sp>
+        <p:nvSpPr>
+          <p:cNvPr id="4" name="TextBox 3"/>
+          <p:cNvSpPr txBox="1"/>
+          <p:nvPr/>
+        </p:nvSpPr>
+        <p:spPr>
+          <a:xfrm>
+            <a:off x="457200" y="365760"/>
+            <a:ext cx="10972800" cy="914400"/>
+          </a:xfrm>
+          <a:prstGeom prst="rect">
+            <a:avLst/>
+          </a:prstGeom>
+          <a:noFill/>
+        </p:spPr>
+        <p:txBody>
+          <a:bodyPr wrap="none">
+            <a:spAutoFit/>
+          </a:bodyPr>
+          <a:lstStyle/>
+          <a:p>
+            <a:pPr algn="l">
+              <a:defRPr sz="3200" b="1">
+                <a:solidFill>
+                  <a:srgbClr val="143D98"/>
+                </a:solidFill>
+                <a:latin typeface="Hiragino Sans"/>
+              </a:defRPr>
+            </a:pPr>
+            <a:r>
               <a:t>まとめ：信頼を基盤に、未来を創る</a:t>
             </a:r>
           </a:p>
@@ -4631,7 +6027,7 @@
               </a:defRPr>
             </a:pPr>
             <a:r>
-              <a:t>1. 銀行の本質的役割と定義</a:t>
+              <a:t>銀行の本質的役割と定義</a:t>
             </a:r>
           </a:p>
           <a:p>
@@ -4647,7 +6043,7 @@
               </a:defRPr>
             </a:pPr>
             <a:r>
-              <a:t>2. 銀行の歴史：中世から現代までの変遷</a:t>
+              <a:t>銀行の歴史：中世から現代までの変遷</a:t>
             </a:r>
           </a:p>
           <a:p>
@@ -4663,7 +6059,7 @@
               </a:defRPr>
             </a:pPr>
             <a:r>
-              <a:t>3. 銀行の種類：役割に応じた多様なプレイヤー</a:t>
+              <a:t>銀行の種類：役割に応じた多様なプレイヤー</a:t>
             </a:r>
           </a:p>
           <a:p>
@@ -4679,7 +6075,7 @@
               </a:defRPr>
             </a:pPr>
             <a:r>
-              <a:t>4. 3大業務と銀行収益の仕組み</a:t>
+              <a:t>3大業務と銀行収益の仕組み</a:t>
             </a:r>
           </a:p>
           <a:p>
@@ -4695,7 +6091,7 @@
               </a:defRPr>
             </a:pPr>
             <a:r>
-              <a:t>5. 業界を取り巻く現状と直面する課題</a:t>
+              <a:t>業界を取り巻く現状と直面する課題</a:t>
             </a:r>
           </a:p>
           <a:p>
@@ -4711,7 +6107,7 @@
               </a:defRPr>
             </a:pPr>
             <a:r>
-              <a:t>6. 未来への展望：DXと新たな金融の形</a:t>
+              <a:t>未来への展望：DXと新たな金融の形</a:t>
             </a:r>
           </a:p>
         </p:txBody>
@@ -4727,14 +6123,6 @@
 <file path=ppt/slides/slide3.xml><?xml version="1.0" encoding="utf-8"?>
 <p:sld xmlns:a="http://schemas.openxmlformats.org/drawingml/2006/main" xmlns:p="http://schemas.openxmlformats.org/presentationml/2006/main" xmlns:r="http://schemas.openxmlformats.org/officeDocument/2006/relationships">
   <p:cSld>
-    <p:bg>
-      <p:bgPr>
-        <a:solidFill>
-          <a:srgbClr val="FEFEFE"/>
-        </a:solidFill>
-        <a:effectLst/>
-      </p:bgPr>
-    </p:bg>
     <p:spTree>
       <p:nvGrpSpPr>
         <p:cNvPr id="1" name=""/>
@@ -4751,7 +6139,7 @@
         <p:spPr>
           <a:xfrm>
             <a:off x="0" y="0"/>
-            <a:ext cx="12191695" cy="45720"/>
+            <a:ext cx="12191695" cy="6858000"/>
           </a:xfrm>
           <a:prstGeom prst="rect">
             <a:avLst/>
@@ -4784,20 +6172,57 @@
       </p:sp>
       <p:sp>
         <p:nvSpPr>
-          <p:cNvPr id="3" name="Rectangle 2"/>
+          <p:cNvPr id="3" name="TextBox 2"/>
+          <p:cNvSpPr txBox="1"/>
+          <p:nvPr/>
+        </p:nvSpPr>
+        <p:spPr>
+          <a:xfrm>
+            <a:off x="0" y="2011680"/>
+            <a:ext cx="12191695" cy="914400"/>
+          </a:xfrm>
+          <a:prstGeom prst="rect">
+            <a:avLst/>
+          </a:prstGeom>
+          <a:noFill/>
+        </p:spPr>
+        <p:txBody>
+          <a:bodyPr wrap="none">
+            <a:spAutoFit/>
+          </a:bodyPr>
+          <a:lstStyle/>
+          <a:p/>
+          <a:p>
+            <a:pPr algn="ctr">
+              <a:defRPr sz="2800">
+                <a:solidFill>
+                  <a:srgbClr val="E6D0A4"/>
+                </a:solidFill>
+                <a:latin typeface="Hiragino Sans"/>
+              </a:defRPr>
+            </a:pPr>
+            <a:r>
+              <a:t>Section 01</a:t>
+            </a:r>
+          </a:p>
+        </p:txBody>
+      </p:sp>
+      <p:sp>
+        <p:nvSpPr>
+          <p:cNvPr id="4" name="Rectangle 3"/>
           <p:cNvSpPr/>
           <p:nvPr/>
         </p:nvSpPr>
         <p:spPr>
           <a:xfrm>
-            <a:off x="457200" y="6492240"/>
-            <a:ext cx="11277295" cy="9144"/>
+            <a:off x="4876678" y="2926080"/>
+            <a:ext cx="2438339" cy="18288"/>
           </a:xfrm>
           <a:prstGeom prst="rect">
             <a:avLst/>
           </a:prstGeom>
           <a:solidFill>
-            <a:srgbClr val="143D98"/>
+            <a:srgbClr val="E6D0A4"/>
           </a:solidFill>
         </p:spPr>
         <p:style>
@@ -4824,14 +6249,14 @@
       </p:sp>
       <p:sp>
         <p:nvSpPr>
-          <p:cNvPr id="4" name="TextBox 3"/>
+          <p:cNvPr id="5" name="TextBox 4"/>
           <p:cNvSpPr txBox="1"/>
           <p:nvPr/>
         </p:nvSpPr>
         <p:spPr>
           <a:xfrm>
-            <a:off x="457200" y="365760"/>
-            <a:ext cx="10972800" cy="914400"/>
+            <a:off x="0" y="3291840"/>
+            <a:ext cx="12191695" cy="1371600"/>
           </a:xfrm>
           <a:prstGeom prst="rect">
             <a:avLst/>
@@ -4843,177 +6268,18 @@
             <a:spAutoFit/>
           </a:bodyPr>
           <a:lstStyle/>
-          <a:p>
-            <a:pPr algn="l">
-              <a:defRPr sz="3200" b="1">
-                <a:solidFill>
-                  <a:srgbClr val="143D98"/>
-                </a:solidFill>
-                <a:latin typeface="Hiragino Sans"/>
-              </a:defRPr>
-            </a:pPr>
-            <a:r>
-              <a:t>1. 銀行の本質的役割と定義</a:t>
-            </a:r>
-          </a:p>
-        </p:txBody>
-      </p:sp>
-      <p:sp>
-        <p:nvSpPr>
-          <p:cNvPr id="5" name="Rectangle 4"/>
-          <p:cNvSpPr/>
-          <p:nvPr/>
-        </p:nvSpPr>
-        <p:spPr>
-          <a:xfrm>
-            <a:off x="457200" y="1188720"/>
-            <a:ext cx="1371600" cy="45720"/>
-          </a:xfrm>
-          <a:prstGeom prst="rect">
-            <a:avLst/>
-          </a:prstGeom>
-          <a:solidFill>
-            <a:srgbClr val="E6D0A4"/>
-          </a:solidFill>
-        </p:spPr>
-        <p:style>
-          <a:lnRef idx="1">
-            <a:schemeClr val="accent1"/>
-          </a:lnRef>
-          <a:fillRef idx="3">
-            <a:schemeClr val="accent1"/>
-          </a:fillRef>
-          <a:effectRef idx="2">
-            <a:schemeClr val="accent1"/>
-          </a:effectRef>
-          <a:fontRef idx="minor">
-            <a:schemeClr val="lt1"/>
-          </a:fontRef>
-        </p:style>
-        <p:txBody>
-          <a:bodyPr rtlCol="0" anchor="ctr"/>
-          <a:lstStyle/>
-          <a:p>
-            <a:pPr algn="ctr"/>
-          </a:p>
-        </p:txBody>
-      </p:sp>
-      <p:sp>
-        <p:nvSpPr>
-          <p:cNvPr id="6" name="TextBox 5"/>
-          <p:cNvSpPr txBox="1"/>
-          <p:nvPr/>
-        </p:nvSpPr>
-        <p:spPr>
-          <a:xfrm>
-            <a:off x="731520" y="1645920"/>
-            <a:ext cx="10728655" cy="4572000"/>
-          </a:xfrm>
-          <a:prstGeom prst="rect">
-            <a:avLst/>
-          </a:prstGeom>
-          <a:noFill/>
-        </p:spPr>
-        <p:txBody>
-          <a:bodyPr wrap="square">
-            <a:spAutoFit/>
-          </a:bodyPr>
-          <a:lstStyle/>
           <a:p/>
           <a:p>
-            <a:pPr>
-              <a:spcAft>
-                <a:spcPts val="1200"/>
-              </a:spcAft>
-              <a:defRPr sz="2000">
-                <a:solidFill>
-                  <a:srgbClr val="333333"/>
-                </a:solidFill>
-                <a:latin typeface="Hiragino Sans"/>
-              </a:defRPr>
-            </a:pPr>
-            <a:r>
-              <a:t>■ 金融（資金の融通）のプロフェッショナル</a:t>
-            </a:r>
-          </a:p>
-          <a:p>
-            <a:pPr lvl="1">
-              <a:spcAft>
-                <a:spcPts val="1200"/>
-              </a:spcAft>
-              <a:defRPr sz="2000">
-                <a:solidFill>
-                  <a:srgbClr val="333333"/>
-                </a:solidFill>
-                <a:latin typeface="Hiragino Sans"/>
-              </a:defRPr>
-            </a:pPr>
-            <a:r>
-              <a:t>・お金が余っている人から、足りない人へ橋渡しを行う。</a:t>
-            </a:r>
-          </a:p>
-          <a:p>
-            <a:pPr>
-              <a:spcAft>
-                <a:spcPts val="1200"/>
-              </a:spcAft>
-              <a:defRPr sz="2000">
-                <a:solidFill>
-                  <a:srgbClr val="333333"/>
-                </a:solidFill>
-                <a:latin typeface="Hiragino Sans"/>
-              </a:defRPr>
-            </a:pPr>
-            <a:r>
-              <a:t>■ 間接金融の中核</a:t>
-            </a:r>
-          </a:p>
-          <a:p>
-            <a:pPr lvl="1">
-              <a:spcAft>
-                <a:spcPts val="1200"/>
-              </a:spcAft>
-              <a:defRPr sz="2000">
-                <a:solidFill>
-                  <a:srgbClr val="333333"/>
-                </a:solidFill>
-                <a:latin typeface="Hiragino Sans"/>
-              </a:defRPr>
-            </a:pPr>
-            <a:r>
-              <a:t>・預金者と借入者の間に銀行が立ち、リスクを負って資金を回す仕組み。</a:t>
-            </a:r>
-          </a:p>
-          <a:p>
-            <a:pPr>
-              <a:spcAft>
-                <a:spcPts val="1200"/>
-              </a:spcAft>
-              <a:defRPr sz="2000">
-                <a:solidFill>
-                  <a:srgbClr val="333333"/>
-                </a:solidFill>
-                <a:latin typeface="Hiragino Sans"/>
-              </a:defRPr>
-            </a:pPr>
-            <a:r>
-              <a:t>■ 「心臓」としての役割</a:t>
-            </a:r>
-          </a:p>
-          <a:p>
-            <a:pPr lvl="1">
-              <a:spcAft>
-                <a:spcPts val="1200"/>
-              </a:spcAft>
-              <a:defRPr sz="2000">
-                <a:solidFill>
-                  <a:srgbClr val="333333"/>
-                </a:solidFill>
-                <a:latin typeface="Hiragino Sans"/>
-              </a:defRPr>
-            </a:pPr>
-            <a:r>
-              <a:t>・お金を血液に見立て、社会の隅々へ送り出すライフライン。</a:t>
+            <a:pPr algn="ctr">
+              <a:defRPr sz="4000" b="1">
+                <a:solidFill>
+                  <a:srgbClr val="FEFEFE"/>
+                </a:solidFill>
+                <a:latin typeface="Hiragino Sans"/>
+              </a:defRPr>
+            </a:pPr>
+            <a:r>
+              <a:t>銀行の本質的役割と定義</a:t>
             </a:r>
           </a:p>
         </p:txBody>
@@ -5155,7 +6421,7 @@
               </a:defRPr>
             </a:pPr>
             <a:r>
-              <a:t>2. 銀行の歴史：中世から現代までの変遷</a:t>
+              <a:t>1. 銀行の本質的役割と定義</a:t>
             </a:r>
           </a:p>
         </p:txBody>
@@ -5235,7 +6501,7 @@
               </a:defRPr>
             </a:pPr>
             <a:r>
-              <a:t>■ ヨーロッパの起源</a:t>
+              <a:t>■ 金融（資金の融通）のプロフェッショナル</a:t>
             </a:r>
           </a:p>
           <a:p>
@@ -5251,7 +6517,23 @@
               </a:defRPr>
             </a:pPr>
             <a:r>
-              <a:t>・中世、金細工師（ゴールドスミス）が金を預かった「預かり証」が紙幣の原型に。</a:t>
+              <a:t>・お金が余っている人から、足りない人へ橋渡しを行う。</a:t>
+            </a:r>
+          </a:p>
+          <a:p>
+            <a:pPr>
+              <a:spcAft>
+                <a:spcPts val="1200"/>
+              </a:spcAft>
+              <a:defRPr sz="2000">
+                <a:solidFill>
+                  <a:srgbClr val="333333"/>
+                </a:solidFill>
+                <a:latin typeface="Hiragino Sans"/>
+              </a:defRPr>
+            </a:pPr>
+            <a:r>
+              <a:t>■ 間接金融の中核</a:t>
             </a:r>
           </a:p>
           <a:p>
@@ -5267,7 +6549,7 @@
               </a:defRPr>
             </a:pPr>
             <a:r>
-              <a:t>・利息を取ることが禁忌とされていた時代、ユダヤ人が金融の先駆者となった。</a:t>
+              <a:t>・預金者と借入者の間に銀行が立ち、リスクを負って資金を回す仕組み。</a:t>
             </a:r>
           </a:p>
           <a:p>
@@ -5283,7 +6565,7 @@
               </a:defRPr>
             </a:pPr>
             <a:r>
-              <a:t>■ 信頼のシステム化</a:t>
+              <a:t>■ 「心臓」としての役割</a:t>
             </a:r>
           </a:p>
           <a:p>
@@ -5299,7 +6581,7 @@
               </a:defRPr>
             </a:pPr>
             <a:r>
-              <a:t>・個人の信用から、組織・制度としての信用への転換。</a:t>
+              <a:t>・お金を血液に見立て、社会の隅々へ送り出すライフライン。</a:t>
             </a:r>
           </a:p>
         </p:txBody>
@@ -5315,14 +6597,6 @@
 <file path=ppt/slides/slide5.xml><?xml version="1.0" encoding="utf-8"?>
 <p:sld xmlns:a="http://schemas.openxmlformats.org/drawingml/2006/main" xmlns:p="http://schemas.openxmlformats.org/presentationml/2006/main" xmlns:r="http://schemas.openxmlformats.org/officeDocument/2006/relationships">
   <p:cSld>
-    <p:bg>
-      <p:bgPr>
-        <a:solidFill>
-          <a:srgbClr val="FEFEFE"/>
-        </a:solidFill>
-        <a:effectLst/>
-      </p:bgPr>
-    </p:bg>
     <p:spTree>
       <p:nvGrpSpPr>
         <p:cNvPr id="1" name=""/>
@@ -5339,7 +6613,7 @@
         <p:spPr>
           <a:xfrm>
             <a:off x="0" y="0"/>
-            <a:ext cx="12191695" cy="45720"/>
+            <a:ext cx="12191695" cy="6858000"/>
           </a:xfrm>
           <a:prstGeom prst="rect">
             <a:avLst/>
@@ -5372,20 +6646,57 @@
       </p:sp>
       <p:sp>
         <p:nvSpPr>
-          <p:cNvPr id="3" name="Rectangle 2"/>
+          <p:cNvPr id="3" name="TextBox 2"/>
+          <p:cNvSpPr txBox="1"/>
+          <p:nvPr/>
+        </p:nvSpPr>
+        <p:spPr>
+          <a:xfrm>
+            <a:off x="0" y="2011680"/>
+            <a:ext cx="12191695" cy="914400"/>
+          </a:xfrm>
+          <a:prstGeom prst="rect">
+            <a:avLst/>
+          </a:prstGeom>
+          <a:noFill/>
+        </p:spPr>
+        <p:txBody>
+          <a:bodyPr wrap="none">
+            <a:spAutoFit/>
+          </a:bodyPr>
+          <a:lstStyle/>
+          <a:p/>
+          <a:p>
+            <a:pPr algn="ctr">
+              <a:defRPr sz="2800">
+                <a:solidFill>
+                  <a:srgbClr val="E6D0A4"/>
+                </a:solidFill>
+                <a:latin typeface="Hiragino Sans"/>
+              </a:defRPr>
+            </a:pPr>
+            <a:r>
+              <a:t>Section 02</a:t>
+            </a:r>
+          </a:p>
+        </p:txBody>
+      </p:sp>
+      <p:sp>
+        <p:nvSpPr>
+          <p:cNvPr id="4" name="Rectangle 3"/>
           <p:cNvSpPr/>
           <p:nvPr/>
         </p:nvSpPr>
         <p:spPr>
           <a:xfrm>
-            <a:off x="457200" y="6492240"/>
-            <a:ext cx="11277295" cy="9144"/>
+            <a:off x="4876678" y="2926080"/>
+            <a:ext cx="2438339" cy="18288"/>
           </a:xfrm>
           <a:prstGeom prst="rect">
             <a:avLst/>
           </a:prstGeom>
           <a:solidFill>
-            <a:srgbClr val="143D98"/>
+            <a:srgbClr val="E6D0A4"/>
           </a:solidFill>
         </p:spPr>
         <p:style>
@@ -5412,14 +6723,14 @@
       </p:sp>
       <p:sp>
         <p:nvSpPr>
-          <p:cNvPr id="4" name="TextBox 3"/>
+          <p:cNvPr id="5" name="TextBox 4"/>
           <p:cNvSpPr txBox="1"/>
           <p:nvPr/>
         </p:nvSpPr>
         <p:spPr>
           <a:xfrm>
-            <a:off x="457200" y="365760"/>
-            <a:ext cx="10972800" cy="914400"/>
+            <a:off x="0" y="3291840"/>
+            <a:ext cx="12191695" cy="1371600"/>
           </a:xfrm>
           <a:prstGeom prst="rect">
             <a:avLst/>
@@ -5431,161 +6742,18 @@
             <a:spAutoFit/>
           </a:bodyPr>
           <a:lstStyle/>
-          <a:p>
-            <a:pPr algn="l">
-              <a:defRPr sz="3200" b="1">
-                <a:solidFill>
-                  <a:srgbClr val="143D98"/>
-                </a:solidFill>
-                <a:latin typeface="Hiragino Sans"/>
-              </a:defRPr>
-            </a:pPr>
-            <a:r>
-              <a:t>2. 銀行の歴史（日本における成立）</a:t>
-            </a:r>
-          </a:p>
-        </p:txBody>
-      </p:sp>
-      <p:sp>
-        <p:nvSpPr>
-          <p:cNvPr id="5" name="Rectangle 4"/>
-          <p:cNvSpPr/>
-          <p:nvPr/>
-        </p:nvSpPr>
-        <p:spPr>
-          <a:xfrm>
-            <a:off x="457200" y="1188720"/>
-            <a:ext cx="1371600" cy="45720"/>
-          </a:xfrm>
-          <a:prstGeom prst="rect">
-            <a:avLst/>
-          </a:prstGeom>
-          <a:solidFill>
-            <a:srgbClr val="E6D0A4"/>
-          </a:solidFill>
-        </p:spPr>
-        <p:style>
-          <a:lnRef idx="1">
-            <a:schemeClr val="accent1"/>
-          </a:lnRef>
-          <a:fillRef idx="3">
-            <a:schemeClr val="accent1"/>
-          </a:fillRef>
-          <a:effectRef idx="2">
-            <a:schemeClr val="accent1"/>
-          </a:effectRef>
-          <a:fontRef idx="minor">
-            <a:schemeClr val="lt1"/>
-          </a:fontRef>
-        </p:style>
-        <p:txBody>
-          <a:bodyPr rtlCol="0" anchor="ctr"/>
-          <a:lstStyle/>
-          <a:p>
-            <a:pPr algn="ctr"/>
-          </a:p>
-        </p:txBody>
-      </p:sp>
-      <p:sp>
-        <p:nvSpPr>
-          <p:cNvPr id="6" name="TextBox 5"/>
-          <p:cNvSpPr txBox="1"/>
-          <p:nvPr/>
-        </p:nvSpPr>
-        <p:spPr>
-          <a:xfrm>
-            <a:off x="731520" y="1645920"/>
-            <a:ext cx="10728655" cy="4572000"/>
-          </a:xfrm>
-          <a:prstGeom prst="rect">
-            <a:avLst/>
-          </a:prstGeom>
-          <a:noFill/>
-        </p:spPr>
-        <p:txBody>
-          <a:bodyPr wrap="square">
-            <a:spAutoFit/>
-          </a:bodyPr>
-          <a:lstStyle/>
           <a:p/>
           <a:p>
-            <a:pPr>
-              <a:spcAft>
-                <a:spcPts val="1200"/>
-              </a:spcAft>
-              <a:defRPr sz="2000">
-                <a:solidFill>
-                  <a:srgbClr val="333333"/>
-                </a:solidFill>
-                <a:latin typeface="Hiragino Sans"/>
-              </a:defRPr>
-            </a:pPr>
-            <a:r>
-              <a:t>■ 日本銀行の設立</a:t>
-            </a:r>
-          </a:p>
-          <a:p>
-            <a:pPr lvl="1">
-              <a:spcAft>
-                <a:spcPts val="1200"/>
-              </a:spcAft>
-              <a:defRPr sz="2000">
-                <a:solidFill>
-                  <a:srgbClr val="333333"/>
-                </a:solidFill>
-                <a:latin typeface="Hiragino Sans"/>
-              </a:defRPr>
-            </a:pPr>
-            <a:r>
-              <a:t>・1882年（明治15年）、中央銀行として日本銀行が誕生。</a:t>
-            </a:r>
-          </a:p>
-          <a:p>
-            <a:pPr lvl="1">
-              <a:spcAft>
-                <a:spcPts val="1200"/>
-              </a:spcAft>
-              <a:defRPr sz="2000">
-                <a:solidFill>
-                  <a:srgbClr val="333333"/>
-                </a:solidFill>
-                <a:latin typeface="Hiragino Sans"/>
-              </a:defRPr>
-            </a:pPr>
-            <a:r>
-              <a:t>・インフレの抑制と通貨価値の安定という重大な使命。</a:t>
-            </a:r>
-          </a:p>
-          <a:p>
-            <a:pPr>
-              <a:spcAft>
-                <a:spcPts val="1200"/>
-              </a:spcAft>
-              <a:defRPr sz="2000">
-                <a:solidFill>
-                  <a:srgbClr val="333333"/>
-                </a:solidFill>
-                <a:latin typeface="Hiragino Sans"/>
-              </a:defRPr>
-            </a:pPr>
-            <a:r>
-              <a:t>■ 殖産興業と金融</a:t>
-            </a:r>
-          </a:p>
-          <a:p>
-            <a:pPr lvl="1">
-              <a:spcAft>
-                <a:spcPts val="1200"/>
-              </a:spcAft>
-              <a:defRPr sz="2000">
-                <a:solidFill>
-                  <a:srgbClr val="333333"/>
-                </a:solidFill>
-                <a:latin typeface="Hiragino Sans"/>
-              </a:defRPr>
-            </a:pPr>
-            <a:r>
-              <a:t>・明治の近代化政策を支えるため、多くの国立銀行（後の民間銀行）も設立された。</a:t>
+            <a:pPr algn="ctr">
+              <a:defRPr sz="4000" b="1">
+                <a:solidFill>
+                  <a:srgbClr val="FEFEFE"/>
+                </a:solidFill>
+                <a:latin typeface="Hiragino Sans"/>
+              </a:defRPr>
+            </a:pPr>
+            <a:r>
+              <a:t>銀行の歴史：中世から現代までの変遷</a:t>
             </a:r>
           </a:p>
         </p:txBody>
@@ -5727,7 +6895,7 @@
               </a:defRPr>
             </a:pPr>
             <a:r>
-              <a:t>2. 銀行の歴史（高度成長〜平成再編）</a:t>
+              <a:t>2. 銀行の歴史：中世から現代までの変遷</a:t>
             </a:r>
           </a:p>
         </p:txBody>
@@ -5807,7 +6975,7 @@
               </a:defRPr>
             </a:pPr>
             <a:r>
-              <a:t>■ 高度経済成長期</a:t>
+              <a:t>■ ヨーロッパの起源</a:t>
             </a:r>
           </a:p>
           <a:p>
@@ -5823,7 +6991,23 @@
               </a:defRPr>
             </a:pPr>
             <a:r>
-              <a:t>・長期信用銀行（長銀）などが設備投資を支え、奇跡の成長を支えた。</a:t>
+              <a:t>・中世、金細工師（ゴールドスミス）が金を預かった「預かり証」が紙幣の原型に。</a:t>
+            </a:r>
+          </a:p>
+          <a:p>
+            <a:pPr lvl="1">
+              <a:spcAft>
+                <a:spcPts val="1200"/>
+              </a:spcAft>
+              <a:defRPr sz="2000">
+                <a:solidFill>
+                  <a:srgbClr val="333333"/>
+                </a:solidFill>
+                <a:latin typeface="Hiragino Sans"/>
+              </a:defRPr>
+            </a:pPr>
+            <a:r>
+              <a:t>・利息を取ることが禁忌とされていた時代、ユダヤ人が金融の先駆者となった。</a:t>
             </a:r>
           </a:p>
           <a:p>
@@ -5839,7 +7023,7 @@
               </a:defRPr>
             </a:pPr>
             <a:r>
-              <a:t>■ バブルの狂奔と崩壊</a:t>
+              <a:t>■ 信頼のシステム化</a:t>
             </a:r>
           </a:p>
           <a:p>
@@ -5855,55 +7039,7 @@
               </a:defRPr>
             </a:pPr>
             <a:r>
-              <a:t>・过剰融資による不良債権問題。長銀や住専の破綻と国有化。</a:t>
-            </a:r>
-          </a:p>
-          <a:p>
-            <a:pPr>
-              <a:spcAft>
-                <a:spcPts val="1200"/>
-              </a:spcAft>
-              <a:defRPr sz="2000">
-                <a:solidFill>
-                  <a:srgbClr val="333333"/>
-                </a:solidFill>
-                <a:latin typeface="Hiragino Sans"/>
-              </a:defRPr>
-            </a:pPr>
-            <a:r>
-              <a:t>■ 平成から令和へ</a:t>
-            </a:r>
-          </a:p>
-          <a:p>
-            <a:pPr lvl="1">
-              <a:spcAft>
-                <a:spcPts val="1200"/>
-              </a:spcAft>
-              <a:defRPr sz="2000">
-                <a:solidFill>
-                  <a:srgbClr val="333333"/>
-                </a:solidFill>
-                <a:latin typeface="Hiragino Sans"/>
-              </a:defRPr>
-            </a:pPr>
-            <a:r>
-              <a:t>・金融ビッグバンを経て、大規模な合併（メガバンク誕生）へ。</a:t>
-            </a:r>
-          </a:p>
-          <a:p>
-            <a:pPr lvl="1">
-              <a:spcAft>
-                <a:spcPts val="1200"/>
-              </a:spcAft>
-              <a:defRPr sz="2000">
-                <a:solidFill>
-                  <a:srgbClr val="333333"/>
-                </a:solidFill>
-                <a:latin typeface="Hiragino Sans"/>
-              </a:defRPr>
-            </a:pPr>
-            <a:r>
-              <a:t>・異業種参入と持ち株会社制の解禁。</a:t>
+              <a:t>・個人の信用から、組織・制度としての信用への転換。</a:t>
             </a:r>
           </a:p>
         </p:txBody>
@@ -6045,7 +7181,7 @@
               </a:defRPr>
             </a:pPr>
             <a:r>
-              <a:t>3. 銀行の種類：役割に応じた多様なプレイヤー</a:t>
+              <a:t>2. 銀行の歴史（日本における成立）</a:t>
             </a:r>
           </a:p>
         </p:txBody>
@@ -6125,7 +7261,7 @@
               </a:defRPr>
             </a:pPr>
             <a:r>
-              <a:t>■ 日本銀行（中央銀行）</a:t>
+              <a:t>■ 日本銀行の設立</a:t>
             </a:r>
           </a:p>
           <a:p>
@@ -6141,7 +7277,23 @@
               </a:defRPr>
             </a:pPr>
             <a:r>
-              <a:t>・「銀行の銀行」「政府の銀行」「発券銀行」。</a:t>
+              <a:t>・1882年（明治15年）、中央銀行として日本銀行が誕生。</a:t>
+            </a:r>
+          </a:p>
+          <a:p>
+            <a:pPr lvl="1">
+              <a:spcAft>
+                <a:spcPts val="1200"/>
+              </a:spcAft>
+              <a:defRPr sz="2000">
+                <a:solidFill>
+                  <a:srgbClr val="333333"/>
+                </a:solidFill>
+                <a:latin typeface="Hiragino Sans"/>
+              </a:defRPr>
+            </a:pPr>
+            <a:r>
+              <a:t>・インフレの抑制と通貨価値の安定という重大な使命。</a:t>
             </a:r>
           </a:p>
           <a:p>
@@ -6157,7 +7309,7 @@
               </a:defRPr>
             </a:pPr>
             <a:r>
-              <a:t>■ 都市銀行（メガバンク）</a:t>
+              <a:t>■ 殖産興業と金融</a:t>
             </a:r>
           </a:p>
           <a:p>
@@ -6173,39 +7325,7 @@
               </a:defRPr>
             </a:pPr>
             <a:r>
-              <a:t>・三菱UFJ、三井住友、みずほ。巨大な資本力で国・世界を支える。</a:t>
-            </a:r>
-          </a:p>
-          <a:p>
-            <a:pPr>
-              <a:spcAft>
-                <a:spcPts val="1200"/>
-              </a:spcAft>
-              <a:defRPr sz="2000">
-                <a:solidFill>
-                  <a:srgbClr val="333333"/>
-                </a:solidFill>
-                <a:latin typeface="Hiragino Sans"/>
-              </a:defRPr>
-            </a:pPr>
-            <a:r>
-              <a:t>■ 地方銀行・第二地銀</a:t>
-            </a:r>
-          </a:p>
-          <a:p>
-            <a:pPr lvl="1">
-              <a:spcAft>
-                <a:spcPts val="1200"/>
-              </a:spcAft>
-              <a:defRPr sz="2000">
-                <a:solidFill>
-                  <a:srgbClr val="333333"/>
-                </a:solidFill>
-                <a:latin typeface="Hiragino Sans"/>
-              </a:defRPr>
-            </a:pPr>
-            <a:r>
-              <a:t>・「地域密着」。地元企業との信頼関係（リレーションシップ）が命。</a:t>
+              <a:t>・明治の近代化政策を支えるため、多くの国立銀行（後の民間銀行）も設立された。</a:t>
             </a:r>
           </a:p>
         </p:txBody>
@@ -6347,7 +7467,7 @@
               </a:defRPr>
             </a:pPr>
             <a:r>
-              <a:t>3. 銀行の種類（デジタル・専門特化）</a:t>
+              <a:t>2. 銀行の歴史（高度成長〜平成再編）</a:t>
             </a:r>
           </a:p>
         </p:txBody>
@@ -6427,7 +7547,7 @@
               </a:defRPr>
             </a:pPr>
             <a:r>
-              <a:t>■ ネット銀行</a:t>
+              <a:t>■ 高度経済成長期</a:t>
             </a:r>
           </a:p>
           <a:p>
@@ -6443,7 +7563,7 @@
               </a:defRPr>
             </a:pPr>
             <a:r>
-              <a:t>・楽天、住信SBIなど。店舗を持たず利便性と低コストを追求。</a:t>
+              <a:t>・長期信用銀行（長銀）などが設備投資を支え、奇跡の成長を支えた。</a:t>
             </a:r>
           </a:p>
           <a:p>
@@ -6459,7 +7579,7 @@
               </a:defRPr>
             </a:pPr>
             <a:r>
-              <a:t>■ 信託銀行</a:t>
+              <a:t>■ バブルの狂奔と崩壊</a:t>
             </a:r>
           </a:p>
           <a:p>
@@ -6475,7 +7595,7 @@
               </a:defRPr>
             </a:pPr>
             <a:r>
-              <a:t>・遺言、不動産、年金など「管理」をコアとする専門性。</a:t>
+              <a:t>・过剰融資による不良債権問題。長銀や住専の破綻と国有化。</a:t>
             </a:r>
           </a:p>
           <a:p>
@@ -6491,7 +7611,7 @@
               </a:defRPr>
             </a:pPr>
             <a:r>
-              <a:t>■ 信用金庫・信用組合</a:t>
+              <a:t>■ 平成から令和へ</a:t>
             </a:r>
           </a:p>
           <a:p>
@@ -6507,7 +7627,23 @@
               </a:defRPr>
             </a:pPr>
             <a:r>
-              <a:t>・地域の相互扶助。利益より地域貢献を優先する非営利組織。</a:t>
+              <a:t>・金融ビッグバンを経て、大規模な合併（メガバンク誕生）へ。</a:t>
+            </a:r>
+          </a:p>
+          <a:p>
+            <a:pPr lvl="1">
+              <a:spcAft>
+                <a:spcPts val="1200"/>
+              </a:spcAft>
+              <a:defRPr sz="2000">
+                <a:solidFill>
+                  <a:srgbClr val="333333"/>
+                </a:solidFill>
+                <a:latin typeface="Hiragino Sans"/>
+              </a:defRPr>
+            </a:pPr>
+            <a:r>
+              <a:t>・異業種参入と持ち株会社制の解禁。</a:t>
             </a:r>
           </a:p>
         </p:txBody>
@@ -6523,14 +7659,6 @@
 <file path=ppt/slides/slide9.xml><?xml version="1.0" encoding="utf-8"?>
 <p:sld xmlns:a="http://schemas.openxmlformats.org/drawingml/2006/main" xmlns:p="http://schemas.openxmlformats.org/presentationml/2006/main" xmlns:r="http://schemas.openxmlformats.org/officeDocument/2006/relationships">
   <p:cSld>
-    <p:bg>
-      <p:bgPr>
-        <a:solidFill>
-          <a:srgbClr val="FEFEFE"/>
-        </a:solidFill>
-        <a:effectLst/>
-      </p:bgPr>
-    </p:bg>
     <p:spTree>
       <p:nvGrpSpPr>
         <p:cNvPr id="1" name=""/>
@@ -6547,7 +7675,7 @@
         <p:spPr>
           <a:xfrm>
             <a:off x="0" y="0"/>
-            <a:ext cx="12191695" cy="45720"/>
+            <a:ext cx="12191695" cy="6858000"/>
           </a:xfrm>
           <a:prstGeom prst="rect">
             <a:avLst/>
@@ -6580,20 +7708,57 @@
       </p:sp>
       <p:sp>
         <p:nvSpPr>
-          <p:cNvPr id="3" name="Rectangle 2"/>
+          <p:cNvPr id="3" name="TextBox 2"/>
+          <p:cNvSpPr txBox="1"/>
+          <p:nvPr/>
+        </p:nvSpPr>
+        <p:spPr>
+          <a:xfrm>
+            <a:off x="0" y="2011680"/>
+            <a:ext cx="12191695" cy="914400"/>
+          </a:xfrm>
+          <a:prstGeom prst="rect">
+            <a:avLst/>
+          </a:prstGeom>
+          <a:noFill/>
+        </p:spPr>
+        <p:txBody>
+          <a:bodyPr wrap="none">
+            <a:spAutoFit/>
+          </a:bodyPr>
+          <a:lstStyle/>
+          <a:p/>
+          <a:p>
+            <a:pPr algn="ctr">
+              <a:defRPr sz="2800">
+                <a:solidFill>
+                  <a:srgbClr val="E6D0A4"/>
+                </a:solidFill>
+                <a:latin typeface="Hiragino Sans"/>
+              </a:defRPr>
+            </a:pPr>
+            <a:r>
+              <a:t>Section 03</a:t>
+            </a:r>
+          </a:p>
+        </p:txBody>
+      </p:sp>
+      <p:sp>
+        <p:nvSpPr>
+          <p:cNvPr id="4" name="Rectangle 3"/>
           <p:cNvSpPr/>
           <p:nvPr/>
         </p:nvSpPr>
         <p:spPr>
           <a:xfrm>
-            <a:off x="457200" y="6492240"/>
-            <a:ext cx="11277295" cy="9144"/>
+            <a:off x="4876678" y="2926080"/>
+            <a:ext cx="2438339" cy="18288"/>
           </a:xfrm>
           <a:prstGeom prst="rect">
             <a:avLst/>
           </a:prstGeom>
           <a:solidFill>
-            <a:srgbClr val="143D98"/>
+            <a:srgbClr val="E6D0A4"/>
           </a:solidFill>
         </p:spPr>
         <p:style>
@@ -6620,14 +7785,14 @@
       </p:sp>
       <p:sp>
         <p:nvSpPr>
-          <p:cNvPr id="4" name="TextBox 3"/>
+          <p:cNvPr id="5" name="TextBox 4"/>
           <p:cNvSpPr txBox="1"/>
           <p:nvPr/>
         </p:nvSpPr>
         <p:spPr>
           <a:xfrm>
-            <a:off x="457200" y="365760"/>
-            <a:ext cx="10972800" cy="914400"/>
+            <a:off x="0" y="3291840"/>
+            <a:ext cx="12191695" cy="1371600"/>
           </a:xfrm>
           <a:prstGeom prst="rect">
             <a:avLst/>
@@ -6639,145 +7804,18 @@
             <a:spAutoFit/>
           </a:bodyPr>
           <a:lstStyle/>
-          <a:p>
-            <a:pPr algn="l">
-              <a:defRPr sz="3200" b="1">
-                <a:solidFill>
-                  <a:srgbClr val="143D98"/>
-                </a:solidFill>
-                <a:latin typeface="Hiragino Sans"/>
-              </a:defRPr>
-            </a:pPr>
-            <a:r>
-              <a:t>4. 3大業務と銀行収益の仕組み</a:t>
-            </a:r>
-          </a:p>
-        </p:txBody>
-      </p:sp>
-      <p:sp>
-        <p:nvSpPr>
-          <p:cNvPr id="5" name="Rectangle 4"/>
-          <p:cNvSpPr/>
-          <p:nvPr/>
-        </p:nvSpPr>
-        <p:spPr>
-          <a:xfrm>
-            <a:off x="457200" y="1188720"/>
-            <a:ext cx="1371600" cy="45720"/>
-          </a:xfrm>
-          <a:prstGeom prst="rect">
-            <a:avLst/>
-          </a:prstGeom>
-          <a:solidFill>
-            <a:srgbClr val="E6D0A4"/>
-          </a:solidFill>
-        </p:spPr>
-        <p:style>
-          <a:lnRef idx="1">
-            <a:schemeClr val="accent1"/>
-          </a:lnRef>
-          <a:fillRef idx="3">
-            <a:schemeClr val="accent1"/>
-          </a:fillRef>
-          <a:effectRef idx="2">
-            <a:schemeClr val="accent1"/>
-          </a:effectRef>
-          <a:fontRef idx="minor">
-            <a:schemeClr val="lt1"/>
-          </a:fontRef>
-        </p:style>
-        <p:txBody>
-          <a:bodyPr rtlCol="0" anchor="ctr"/>
-          <a:lstStyle/>
-          <a:p>
-            <a:pPr algn="ctr"/>
-          </a:p>
-        </p:txBody>
-      </p:sp>
-      <p:sp>
-        <p:nvSpPr>
-          <p:cNvPr id="6" name="TextBox 5"/>
-          <p:cNvSpPr txBox="1"/>
-          <p:nvPr/>
-        </p:nvSpPr>
-        <p:spPr>
-          <a:xfrm>
-            <a:off x="731520" y="1645920"/>
-            <a:ext cx="10728655" cy="4572000"/>
-          </a:xfrm>
-          <a:prstGeom prst="rect">
-            <a:avLst/>
-          </a:prstGeom>
-          <a:noFill/>
-        </p:spPr>
-        <p:txBody>
-          <a:bodyPr wrap="square">
-            <a:spAutoFit/>
-          </a:bodyPr>
-          <a:lstStyle/>
           <a:p/>
           <a:p>
-            <a:pPr>
-              <a:spcAft>
-                <a:spcPts val="1200"/>
-              </a:spcAft>
-              <a:defRPr sz="2000">
-                <a:solidFill>
-                  <a:srgbClr val="333333"/>
-                </a:solidFill>
-                <a:latin typeface="Hiragino Sans"/>
-              </a:defRPr>
-            </a:pPr>
-            <a:r>
-              <a:t>1. 預金業務：大切な資産を安全に預かる。</a:t>
-            </a:r>
-          </a:p>
-          <a:p>
-            <a:pPr>
-              <a:spcAft>
-                <a:spcPts val="1200"/>
-              </a:spcAft>
-              <a:defRPr sz="2000">
-                <a:solidFill>
-                  <a:srgbClr val="333333"/>
-                </a:solidFill>
-                <a:latin typeface="Hiragino Sans"/>
-              </a:defRPr>
-            </a:pPr>
-            <a:r>
-              <a:t>2. 貸出業務：成長を望む企業や個人へ資金を貸し付ける。</a:t>
-            </a:r>
-          </a:p>
-          <a:p>
-            <a:pPr lvl="1">
-              <a:spcAft>
-                <a:spcPts val="1200"/>
-              </a:spcAft>
-              <a:defRPr sz="2000">
-                <a:solidFill>
-                  <a:srgbClr val="333333"/>
-                </a:solidFill>
-                <a:latin typeface="Hiragino Sans"/>
-              </a:defRPr>
-            </a:pPr>
-            <a:r>
-              <a:t>・証書貸付、手形割引など。</a:t>
-            </a:r>
-          </a:p>
-          <a:p>
-            <a:pPr>
-              <a:spcAft>
-                <a:spcPts val="1200"/>
-              </a:spcAft>
-              <a:defRPr sz="2000">
-                <a:solidFill>
-                  <a:srgbClr val="333333"/>
-                </a:solidFill>
-                <a:latin typeface="Hiragino Sans"/>
-              </a:defRPr>
-            </a:pPr>
-            <a:r>
-              <a:t>3. 為替業務：現金を運ばず、安全・迅速に決済を完了させる。</a:t>
+            <a:pPr algn="ctr">
+              <a:defRPr sz="4000" b="1">
+                <a:solidFill>
+                  <a:srgbClr val="FEFEFE"/>
+                </a:solidFill>
+                <a:latin typeface="Hiragino Sans"/>
+              </a:defRPr>
+            </a:pPr>
+            <a:r>
+              <a:t>銀行の種類：役割に応じた多様なプレイヤー</a:t>
             </a:r>
           </a:p>
         </p:txBody>

</xml_diff>

<commit_message>
Fix content slide layout: vertical centering, increased font size and spacing
</commit_message>
<xml_diff>
--- a/bank_industry_presentation.pptx
+++ b/bank_industry_presentation.pptx
@@ -3450,8 +3450,8 @@
         </p:nvSpPr>
         <p:spPr>
           <a:xfrm>
-            <a:off x="731520" y="1645920"/>
-            <a:ext cx="10728655" cy="4572000"/>
+            <a:off x="731520" y="1463040"/>
+            <a:ext cx="10728655" cy="4754880"/>
           </a:xfrm>
           <a:prstGeom prst="rect">
             <a:avLst/>
@@ -3459,7 +3459,7 @@
           <a:noFill/>
         </p:spPr>
         <p:txBody>
-          <a:bodyPr wrap="square">
+          <a:bodyPr wrap="square" anchor="ctr">
             <a:spAutoFit/>
           </a:bodyPr>
           <a:lstStyle/>
@@ -3467,9 +3467,9 @@
           <a:p>
             <a:pPr>
               <a:spcAft>
-                <a:spcPts val="1200"/>
+                <a:spcPts val="2400"/>
               </a:spcAft>
-              <a:defRPr sz="2000">
+              <a:defRPr sz="2200">
                 <a:solidFill>
                   <a:srgbClr val="333333"/>
                 </a:solidFill>
@@ -3483,9 +3483,9 @@
           <a:p>
             <a:pPr lvl="1">
               <a:spcAft>
-                <a:spcPts val="1200"/>
+                <a:spcPts val="2400"/>
               </a:spcAft>
-              <a:defRPr sz="2000">
+              <a:defRPr sz="2200">
                 <a:solidFill>
                   <a:srgbClr val="333333"/>
                 </a:solidFill>
@@ -3499,9 +3499,9 @@
           <a:p>
             <a:pPr>
               <a:spcAft>
-                <a:spcPts val="1200"/>
+                <a:spcPts val="2400"/>
               </a:spcAft>
-              <a:defRPr sz="2000">
+              <a:defRPr sz="2200">
                 <a:solidFill>
                   <a:srgbClr val="333333"/>
                 </a:solidFill>
@@ -3515,9 +3515,9 @@
           <a:p>
             <a:pPr lvl="1">
               <a:spcAft>
-                <a:spcPts val="1200"/>
+                <a:spcPts val="2400"/>
               </a:spcAft>
-              <a:defRPr sz="2000">
+              <a:defRPr sz="2200">
                 <a:solidFill>
                   <a:srgbClr val="333333"/>
                 </a:solidFill>
@@ -3525,15 +3525,15 @@
               </a:defRPr>
             </a:pPr>
             <a:r>
-              <a:t>・三菱UFJ、三井住友、みずほ. 巨大な資本力で国・世界を支える。</a:t>
+              <a:t>・三菱UFJ、三井住友、みずほ。巨大な資本力で国・世界を支える。</a:t>
             </a:r>
           </a:p>
           <a:p>
             <a:pPr>
               <a:spcAft>
-                <a:spcPts val="1200"/>
+                <a:spcPts val="2400"/>
               </a:spcAft>
-              <a:defRPr sz="2000">
+              <a:defRPr sz="2200">
                 <a:solidFill>
                   <a:srgbClr val="333333"/>
                 </a:solidFill>
@@ -3547,9 +3547,9 @@
           <a:p>
             <a:pPr lvl="1">
               <a:spcAft>
-                <a:spcPts val="1200"/>
+                <a:spcPts val="2400"/>
               </a:spcAft>
-              <a:defRPr sz="2000">
+              <a:defRPr sz="2200">
                 <a:solidFill>
                   <a:srgbClr val="333333"/>
                 </a:solidFill>
@@ -3752,8 +3752,8 @@
         </p:nvSpPr>
         <p:spPr>
           <a:xfrm>
-            <a:off x="731520" y="1645920"/>
-            <a:ext cx="10728655" cy="4572000"/>
+            <a:off x="731520" y="1463040"/>
+            <a:ext cx="10728655" cy="4754880"/>
           </a:xfrm>
           <a:prstGeom prst="rect">
             <a:avLst/>
@@ -3761,7 +3761,7 @@
           <a:noFill/>
         </p:spPr>
         <p:txBody>
-          <a:bodyPr wrap="square">
+          <a:bodyPr wrap="square" anchor="ctr">
             <a:spAutoFit/>
           </a:bodyPr>
           <a:lstStyle/>
@@ -3769,9 +3769,9 @@
           <a:p>
             <a:pPr>
               <a:spcAft>
-                <a:spcPts val="1200"/>
+                <a:spcPts val="2400"/>
               </a:spcAft>
-              <a:defRPr sz="2000">
+              <a:defRPr sz="2200">
                 <a:solidFill>
                   <a:srgbClr val="333333"/>
                 </a:solidFill>
@@ -3785,9 +3785,9 @@
           <a:p>
             <a:pPr lvl="1">
               <a:spcAft>
-                <a:spcPts val="1200"/>
+                <a:spcPts val="2400"/>
               </a:spcAft>
-              <a:defRPr sz="2000">
+              <a:defRPr sz="2200">
                 <a:solidFill>
                   <a:srgbClr val="333333"/>
                 </a:solidFill>
@@ -3801,9 +3801,9 @@
           <a:p>
             <a:pPr>
               <a:spcAft>
-                <a:spcPts val="1200"/>
+                <a:spcPts val="2400"/>
               </a:spcAft>
-              <a:defRPr sz="2000">
+              <a:defRPr sz="2200">
                 <a:solidFill>
                   <a:srgbClr val="333333"/>
                 </a:solidFill>
@@ -3817,9 +3817,9 @@
           <a:p>
             <a:pPr lvl="1">
               <a:spcAft>
-                <a:spcPts val="1200"/>
+                <a:spcPts val="2400"/>
               </a:spcAft>
-              <a:defRPr sz="2000">
+              <a:defRPr sz="2200">
                 <a:solidFill>
                   <a:srgbClr val="333333"/>
                 </a:solidFill>
@@ -3833,9 +3833,9 @@
           <a:p>
             <a:pPr>
               <a:spcAft>
-                <a:spcPts val="1200"/>
+                <a:spcPts val="2400"/>
               </a:spcAft>
-              <a:defRPr sz="2000">
+              <a:defRPr sz="2200">
                 <a:solidFill>
                   <a:srgbClr val="333333"/>
                 </a:solidFill>
@@ -3849,9 +3849,9 @@
           <a:p>
             <a:pPr lvl="1">
               <a:spcAft>
-                <a:spcPts val="1200"/>
+                <a:spcPts val="2400"/>
               </a:spcAft>
-              <a:defRPr sz="2000">
+              <a:defRPr sz="2200">
                 <a:solidFill>
                   <a:srgbClr val="333333"/>
                 </a:solidFill>
@@ -4226,8 +4226,8 @@
         </p:nvSpPr>
         <p:spPr>
           <a:xfrm>
-            <a:off x="731520" y="1645920"/>
-            <a:ext cx="10728655" cy="4572000"/>
+            <a:off x="731520" y="1463040"/>
+            <a:ext cx="10728655" cy="4754880"/>
           </a:xfrm>
           <a:prstGeom prst="rect">
             <a:avLst/>
@@ -4235,7 +4235,7 @@
           <a:noFill/>
         </p:spPr>
         <p:txBody>
-          <a:bodyPr wrap="square">
+          <a:bodyPr wrap="square" anchor="ctr">
             <a:spAutoFit/>
           </a:bodyPr>
           <a:lstStyle/>
@@ -4243,9 +4243,9 @@
           <a:p>
             <a:pPr>
               <a:spcAft>
-                <a:spcPts val="1200"/>
+                <a:spcPts val="2400"/>
               </a:spcAft>
-              <a:defRPr sz="2000">
+              <a:defRPr sz="2200">
                 <a:solidFill>
                   <a:srgbClr val="333333"/>
                 </a:solidFill>
@@ -4259,9 +4259,9 @@
           <a:p>
             <a:pPr>
               <a:spcAft>
-                <a:spcPts val="1200"/>
+                <a:spcPts val="2400"/>
               </a:spcAft>
-              <a:defRPr sz="2000">
+              <a:defRPr sz="2200">
                 <a:solidFill>
                   <a:srgbClr val="333333"/>
                 </a:solidFill>
@@ -4275,9 +4275,9 @@
           <a:p>
             <a:pPr lvl="1">
               <a:spcAft>
-                <a:spcPts val="1200"/>
+                <a:spcPts val="2400"/>
               </a:spcAft>
-              <a:defRPr sz="2000">
+              <a:defRPr sz="2200">
                 <a:solidFill>
                   <a:srgbClr val="333333"/>
                 </a:solidFill>
@@ -4291,9 +4291,9 @@
           <a:p>
             <a:pPr>
               <a:spcAft>
-                <a:spcPts val="1200"/>
+                <a:spcPts val="2400"/>
               </a:spcAft>
-              <a:defRPr sz="2000">
+              <a:defRPr sz="2200">
                 <a:solidFill>
                   <a:srgbClr val="333333"/>
                 </a:solidFill>
@@ -4496,8 +4496,8 @@
         </p:nvSpPr>
         <p:spPr>
           <a:xfrm>
-            <a:off x="731520" y="1645920"/>
-            <a:ext cx="10728655" cy="4572000"/>
+            <a:off x="731520" y="1463040"/>
+            <a:ext cx="10728655" cy="4754880"/>
           </a:xfrm>
           <a:prstGeom prst="rect">
             <a:avLst/>
@@ -4505,7 +4505,7 @@
           <a:noFill/>
         </p:spPr>
         <p:txBody>
-          <a:bodyPr wrap="square">
+          <a:bodyPr wrap="square" anchor="ctr">
             <a:spAutoFit/>
           </a:bodyPr>
           <a:lstStyle/>
@@ -4513,9 +4513,9 @@
           <a:p>
             <a:pPr>
               <a:spcAft>
-                <a:spcPts val="1200"/>
+                <a:spcPts val="2400"/>
               </a:spcAft>
-              <a:defRPr sz="2000">
+              <a:defRPr sz="2200">
                 <a:solidFill>
                   <a:srgbClr val="333333"/>
                 </a:solidFill>
@@ -4529,9 +4529,9 @@
           <a:p>
             <a:pPr lvl="1">
               <a:spcAft>
-                <a:spcPts val="1200"/>
+                <a:spcPts val="2400"/>
               </a:spcAft>
-              <a:defRPr sz="2000">
+              <a:defRPr sz="2200">
                 <a:solidFill>
                   <a:srgbClr val="333333"/>
                 </a:solidFill>
@@ -4545,9 +4545,9 @@
           <a:p>
             <a:pPr>
               <a:spcAft>
-                <a:spcPts val="1200"/>
+                <a:spcPts val="2400"/>
               </a:spcAft>
-              <a:defRPr sz="2000">
+              <a:defRPr sz="2200">
                 <a:solidFill>
                   <a:srgbClr val="333333"/>
                 </a:solidFill>
@@ -4561,9 +4561,9 @@
           <a:p>
             <a:pPr lvl="1">
               <a:spcAft>
-                <a:spcPts val="1200"/>
+                <a:spcPts val="2400"/>
               </a:spcAft>
-              <a:defRPr sz="2000">
+              <a:defRPr sz="2200">
                 <a:solidFill>
                   <a:srgbClr val="333333"/>
                 </a:solidFill>
@@ -4577,9 +4577,9 @@
           <a:p>
             <a:pPr lvl="1">
               <a:spcAft>
-                <a:spcPts val="1200"/>
+                <a:spcPts val="2400"/>
               </a:spcAft>
-              <a:defRPr sz="2000">
+              <a:defRPr sz="2200">
                 <a:solidFill>
                   <a:srgbClr val="333333"/>
                 </a:solidFill>
@@ -4954,8 +4954,8 @@
         </p:nvSpPr>
         <p:spPr>
           <a:xfrm>
-            <a:off x="731520" y="1645920"/>
-            <a:ext cx="10728655" cy="4572000"/>
+            <a:off x="731520" y="1463040"/>
+            <a:ext cx="10728655" cy="4754880"/>
           </a:xfrm>
           <a:prstGeom prst="rect">
             <a:avLst/>
@@ -4963,7 +4963,7 @@
           <a:noFill/>
         </p:spPr>
         <p:txBody>
-          <a:bodyPr wrap="square">
+          <a:bodyPr wrap="square" anchor="ctr">
             <a:spAutoFit/>
           </a:bodyPr>
           <a:lstStyle/>
@@ -4971,9 +4971,9 @@
           <a:p>
             <a:pPr>
               <a:spcAft>
-                <a:spcPts val="1200"/>
+                <a:spcPts val="2400"/>
               </a:spcAft>
-              <a:defRPr sz="2000">
+              <a:defRPr sz="2200">
                 <a:solidFill>
                   <a:srgbClr val="333333"/>
                 </a:solidFill>
@@ -4987,9 +4987,9 @@
           <a:p>
             <a:pPr lvl="1">
               <a:spcAft>
-                <a:spcPts val="1200"/>
+                <a:spcPts val="2400"/>
               </a:spcAft>
-              <a:defRPr sz="2000">
+              <a:defRPr sz="2200">
                 <a:solidFill>
                   <a:srgbClr val="333333"/>
                 </a:solidFill>
@@ -5003,9 +5003,9 @@
           <a:p>
             <a:pPr>
               <a:spcAft>
-                <a:spcPts val="1200"/>
+                <a:spcPts val="2400"/>
               </a:spcAft>
-              <a:defRPr sz="2000">
+              <a:defRPr sz="2200">
                 <a:solidFill>
                   <a:srgbClr val="333333"/>
                 </a:solidFill>
@@ -5019,9 +5019,9 @@
           <a:p>
             <a:pPr lvl="1">
               <a:spcAft>
-                <a:spcPts val="1200"/>
+                <a:spcPts val="2400"/>
               </a:spcAft>
-              <a:defRPr sz="2000">
+              <a:defRPr sz="2200">
                 <a:solidFill>
                   <a:srgbClr val="333333"/>
                 </a:solidFill>
@@ -5035,9 +5035,9 @@
           <a:p>
             <a:pPr>
               <a:spcAft>
-                <a:spcPts val="1200"/>
+                <a:spcPts val="2400"/>
               </a:spcAft>
-              <a:defRPr sz="2000">
+              <a:defRPr sz="2200">
                 <a:solidFill>
                   <a:srgbClr val="333333"/>
                 </a:solidFill>
@@ -5051,9 +5051,9 @@
           <a:p>
             <a:pPr lvl="1">
               <a:spcAft>
-                <a:spcPts val="1200"/>
+                <a:spcPts val="2400"/>
               </a:spcAft>
-              <a:defRPr sz="2000">
+              <a:defRPr sz="2200">
                 <a:solidFill>
                   <a:srgbClr val="333333"/>
                 </a:solidFill>
@@ -5428,8 +5428,8 @@
         </p:nvSpPr>
         <p:spPr>
           <a:xfrm>
-            <a:off x="731520" y="1645920"/>
-            <a:ext cx="10728655" cy="4572000"/>
+            <a:off x="731520" y="1463040"/>
+            <a:ext cx="10728655" cy="4754880"/>
           </a:xfrm>
           <a:prstGeom prst="rect">
             <a:avLst/>
@@ -5437,7 +5437,7 @@
           <a:noFill/>
         </p:spPr>
         <p:txBody>
-          <a:bodyPr wrap="square">
+          <a:bodyPr wrap="square" anchor="ctr">
             <a:spAutoFit/>
           </a:bodyPr>
           <a:lstStyle/>
@@ -5445,9 +5445,9 @@
           <a:p>
             <a:pPr>
               <a:spcAft>
-                <a:spcPts val="1200"/>
+                <a:spcPts val="2400"/>
               </a:spcAft>
-              <a:defRPr sz="2000">
+              <a:defRPr sz="2200">
                 <a:solidFill>
                   <a:srgbClr val="333333"/>
                 </a:solidFill>
@@ -5461,9 +5461,9 @@
           <a:p>
             <a:pPr lvl="1">
               <a:spcAft>
-                <a:spcPts val="1200"/>
+                <a:spcPts val="2400"/>
               </a:spcAft>
-              <a:defRPr sz="2000">
+              <a:defRPr sz="2200">
                 <a:solidFill>
                   <a:srgbClr val="333333"/>
                 </a:solidFill>
@@ -5477,9 +5477,9 @@
           <a:p>
             <a:pPr>
               <a:spcAft>
-                <a:spcPts val="1200"/>
+                <a:spcPts val="2400"/>
               </a:spcAft>
-              <a:defRPr sz="2000">
+              <a:defRPr sz="2200">
                 <a:solidFill>
                   <a:srgbClr val="333333"/>
                 </a:solidFill>
@@ -5493,9 +5493,9 @@
           <a:p>
             <a:pPr lvl="1">
               <a:spcAft>
-                <a:spcPts val="1200"/>
+                <a:spcPts val="2400"/>
               </a:spcAft>
-              <a:defRPr sz="2000">
+              <a:defRPr sz="2200">
                 <a:solidFill>
                   <a:srgbClr val="333333"/>
                 </a:solidFill>
@@ -5509,9 +5509,9 @@
           <a:p>
             <a:pPr>
               <a:spcAft>
-                <a:spcPts val="1200"/>
+                <a:spcPts val="2400"/>
               </a:spcAft>
-              <a:defRPr sz="2000">
+              <a:defRPr sz="2200">
                 <a:solidFill>
                   <a:srgbClr val="333333"/>
                 </a:solidFill>
@@ -5525,9 +5525,9 @@
           <a:p>
             <a:pPr lvl="1">
               <a:spcAft>
-                <a:spcPts val="1200"/>
+                <a:spcPts val="2400"/>
               </a:spcAft>
-              <a:defRPr sz="2000">
+              <a:defRPr sz="2200">
                 <a:solidFill>
                   <a:srgbClr val="333333"/>
                 </a:solidFill>
@@ -5730,8 +5730,8 @@
         </p:nvSpPr>
         <p:spPr>
           <a:xfrm>
-            <a:off x="731520" y="1645920"/>
-            <a:ext cx="10728655" cy="4572000"/>
+            <a:off x="731520" y="1463040"/>
+            <a:ext cx="10728655" cy="4754880"/>
           </a:xfrm>
           <a:prstGeom prst="rect">
             <a:avLst/>
@@ -5739,7 +5739,7 @@
           <a:noFill/>
         </p:spPr>
         <p:txBody>
-          <a:bodyPr wrap="square">
+          <a:bodyPr wrap="square" anchor="ctr">
             <a:spAutoFit/>
           </a:bodyPr>
           <a:lstStyle/>
@@ -5747,9 +5747,9 @@
           <a:p>
             <a:pPr>
               <a:spcAft>
-                <a:spcPts val="1200"/>
+                <a:spcPts val="2400"/>
               </a:spcAft>
-              <a:defRPr sz="2000">
+              <a:defRPr sz="2200">
                 <a:solidFill>
                   <a:srgbClr val="333333"/>
                 </a:solidFill>
@@ -5763,9 +5763,9 @@
           <a:p>
             <a:pPr>
               <a:spcAft>
-                <a:spcPts val="1200"/>
+                <a:spcPts val="2400"/>
               </a:spcAft>
-              <a:defRPr sz="2000">
+              <a:defRPr sz="2200">
                 <a:solidFill>
                   <a:srgbClr val="333333"/>
                 </a:solidFill>
@@ -5779,9 +5779,9 @@
           <a:p>
             <a:pPr>
               <a:spcAft>
-                <a:spcPts val="1200"/>
+                <a:spcPts val="2400"/>
               </a:spcAft>
-              <a:defRPr sz="2000">
+              <a:defRPr sz="2200">
                 <a:solidFill>
                   <a:srgbClr val="333333"/>
                 </a:solidFill>
@@ -5795,9 +5795,9 @@
           <a:p>
             <a:pPr>
               <a:spcAft>
-                <a:spcPts val="1200"/>
+                <a:spcPts val="2400"/>
               </a:spcAft>
-              <a:defRPr sz="2000">
+              <a:defRPr sz="2200">
                 <a:solidFill>
                   <a:srgbClr val="333333"/>
                 </a:solidFill>
@@ -6000,8 +6000,8 @@
         </p:nvSpPr>
         <p:spPr>
           <a:xfrm>
-            <a:off x="731520" y="1645920"/>
-            <a:ext cx="10728655" cy="4572000"/>
+            <a:off x="731520" y="1463040"/>
+            <a:ext cx="10728655" cy="4754880"/>
           </a:xfrm>
           <a:prstGeom prst="rect">
             <a:avLst/>
@@ -6009,7 +6009,7 @@
           <a:noFill/>
         </p:spPr>
         <p:txBody>
-          <a:bodyPr wrap="square">
+          <a:bodyPr wrap="square" anchor="ctr">
             <a:spAutoFit/>
           </a:bodyPr>
           <a:lstStyle/>
@@ -6017,9 +6017,9 @@
           <a:p>
             <a:pPr>
               <a:spcAft>
-                <a:spcPts val="1200"/>
+                <a:spcPts val="2400"/>
               </a:spcAft>
-              <a:defRPr sz="2000">
+              <a:defRPr sz="2200">
                 <a:solidFill>
                   <a:srgbClr val="333333"/>
                 </a:solidFill>
@@ -6033,9 +6033,9 @@
           <a:p>
             <a:pPr>
               <a:spcAft>
-                <a:spcPts val="1200"/>
+                <a:spcPts val="2400"/>
               </a:spcAft>
-              <a:defRPr sz="2000">
+              <a:defRPr sz="2200">
                 <a:solidFill>
                   <a:srgbClr val="333333"/>
                 </a:solidFill>
@@ -6049,9 +6049,9 @@
           <a:p>
             <a:pPr>
               <a:spcAft>
-                <a:spcPts val="1200"/>
+                <a:spcPts val="2400"/>
               </a:spcAft>
-              <a:defRPr sz="2000">
+              <a:defRPr sz="2200">
                 <a:solidFill>
                   <a:srgbClr val="333333"/>
                 </a:solidFill>
@@ -6065,9 +6065,9 @@
           <a:p>
             <a:pPr>
               <a:spcAft>
-                <a:spcPts val="1200"/>
+                <a:spcPts val="2400"/>
               </a:spcAft>
-              <a:defRPr sz="2000">
+              <a:defRPr sz="2200">
                 <a:solidFill>
                   <a:srgbClr val="333333"/>
                 </a:solidFill>
@@ -6081,9 +6081,9 @@
           <a:p>
             <a:pPr>
               <a:spcAft>
-                <a:spcPts val="1200"/>
+                <a:spcPts val="2400"/>
               </a:spcAft>
-              <a:defRPr sz="2000">
+              <a:defRPr sz="2200">
                 <a:solidFill>
                   <a:srgbClr val="333333"/>
                 </a:solidFill>
@@ -6097,9 +6097,9 @@
           <a:p>
             <a:pPr>
               <a:spcAft>
-                <a:spcPts val="1200"/>
+                <a:spcPts val="2400"/>
               </a:spcAft>
-              <a:defRPr sz="2000">
+              <a:defRPr sz="2200">
                 <a:solidFill>
                   <a:srgbClr val="333333"/>
                 </a:solidFill>
@@ -6474,8 +6474,8 @@
         </p:nvSpPr>
         <p:spPr>
           <a:xfrm>
-            <a:off x="731520" y="1645920"/>
-            <a:ext cx="10728655" cy="4572000"/>
+            <a:off x="731520" y="1463040"/>
+            <a:ext cx="10728655" cy="4754880"/>
           </a:xfrm>
           <a:prstGeom prst="rect">
             <a:avLst/>
@@ -6483,7 +6483,7 @@
           <a:noFill/>
         </p:spPr>
         <p:txBody>
-          <a:bodyPr wrap="square">
+          <a:bodyPr wrap="square" anchor="ctr">
             <a:spAutoFit/>
           </a:bodyPr>
           <a:lstStyle/>
@@ -6491,9 +6491,9 @@
           <a:p>
             <a:pPr>
               <a:spcAft>
-                <a:spcPts val="1200"/>
+                <a:spcPts val="2400"/>
               </a:spcAft>
-              <a:defRPr sz="2000">
+              <a:defRPr sz="2200">
                 <a:solidFill>
                   <a:srgbClr val="333333"/>
                 </a:solidFill>
@@ -6507,9 +6507,9 @@
           <a:p>
             <a:pPr lvl="1">
               <a:spcAft>
-                <a:spcPts val="1200"/>
+                <a:spcPts val="2400"/>
               </a:spcAft>
-              <a:defRPr sz="2000">
+              <a:defRPr sz="2200">
                 <a:solidFill>
                   <a:srgbClr val="333333"/>
                 </a:solidFill>
@@ -6523,9 +6523,9 @@
           <a:p>
             <a:pPr>
               <a:spcAft>
-                <a:spcPts val="1200"/>
+                <a:spcPts val="2400"/>
               </a:spcAft>
-              <a:defRPr sz="2000">
+              <a:defRPr sz="2200">
                 <a:solidFill>
                   <a:srgbClr val="333333"/>
                 </a:solidFill>
@@ -6539,9 +6539,9 @@
           <a:p>
             <a:pPr lvl="1">
               <a:spcAft>
-                <a:spcPts val="1200"/>
+                <a:spcPts val="2400"/>
               </a:spcAft>
-              <a:defRPr sz="2000">
+              <a:defRPr sz="2200">
                 <a:solidFill>
                   <a:srgbClr val="333333"/>
                 </a:solidFill>
@@ -6555,9 +6555,9 @@
           <a:p>
             <a:pPr>
               <a:spcAft>
-                <a:spcPts val="1200"/>
+                <a:spcPts val="2400"/>
               </a:spcAft>
-              <a:defRPr sz="2000">
+              <a:defRPr sz="2200">
                 <a:solidFill>
                   <a:srgbClr val="333333"/>
                 </a:solidFill>
@@ -6571,9 +6571,9 @@
           <a:p>
             <a:pPr lvl="1">
               <a:spcAft>
-                <a:spcPts val="1200"/>
+                <a:spcPts val="2400"/>
               </a:spcAft>
-              <a:defRPr sz="2000">
+              <a:defRPr sz="2200">
                 <a:solidFill>
                   <a:srgbClr val="333333"/>
                 </a:solidFill>
@@ -6948,8 +6948,8 @@
         </p:nvSpPr>
         <p:spPr>
           <a:xfrm>
-            <a:off x="731520" y="1645920"/>
-            <a:ext cx="10728655" cy="4572000"/>
+            <a:off x="731520" y="1463040"/>
+            <a:ext cx="10728655" cy="4754880"/>
           </a:xfrm>
           <a:prstGeom prst="rect">
             <a:avLst/>
@@ -6957,7 +6957,7 @@
           <a:noFill/>
         </p:spPr>
         <p:txBody>
-          <a:bodyPr wrap="square">
+          <a:bodyPr wrap="square" anchor="ctr">
             <a:spAutoFit/>
           </a:bodyPr>
           <a:lstStyle/>
@@ -6965,9 +6965,9 @@
           <a:p>
             <a:pPr>
               <a:spcAft>
-                <a:spcPts val="1200"/>
+                <a:spcPts val="2400"/>
               </a:spcAft>
-              <a:defRPr sz="2000">
+              <a:defRPr sz="2200">
                 <a:solidFill>
                   <a:srgbClr val="333333"/>
                 </a:solidFill>
@@ -6981,9 +6981,9 @@
           <a:p>
             <a:pPr lvl="1">
               <a:spcAft>
-                <a:spcPts val="1200"/>
+                <a:spcPts val="2400"/>
               </a:spcAft>
-              <a:defRPr sz="2000">
+              <a:defRPr sz="2200">
                 <a:solidFill>
                   <a:srgbClr val="333333"/>
                 </a:solidFill>
@@ -6997,9 +6997,9 @@
           <a:p>
             <a:pPr lvl="1">
               <a:spcAft>
-                <a:spcPts val="1200"/>
+                <a:spcPts val="2400"/>
               </a:spcAft>
-              <a:defRPr sz="2000">
+              <a:defRPr sz="2200">
                 <a:solidFill>
                   <a:srgbClr val="333333"/>
                 </a:solidFill>
@@ -7013,9 +7013,9 @@
           <a:p>
             <a:pPr>
               <a:spcAft>
-                <a:spcPts val="1200"/>
+                <a:spcPts val="2400"/>
               </a:spcAft>
-              <a:defRPr sz="2000">
+              <a:defRPr sz="2200">
                 <a:solidFill>
                   <a:srgbClr val="333333"/>
                 </a:solidFill>
@@ -7029,9 +7029,9 @@
           <a:p>
             <a:pPr lvl="1">
               <a:spcAft>
-                <a:spcPts val="1200"/>
+                <a:spcPts val="2400"/>
               </a:spcAft>
-              <a:defRPr sz="2000">
+              <a:defRPr sz="2200">
                 <a:solidFill>
                   <a:srgbClr val="333333"/>
                 </a:solidFill>
@@ -7234,8 +7234,8 @@
         </p:nvSpPr>
         <p:spPr>
           <a:xfrm>
-            <a:off x="731520" y="1645920"/>
-            <a:ext cx="10728655" cy="4572000"/>
+            <a:off x="731520" y="1463040"/>
+            <a:ext cx="10728655" cy="4754880"/>
           </a:xfrm>
           <a:prstGeom prst="rect">
             <a:avLst/>
@@ -7243,7 +7243,7 @@
           <a:noFill/>
         </p:spPr>
         <p:txBody>
-          <a:bodyPr wrap="square">
+          <a:bodyPr wrap="square" anchor="ctr">
             <a:spAutoFit/>
           </a:bodyPr>
           <a:lstStyle/>
@@ -7251,9 +7251,9 @@
           <a:p>
             <a:pPr>
               <a:spcAft>
-                <a:spcPts val="1200"/>
+                <a:spcPts val="2400"/>
               </a:spcAft>
-              <a:defRPr sz="2000">
+              <a:defRPr sz="2200">
                 <a:solidFill>
                   <a:srgbClr val="333333"/>
                 </a:solidFill>
@@ -7267,9 +7267,9 @@
           <a:p>
             <a:pPr lvl="1">
               <a:spcAft>
-                <a:spcPts val="1200"/>
+                <a:spcPts val="2400"/>
               </a:spcAft>
-              <a:defRPr sz="2000">
+              <a:defRPr sz="2200">
                 <a:solidFill>
                   <a:srgbClr val="333333"/>
                 </a:solidFill>
@@ -7283,9 +7283,9 @@
           <a:p>
             <a:pPr lvl="1">
               <a:spcAft>
-                <a:spcPts val="1200"/>
+                <a:spcPts val="2400"/>
               </a:spcAft>
-              <a:defRPr sz="2000">
+              <a:defRPr sz="2200">
                 <a:solidFill>
                   <a:srgbClr val="333333"/>
                 </a:solidFill>
@@ -7299,9 +7299,9 @@
           <a:p>
             <a:pPr>
               <a:spcAft>
-                <a:spcPts val="1200"/>
+                <a:spcPts val="2400"/>
               </a:spcAft>
-              <a:defRPr sz="2000">
+              <a:defRPr sz="2200">
                 <a:solidFill>
                   <a:srgbClr val="333333"/>
                 </a:solidFill>
@@ -7315,9 +7315,9 @@
           <a:p>
             <a:pPr lvl="1">
               <a:spcAft>
-                <a:spcPts val="1200"/>
+                <a:spcPts val="2400"/>
               </a:spcAft>
-              <a:defRPr sz="2000">
+              <a:defRPr sz="2200">
                 <a:solidFill>
                   <a:srgbClr val="333333"/>
                 </a:solidFill>
@@ -7520,8 +7520,8 @@
         </p:nvSpPr>
         <p:spPr>
           <a:xfrm>
-            <a:off x="731520" y="1645920"/>
-            <a:ext cx="10728655" cy="4572000"/>
+            <a:off x="731520" y="1463040"/>
+            <a:ext cx="10728655" cy="4754880"/>
           </a:xfrm>
           <a:prstGeom prst="rect">
             <a:avLst/>
@@ -7529,7 +7529,7 @@
           <a:noFill/>
         </p:spPr>
         <p:txBody>
-          <a:bodyPr wrap="square">
+          <a:bodyPr wrap="square" anchor="ctr">
             <a:spAutoFit/>
           </a:bodyPr>
           <a:lstStyle/>
@@ -7537,9 +7537,9 @@
           <a:p>
             <a:pPr>
               <a:spcAft>
-                <a:spcPts val="1200"/>
+                <a:spcPts val="2400"/>
               </a:spcAft>
-              <a:defRPr sz="2000">
+              <a:defRPr sz="2200">
                 <a:solidFill>
                   <a:srgbClr val="333333"/>
                 </a:solidFill>
@@ -7553,9 +7553,9 @@
           <a:p>
             <a:pPr lvl="1">
               <a:spcAft>
-                <a:spcPts val="1200"/>
+                <a:spcPts val="2400"/>
               </a:spcAft>
-              <a:defRPr sz="2000">
+              <a:defRPr sz="2200">
                 <a:solidFill>
                   <a:srgbClr val="333333"/>
                 </a:solidFill>
@@ -7569,9 +7569,9 @@
           <a:p>
             <a:pPr>
               <a:spcAft>
-                <a:spcPts val="1200"/>
+                <a:spcPts val="2400"/>
               </a:spcAft>
-              <a:defRPr sz="2000">
+              <a:defRPr sz="2200">
                 <a:solidFill>
                   <a:srgbClr val="333333"/>
                 </a:solidFill>
@@ -7585,9 +7585,9 @@
           <a:p>
             <a:pPr lvl="1">
               <a:spcAft>
-                <a:spcPts val="1200"/>
+                <a:spcPts val="2400"/>
               </a:spcAft>
-              <a:defRPr sz="2000">
+              <a:defRPr sz="2200">
                 <a:solidFill>
                   <a:srgbClr val="333333"/>
                 </a:solidFill>
@@ -7595,15 +7595,15 @@
               </a:defRPr>
             </a:pPr>
             <a:r>
-              <a:t>・过剰融資による不良債権問題。長銀や住専の破綻と国有化。</a:t>
+              <a:t>・過剰融資による不良債権問題。長銀や住専の破綻と国有化。</a:t>
             </a:r>
           </a:p>
           <a:p>
             <a:pPr>
               <a:spcAft>
-                <a:spcPts val="1200"/>
+                <a:spcPts val="2400"/>
               </a:spcAft>
-              <a:defRPr sz="2000">
+              <a:defRPr sz="2200">
                 <a:solidFill>
                   <a:srgbClr val="333333"/>
                 </a:solidFill>
@@ -7617,9 +7617,9 @@
           <a:p>
             <a:pPr lvl="1">
               <a:spcAft>
-                <a:spcPts val="1200"/>
+                <a:spcPts val="2400"/>
               </a:spcAft>
-              <a:defRPr sz="2000">
+              <a:defRPr sz="2200">
                 <a:solidFill>
                   <a:srgbClr val="333333"/>
                 </a:solidFill>
@@ -7633,9 +7633,9 @@
           <a:p>
             <a:pPr lvl="1">
               <a:spcAft>
-                <a:spcPts val="1200"/>
+                <a:spcPts val="2400"/>
               </a:spcAft>
-              <a:defRPr sz="2000">
+              <a:defRPr sz="2200">
                 <a:solidFill>
                   <a:srgbClr val="333333"/>
                 </a:solidFill>

</xml_diff>

<commit_message>
Update Section 5: Replace crisis of customer loss with threat of alternative means
</commit_message>
<xml_diff>
--- a/bank_industry_presentation.pptx
+++ b/bank_industry_presentation.pptx
@@ -5045,7 +5045,7 @@
               </a:defRPr>
             </a:pPr>
             <a:r>
-              <a:t>■ 顧客喪失への危機感</a:t>
+              <a:t>■ 更なる代替手段の脅威</a:t>
             </a:r>
           </a:p>
           <a:p>
@@ -5061,7 +5061,7 @@
               </a:defRPr>
             </a:pPr>
             <a:r>
-              <a:t>・「銀行は必要だが、銀行員はいらなくなる？」という問い。</a:t>
+              <a:t>・ステーブルコインや中央銀行デジタル通貨</a:t>
             </a:r>
           </a:p>
         </p:txBody>

</xml_diff>

<commit_message>
Add numbering to Table of Contents slide
</commit_message>
<xml_diff>
--- a/bank_industry_presentation.pptx
+++ b/bank_industry_presentation.pptx
@@ -4031,7 +4031,7 @@
               </a:defRPr>
             </a:pPr>
             <a:r>
-              <a:t>3大業務と銀行収益の仕組み</a:t>
+              <a:t>4. 3大業務と銀行収益の仕組み</a:t>
             </a:r>
           </a:p>
         </p:txBody>
@@ -4759,7 +4759,7 @@
               </a:defRPr>
             </a:pPr>
             <a:r>
-              <a:t>業界を取り巻く現状と直面する課題</a:t>
+              <a:t>5. 業界を取り巻く現状と直面する課題</a:t>
             </a:r>
           </a:p>
         </p:txBody>
@@ -5233,7 +5233,7 @@
               </a:defRPr>
             </a:pPr>
             <a:r>
-              <a:t>未来への展望：DXと新たな金融の形</a:t>
+              <a:t>6. 未来への展望：DXと新たな金融の形</a:t>
             </a:r>
           </a:p>
         </p:txBody>
@@ -6027,7 +6027,7 @@
               </a:defRPr>
             </a:pPr>
             <a:r>
-              <a:t>銀行の本質的役割と定義</a:t>
+              <a:t>1. 銀行の本質的役割と定義</a:t>
             </a:r>
           </a:p>
           <a:p>
@@ -6043,7 +6043,7 @@
               </a:defRPr>
             </a:pPr>
             <a:r>
-              <a:t>銀行の歴史：中世から現代までの変遷</a:t>
+              <a:t>2. 銀行の歴史：中世から現代までの変遷</a:t>
             </a:r>
           </a:p>
           <a:p>
@@ -6059,7 +6059,7 @@
               </a:defRPr>
             </a:pPr>
             <a:r>
-              <a:t>銀行の種類：役割に応じた多様なプレイヤー</a:t>
+              <a:t>3. 銀行の種類：役割に応じた多様なプレイヤー</a:t>
             </a:r>
           </a:p>
           <a:p>
@@ -6075,7 +6075,7 @@
               </a:defRPr>
             </a:pPr>
             <a:r>
-              <a:t>3大業務と銀行収益の仕組み</a:t>
+              <a:t>4. 3大業務と銀行収益の仕組み</a:t>
             </a:r>
           </a:p>
           <a:p>
@@ -6091,7 +6091,7 @@
               </a:defRPr>
             </a:pPr>
             <a:r>
-              <a:t>業界を取り巻く現状と直面する課題</a:t>
+              <a:t>5. 業界を取り巻く現状と直面する課題</a:t>
             </a:r>
           </a:p>
           <a:p>
@@ -6107,7 +6107,7 @@
               </a:defRPr>
             </a:pPr>
             <a:r>
-              <a:t>未来への展望：DXと新たな金融の形</a:t>
+              <a:t>6. 未来への展望：DXと新たな金融の形</a:t>
             </a:r>
           </a:p>
         </p:txBody>
@@ -6279,7 +6279,7 @@
               </a:defRPr>
             </a:pPr>
             <a:r>
-              <a:t>銀行の本質的役割と定義</a:t>
+              <a:t>1. 銀行の本質的役割と定義</a:t>
             </a:r>
           </a:p>
         </p:txBody>
@@ -6753,7 +6753,7 @@
               </a:defRPr>
             </a:pPr>
             <a:r>
-              <a:t>銀行の歴史：中世から現代までの変遷</a:t>
+              <a:t>2. 銀行の歴史：中世から現代までの変遷</a:t>
             </a:r>
           </a:p>
         </p:txBody>
@@ -7815,7 +7815,7 @@
               </a:defRPr>
             </a:pPr>
             <a:r>
-              <a:t>銀行の種類：役割に応じた多様なプレイヤー</a:t>
+              <a:t>3. 銀行の種類：役割に応じた多様なプレイヤー</a:t>
             </a:r>
           </a:p>
         </p:txBody>

</xml_diff>

<commit_message>
Add a placeholder References slide at the end
</commit_message>
<xml_diff>
--- a/bank_industry_presentation.pptx
+++ b/bank_industry_presentation.pptx
@@ -24,6 +24,7 @@
     <p:sldId id="272" r:id="rId23"/>
     <p:sldId id="273" r:id="rId24"/>
     <p:sldId id="274" r:id="rId25"/>
+    <p:sldId id="275" r:id="rId26"/>
   </p:sldIdLst>
   <p:sldSz cx="12191695" cy="6858000" type="screen4x3"/>
   <p:notesSz cx="6858000" cy="9144000"/>
@@ -6108,6 +6109,228 @@
             </a:pPr>
             <a:r>
               <a:t>6. 未来への展望：DXと新たな金融の形</a:t>
+            </a:r>
+          </a:p>
+        </p:txBody>
+      </p:sp>
+    </p:spTree>
+  </p:cSld>
+  <p:clrMapOvr>
+    <a:masterClrMapping/>
+  </p:clrMapOvr>
+</p:sld>
+</file>
+
+<file path=ppt/slides/slide20.xml><?xml version="1.0" encoding="utf-8"?>
+<p:sld xmlns:a="http://schemas.openxmlformats.org/drawingml/2006/main" xmlns:p="http://schemas.openxmlformats.org/presentationml/2006/main" xmlns:r="http://schemas.openxmlformats.org/officeDocument/2006/relationships">
+  <p:cSld>
+    <p:bg>
+      <p:bgPr>
+        <a:solidFill>
+          <a:srgbClr val="FEFEFE"/>
+        </a:solidFill>
+        <a:effectLst/>
+      </p:bgPr>
+    </p:bg>
+    <p:spTree>
+      <p:nvGrpSpPr>
+        <p:cNvPr id="1" name=""/>
+        <p:cNvGrpSpPr/>
+        <p:nvPr/>
+      </p:nvGrpSpPr>
+      <p:grpSpPr/>
+      <p:sp>
+        <p:nvSpPr>
+          <p:cNvPr id="2" name="Rectangle 1"/>
+          <p:cNvSpPr/>
+          <p:nvPr/>
+        </p:nvSpPr>
+        <p:spPr>
+          <a:xfrm>
+            <a:off x="0" y="0"/>
+            <a:ext cx="12191695" cy="45720"/>
+          </a:xfrm>
+          <a:prstGeom prst="rect">
+            <a:avLst/>
+          </a:prstGeom>
+          <a:solidFill>
+            <a:srgbClr val="143D98"/>
+          </a:solidFill>
+        </p:spPr>
+        <p:style>
+          <a:lnRef idx="1">
+            <a:schemeClr val="accent1"/>
+          </a:lnRef>
+          <a:fillRef idx="3">
+            <a:schemeClr val="accent1"/>
+          </a:fillRef>
+          <a:effectRef idx="2">
+            <a:schemeClr val="accent1"/>
+          </a:effectRef>
+          <a:fontRef idx="minor">
+            <a:schemeClr val="lt1"/>
+          </a:fontRef>
+        </p:style>
+        <p:txBody>
+          <a:bodyPr rtlCol="0" anchor="ctr"/>
+          <a:lstStyle/>
+          <a:p>
+            <a:pPr algn="ctr"/>
+          </a:p>
+        </p:txBody>
+      </p:sp>
+      <p:sp>
+        <p:nvSpPr>
+          <p:cNvPr id="3" name="Rectangle 2"/>
+          <p:cNvSpPr/>
+          <p:nvPr/>
+        </p:nvSpPr>
+        <p:spPr>
+          <a:xfrm>
+            <a:off x="457200" y="6492240"/>
+            <a:ext cx="11277295" cy="9144"/>
+          </a:xfrm>
+          <a:prstGeom prst="rect">
+            <a:avLst/>
+          </a:prstGeom>
+          <a:solidFill>
+            <a:srgbClr val="143D98"/>
+          </a:solidFill>
+        </p:spPr>
+        <p:style>
+          <a:lnRef idx="1">
+            <a:schemeClr val="accent1"/>
+          </a:lnRef>
+          <a:fillRef idx="3">
+            <a:schemeClr val="accent1"/>
+          </a:fillRef>
+          <a:effectRef idx="2">
+            <a:schemeClr val="accent1"/>
+          </a:effectRef>
+          <a:fontRef idx="minor">
+            <a:schemeClr val="lt1"/>
+          </a:fontRef>
+        </p:style>
+        <p:txBody>
+          <a:bodyPr rtlCol="0" anchor="ctr"/>
+          <a:lstStyle/>
+          <a:p>
+            <a:pPr algn="ctr"/>
+          </a:p>
+        </p:txBody>
+      </p:sp>
+      <p:sp>
+        <p:nvSpPr>
+          <p:cNvPr id="4" name="TextBox 3"/>
+          <p:cNvSpPr txBox="1"/>
+          <p:nvPr/>
+        </p:nvSpPr>
+        <p:spPr>
+          <a:xfrm>
+            <a:off x="457200" y="365760"/>
+            <a:ext cx="10972800" cy="914400"/>
+          </a:xfrm>
+          <a:prstGeom prst="rect">
+            <a:avLst/>
+          </a:prstGeom>
+          <a:noFill/>
+        </p:spPr>
+        <p:txBody>
+          <a:bodyPr wrap="none">
+            <a:spAutoFit/>
+          </a:bodyPr>
+          <a:lstStyle/>
+          <a:p>
+            <a:pPr algn="l">
+              <a:defRPr sz="3200" b="1">
+                <a:solidFill>
+                  <a:srgbClr val="143D98"/>
+                </a:solidFill>
+                <a:latin typeface="Hiragino Sans"/>
+              </a:defRPr>
+            </a:pPr>
+            <a:r>
+              <a:t>参考一覧</a:t>
+            </a:r>
+          </a:p>
+        </p:txBody>
+      </p:sp>
+      <p:sp>
+        <p:nvSpPr>
+          <p:cNvPr id="5" name="Rectangle 4"/>
+          <p:cNvSpPr/>
+          <p:nvPr/>
+        </p:nvSpPr>
+        <p:spPr>
+          <a:xfrm>
+            <a:off x="457200" y="1188720"/>
+            <a:ext cx="1371600" cy="45720"/>
+          </a:xfrm>
+          <a:prstGeom prst="rect">
+            <a:avLst/>
+          </a:prstGeom>
+          <a:solidFill>
+            <a:srgbClr val="E6D0A4"/>
+          </a:solidFill>
+        </p:spPr>
+        <p:style>
+          <a:lnRef idx="1">
+            <a:schemeClr val="accent1"/>
+          </a:lnRef>
+          <a:fillRef idx="3">
+            <a:schemeClr val="accent1"/>
+          </a:fillRef>
+          <a:effectRef idx="2">
+            <a:schemeClr val="accent1"/>
+          </a:effectRef>
+          <a:fontRef idx="minor">
+            <a:schemeClr val="lt1"/>
+          </a:fontRef>
+        </p:style>
+        <p:txBody>
+          <a:bodyPr rtlCol="0" anchor="ctr"/>
+          <a:lstStyle/>
+          <a:p>
+            <a:pPr algn="ctr"/>
+          </a:p>
+        </p:txBody>
+      </p:sp>
+      <p:sp>
+        <p:nvSpPr>
+          <p:cNvPr id="6" name="TextBox 5"/>
+          <p:cNvSpPr txBox="1"/>
+          <p:nvPr/>
+        </p:nvSpPr>
+        <p:spPr>
+          <a:xfrm>
+            <a:off x="731520" y="1463040"/>
+            <a:ext cx="10728655" cy="4754880"/>
+          </a:xfrm>
+          <a:prstGeom prst="rect">
+            <a:avLst/>
+          </a:prstGeom>
+          <a:noFill/>
+        </p:spPr>
+        <p:txBody>
+          <a:bodyPr wrap="square" anchor="ctr">
+            <a:spAutoFit/>
+          </a:bodyPr>
+          <a:lstStyle/>
+          <a:p/>
+          <a:p>
+            <a:pPr>
+              <a:spcAft>
+                <a:spcPts val="2400"/>
+              </a:spcAft>
+              <a:defRPr sz="2200">
+                <a:solidFill>
+                  <a:srgbClr val="333333"/>
+                </a:solidFill>
+                <a:latin typeface="Hiragino Sans"/>
+              </a:defRPr>
+            </a:pPr>
+            <a:r>
+              <a:t>（ここに参考資料・Webサイトのリンク等を追記）</a:t>
             </a:r>
           </a:p>
         </p:txBody>

</xml_diff>

<commit_message>
Remove redundant numbering from transition slide titles
</commit_message>
<xml_diff>
--- a/bank_industry_presentation.pptx
+++ b/bank_industry_presentation.pptx
@@ -4032,7 +4032,7 @@
               </a:defRPr>
             </a:pPr>
             <a:r>
-              <a:t>4. 3大業務と銀行収益の仕組み</a:t>
+              <a:t>3大業務と銀行収益の仕組み</a:t>
             </a:r>
           </a:p>
         </p:txBody>
@@ -4760,7 +4760,7 @@
               </a:defRPr>
             </a:pPr>
             <a:r>
-              <a:t>5. 業界を取り巻く現状と直面する課題</a:t>
+              <a:t>業界を取り巻く現状と直面する課題</a:t>
             </a:r>
           </a:p>
         </p:txBody>
@@ -5234,7 +5234,7 @@
               </a:defRPr>
             </a:pPr>
             <a:r>
-              <a:t>6. 未来への展望：DXと新たな金融の形</a:t>
+              <a:t>未来への展望：DXと新たな金融の形</a:t>
             </a:r>
           </a:p>
         </p:txBody>
@@ -6502,7 +6502,7 @@
               </a:defRPr>
             </a:pPr>
             <a:r>
-              <a:t>1. 銀行の本質的役割と定義</a:t>
+              <a:t>銀行の本質的役割と定義</a:t>
             </a:r>
           </a:p>
         </p:txBody>
@@ -6976,7 +6976,7 @@
               </a:defRPr>
             </a:pPr>
             <a:r>
-              <a:t>2. 銀行の歴史：中世から現代までの変遷</a:t>
+              <a:t>銀行の歴史：中世から現代までの変遷</a:t>
             </a:r>
           </a:p>
         </p:txBody>
@@ -8038,7 +8038,7 @@
               </a:defRPr>
             </a:pPr>
             <a:r>
-              <a:t>3. 銀行の種類：役割に応じた多様なプレイヤー</a:t>
+              <a:t>銀行の種類：役割に応じた多様なプレイヤー</a:t>
             </a:r>
           </a:p>
         </p:txBody>

</xml_diff>

<commit_message>
Integrate historical timeline image into Chapter 2
</commit_message>
<xml_diff>
--- a/bank_industry_presentation.pptx
+++ b/bank_industry_presentation.pptx
@@ -4302,7 +4302,7 @@
               </a:defRPr>
             </a:pPr>
             <a:r>
-              <a:t>3. 為替業務：現金を運ばず、安全・迅速に決済を完了させる。</a:t>
+              <a:t>3. 為替業務：現金を運ばず、安全、迅速に決済を完了させる。</a:t>
             </a:r>
           </a:p>
         </p:txBody>
@@ -4588,7 +4588,7 @@
               </a:defRPr>
             </a:pPr>
             <a:r>
-              <a:t>・支払準備制度により安全性を担保しつつ、経済を膨らませる機能。</a:t>
+              <a:t>・経済を膨らませ、社会の成長を加速させる独自の機能。</a:t>
             </a:r>
           </a:p>
         </p:txBody>
@@ -7163,110 +7163,30 @@
           </a:p>
         </p:txBody>
       </p:sp>
-      <p:sp>
-        <p:nvSpPr>
-          <p:cNvPr id="6" name="TextBox 5"/>
-          <p:cNvSpPr txBox="1"/>
-          <p:nvPr/>
-        </p:nvSpPr>
-        <p:spPr>
-          <a:xfrm>
-            <a:off x="731520" y="1463040"/>
-            <a:ext cx="10728655" cy="4754880"/>
-          </a:xfrm>
-          <a:prstGeom prst="rect">
-            <a:avLst/>
-          </a:prstGeom>
-          <a:noFill/>
-        </p:spPr>
-        <p:txBody>
-          <a:bodyPr wrap="square" anchor="ctr">
-            <a:spAutoFit/>
-          </a:bodyPr>
-          <a:lstStyle/>
-          <a:p/>
-          <a:p>
-            <a:pPr>
-              <a:spcAft>
-                <a:spcPts val="2400"/>
-              </a:spcAft>
-              <a:defRPr sz="2200">
-                <a:solidFill>
-                  <a:srgbClr val="333333"/>
-                </a:solidFill>
-                <a:latin typeface="Hiragino Sans"/>
-              </a:defRPr>
-            </a:pPr>
-            <a:r>
-              <a:t>■ ヨーロッパの起源</a:t>
-            </a:r>
-          </a:p>
-          <a:p>
-            <a:pPr lvl="1">
-              <a:spcAft>
-                <a:spcPts val="2400"/>
-              </a:spcAft>
-              <a:defRPr sz="2200">
-                <a:solidFill>
-                  <a:srgbClr val="333333"/>
-                </a:solidFill>
-                <a:latin typeface="Hiragino Sans"/>
-              </a:defRPr>
-            </a:pPr>
-            <a:r>
-              <a:t>・中世、金細工師（ゴールドスミス）が金を預かった「預かり証」が紙幣の原型に。</a:t>
-            </a:r>
-          </a:p>
-          <a:p>
-            <a:pPr lvl="1">
-              <a:spcAft>
-                <a:spcPts val="2400"/>
-              </a:spcAft>
-              <a:defRPr sz="2200">
-                <a:solidFill>
-                  <a:srgbClr val="333333"/>
-                </a:solidFill>
-                <a:latin typeface="Hiragino Sans"/>
-              </a:defRPr>
-            </a:pPr>
-            <a:r>
-              <a:t>・利息を取ることが禁忌とされていた時代、ユダヤ人が金融の先駆者となった。</a:t>
-            </a:r>
-          </a:p>
-          <a:p>
-            <a:pPr>
-              <a:spcAft>
-                <a:spcPts val="2400"/>
-              </a:spcAft>
-              <a:defRPr sz="2200">
-                <a:solidFill>
-                  <a:srgbClr val="333333"/>
-                </a:solidFill>
-                <a:latin typeface="Hiragino Sans"/>
-              </a:defRPr>
-            </a:pPr>
-            <a:r>
-              <a:t>■ 信頼のシステム化</a:t>
-            </a:r>
-          </a:p>
-          <a:p>
-            <a:pPr lvl="1">
-              <a:spcAft>
-                <a:spcPts val="2400"/>
-              </a:spcAft>
-              <a:defRPr sz="2200">
-                <a:solidFill>
-                  <a:srgbClr val="333333"/>
-                </a:solidFill>
-                <a:latin typeface="Hiragino Sans"/>
-              </a:defRPr>
-            </a:pPr>
-            <a:r>
-              <a:t>・個人の信用から、組織・制度としての信用への転換。</a:t>
-            </a:r>
-          </a:p>
-        </p:txBody>
-      </p:sp>
+      <p:pic>
+        <p:nvPicPr>
+          <p:cNvPr id="6" name="Picture 5" descr="history_timeline.png"/>
+          <p:cNvPicPr>
+            <a:picLocks noChangeAspect="1"/>
+          </p:cNvPicPr>
+          <p:nvPr/>
+        </p:nvPicPr>
+        <p:blipFill>
+          <a:blip r:embed="rId2"/>
+          <a:stretch>
+            <a:fillRect/>
+          </a:stretch>
+        </p:blipFill>
+        <p:spPr>
+          <a:xfrm>
+            <a:off x="914400" y="1463040"/>
+            <a:ext cx="10362895" cy="10362895"/>
+          </a:xfrm>
+          <a:prstGeom prst="rect">
+            <a:avLst/>
+          </a:prstGeom>
+        </p:spPr>
+      </p:pic>
     </p:spTree>
   </p:cSld>
   <p:clrMapOvr>
@@ -7404,7 +7324,7 @@
               </a:defRPr>
             </a:pPr>
             <a:r>
-              <a:t>2. 銀行の歴史（日本における成立）</a:t>
+              <a:t>2. 銀行の歴史（欧州の起源と近代日本）</a:t>
             </a:r>
           </a:p>
         </p:txBody>
@@ -7484,7 +7404,7 @@
               </a:defRPr>
             </a:pPr>
             <a:r>
-              <a:t>■ 日本銀行の設立</a:t>
+              <a:t>■ ヨーロッパの起源</a:t>
             </a:r>
           </a:p>
           <a:p>
@@ -7500,7 +7420,23 @@
               </a:defRPr>
             </a:pPr>
             <a:r>
-              <a:t>・1882年（明治15年）、中央銀行として日本銀行が誕生。</a:t>
+              <a:t>・中世、金細工師（ゴールドスミス）が金を預かった「預かり証」が紙幣の原型に。</a:t>
+            </a:r>
+          </a:p>
+          <a:p>
+            <a:pPr>
+              <a:spcAft>
+                <a:spcPts val="2400"/>
+              </a:spcAft>
+              <a:defRPr sz="2200">
+                <a:solidFill>
+                  <a:srgbClr val="333333"/>
+                </a:solidFill>
+                <a:latin typeface="Hiragino Sans"/>
+              </a:defRPr>
+            </a:pPr>
+            <a:r>
+              <a:t>■ 日本銀行の設立（1882年）</a:t>
             </a:r>
           </a:p>
           <a:p>
@@ -7548,7 +7484,7 @@
               </a:defRPr>
             </a:pPr>
             <a:r>
-              <a:t>・明治の近代化政策を支えるため、多くの国立銀行（後の民間銀行）も設立された。</a:t>
+              <a:t>・明治の近代化政策を支えるため、多くの国立銀行が設立された。</a:t>
             </a:r>
           </a:p>
         </p:txBody>
@@ -7802,7 +7738,7 @@
               </a:defRPr>
             </a:pPr>
             <a:r>
-              <a:t>■ バブルの狂奔と崩壊</a:t>
+              <a:t>■ バブルの狂奔と崩壊（1990年前後）</a:t>
             </a:r>
           </a:p>
           <a:p>
@@ -7818,7 +7754,7 @@
               </a:defRPr>
             </a:pPr>
             <a:r>
-              <a:t>・過剰融資による不良債権問題。長銀や住専の破綻と国有化。</a:t>
+              <a:t>・過剰融資による不良債権問題。大規模な合併（メガバンク誕生）へ。</a:t>
             </a:r>
           </a:p>
           <a:p>
@@ -7834,7 +7770,7 @@
               </a:defRPr>
             </a:pPr>
             <a:r>
-              <a:t>■ 平成から令和へ</a:t>
+              <a:t>■ 異業種参入と再編</a:t>
             </a:r>
           </a:p>
           <a:p>
@@ -7850,23 +7786,7 @@
               </a:defRPr>
             </a:pPr>
             <a:r>
-              <a:t>・金融ビッグバンを経て、大規模な合併（メガバンク誕生）へ。</a:t>
-            </a:r>
-          </a:p>
-          <a:p>
-            <a:pPr lvl="1">
-              <a:spcAft>
-                <a:spcPts val="2400"/>
-              </a:spcAft>
-              <a:defRPr sz="2200">
-                <a:solidFill>
-                  <a:srgbClr val="333333"/>
-                </a:solidFill>
-                <a:latin typeface="Hiragino Sans"/>
-              </a:defRPr>
-            </a:pPr>
-            <a:r>
-              <a:t>・異業種参入と持ち株会社制の解禁。</a:t>
+              <a:t>・金融ビッグバンを経て、店舗を持たないネット銀行なども台頭。</a:t>
             </a:r>
           </a:p>
         </p:txBody>

</xml_diff>

<commit_message>
Finalize detailed historical timeline with pure white background and optimized sizing
</commit_message>
<xml_diff>
--- a/bank_industry_presentation.pptx
+++ b/bank_industry_presentation.pptx
@@ -3197,7 +3197,7 @@
             <a:pPr>
               <a:defRPr sz="4400" b="1">
                 <a:solidFill>
-                  <a:srgbClr val="FEFEFE"/>
+                  <a:srgbClr val="FFFFFF"/>
                 </a:solidFill>
                 <a:latin typeface="Hiragino Sans"/>
               </a:defRPr>
@@ -3275,7 +3275,7 @@
     <p:bg>
       <p:bgPr>
         <a:solidFill>
-          <a:srgbClr val="FEFEFE"/>
+          <a:srgbClr val="FFFFFF"/>
         </a:solidFill>
         <a:effectLst/>
       </p:bgPr>
@@ -3577,7 +3577,7 @@
     <p:bg>
       <p:bgPr>
         <a:solidFill>
-          <a:srgbClr val="FEFEFE"/>
+          <a:srgbClr val="FFFFFF"/>
         </a:solidFill>
         <a:effectLst/>
       </p:bgPr>
@@ -4026,7 +4026,7 @@
             <a:pPr algn="ctr">
               <a:defRPr sz="4000" b="1">
                 <a:solidFill>
-                  <a:srgbClr val="FEFEFE"/>
+                  <a:srgbClr val="FFFFFF"/>
                 </a:solidFill>
                 <a:latin typeface="Hiragino Sans"/>
               </a:defRPr>
@@ -4051,7 +4051,7 @@
     <p:bg>
       <p:bgPr>
         <a:solidFill>
-          <a:srgbClr val="FEFEFE"/>
+          <a:srgbClr val="FFFFFF"/>
         </a:solidFill>
         <a:effectLst/>
       </p:bgPr>
@@ -4321,7 +4321,7 @@
     <p:bg>
       <p:bgPr>
         <a:solidFill>
-          <a:srgbClr val="FEFEFE"/>
+          <a:srgbClr val="FFFFFF"/>
         </a:solidFill>
         <a:effectLst/>
       </p:bgPr>
@@ -4754,7 +4754,7 @@
             <a:pPr algn="ctr">
               <a:defRPr sz="4000" b="1">
                 <a:solidFill>
-                  <a:srgbClr val="FEFEFE"/>
+                  <a:srgbClr val="FFFFFF"/>
                 </a:solidFill>
                 <a:latin typeface="Hiragino Sans"/>
               </a:defRPr>
@@ -4779,7 +4779,7 @@
     <p:bg>
       <p:bgPr>
         <a:solidFill>
-          <a:srgbClr val="FEFEFE"/>
+          <a:srgbClr val="FFFFFF"/>
         </a:solidFill>
         <a:effectLst/>
       </p:bgPr>
@@ -5228,7 +5228,7 @@
             <a:pPr algn="ctr">
               <a:defRPr sz="4000" b="1">
                 <a:solidFill>
-                  <a:srgbClr val="FEFEFE"/>
+                  <a:srgbClr val="FFFFFF"/>
                 </a:solidFill>
                 <a:latin typeface="Hiragino Sans"/>
               </a:defRPr>
@@ -5253,7 +5253,7 @@
     <p:bg>
       <p:bgPr>
         <a:solidFill>
-          <a:srgbClr val="FEFEFE"/>
+          <a:srgbClr val="FFFFFF"/>
         </a:solidFill>
         <a:effectLst/>
       </p:bgPr>
@@ -5555,7 +5555,7 @@
     <p:bg>
       <p:bgPr>
         <a:solidFill>
-          <a:srgbClr val="FEFEFE"/>
+          <a:srgbClr val="FFFFFF"/>
         </a:solidFill>
         <a:effectLst/>
       </p:bgPr>
@@ -5825,7 +5825,7 @@
     <p:bg>
       <p:bgPr>
         <a:solidFill>
-          <a:srgbClr val="FEFEFE"/>
+          <a:srgbClr val="FFFFFF"/>
         </a:solidFill>
         <a:effectLst/>
       </p:bgPr>
@@ -6127,7 +6127,7 @@
     <p:bg>
       <p:bgPr>
         <a:solidFill>
-          <a:srgbClr val="FEFEFE"/>
+          <a:srgbClr val="FFFFFF"/>
         </a:solidFill>
         <a:effectLst/>
       </p:bgPr>
@@ -6496,7 +6496,7 @@
             <a:pPr algn="ctr">
               <a:defRPr sz="4000" b="1">
                 <a:solidFill>
-                  <a:srgbClr val="FEFEFE"/>
+                  <a:srgbClr val="FFFFFF"/>
                 </a:solidFill>
                 <a:latin typeface="Hiragino Sans"/>
               </a:defRPr>
@@ -6521,7 +6521,7 @@
     <p:bg>
       <p:bgPr>
         <a:solidFill>
-          <a:srgbClr val="FEFEFE"/>
+          <a:srgbClr val="FFFFFF"/>
         </a:solidFill>
         <a:effectLst/>
       </p:bgPr>
@@ -6970,7 +6970,7 @@
             <a:pPr algn="ctr">
               <a:defRPr sz="4000" b="1">
                 <a:solidFill>
-                  <a:srgbClr val="FEFEFE"/>
+                  <a:srgbClr val="FFFFFF"/>
                 </a:solidFill>
                 <a:latin typeface="Hiragino Sans"/>
               </a:defRPr>
@@ -6995,7 +6995,7 @@
     <p:bg>
       <p:bgPr>
         <a:solidFill>
-          <a:srgbClr val="FEFEFE"/>
+          <a:srgbClr val="FFFFFF"/>
         </a:solidFill>
         <a:effectLst/>
       </p:bgPr>
@@ -7118,7 +7118,7 @@
               </a:defRPr>
             </a:pPr>
             <a:r>
-              <a:t>2. 銀行の歴史：中世から現代までの変遷</a:t>
+              <a:t>2. 銀行の歴史（変遷のタイムライン）</a:t>
             </a:r>
           </a:p>
         </p:txBody>
@@ -7179,8 +7179,8 @@
         </p:blipFill>
         <p:spPr>
           <a:xfrm>
-            <a:off x="914400" y="1463040"/>
-            <a:ext cx="10362895" cy="10362895"/>
+            <a:off x="548640" y="1463040"/>
+            <a:ext cx="11094415" cy="11094415"/>
           </a:xfrm>
           <a:prstGeom prst="rect">
             <a:avLst/>
@@ -7201,7 +7201,7 @@
     <p:bg>
       <p:bgPr>
         <a:solidFill>
-          <a:srgbClr val="FEFEFE"/>
+          <a:srgbClr val="FFFFFF"/>
         </a:solidFill>
         <a:effectLst/>
       </p:bgPr>
@@ -7324,7 +7324,7 @@
               </a:defRPr>
             </a:pPr>
             <a:r>
-              <a:t>2. 銀行の歴史（欧州の起源と近代日本）</a:t>
+              <a:t>2. 銀行の歴史（欧州の起源と近代制度）</a:t>
             </a:r>
           </a:p>
         </p:txBody>
@@ -7420,7 +7420,7 @@
               </a:defRPr>
             </a:pPr>
             <a:r>
-              <a:t>・中世、金細工師（ゴールドスミス）が金を預かった「預かり証」が紙幣の原型に。</a:t>
+              <a:t>・中世の両替商や、1694年のイングランド銀行設立が近代銀行の礎に。</a:t>
             </a:r>
           </a:p>
           <a:p>
@@ -7452,7 +7452,7 @@
               </a:defRPr>
             </a:pPr>
             <a:r>
-              <a:t>・インフレの抑制と通貨価値の安定という重大な使命。</a:t>
+              <a:t>・松方デフレを経て、通貨の番人としての中央銀行が誕生。</a:t>
             </a:r>
           </a:p>
           <a:p>
@@ -7468,7 +7468,7 @@
               </a:defRPr>
             </a:pPr>
             <a:r>
-              <a:t>■ 殖産興業と金融</a:t>
+              <a:t>■ 第一国立銀行（1873年）</a:t>
             </a:r>
           </a:p>
           <a:p>
@@ -7484,7 +7484,7 @@
               </a:defRPr>
             </a:pPr>
             <a:r>
-              <a:t>・明治の近代化政策を支えるため、多くの国立銀行が設立された。</a:t>
+              <a:t>・渋沢栄一により設立された日本初の民間銀行。殖産興業を支えた。</a:t>
             </a:r>
           </a:p>
         </p:txBody>
@@ -7503,7 +7503,7 @@
     <p:bg>
       <p:bgPr>
         <a:solidFill>
-          <a:srgbClr val="FEFEFE"/>
+          <a:srgbClr val="FFFFFF"/>
         </a:solidFill>
         <a:effectLst/>
       </p:bgPr>
@@ -7706,7 +7706,7 @@
               </a:defRPr>
             </a:pPr>
             <a:r>
-              <a:t>■ 高度経済成長期</a:t>
+              <a:t>■ 高度経済成長期（1950s-70s）</a:t>
             </a:r>
           </a:p>
           <a:p>
@@ -7722,7 +7722,7 @@
               </a:defRPr>
             </a:pPr>
             <a:r>
-              <a:t>・長期信用銀行（長銀）などが設備投資を支え、奇跡の成長を支えた。</a:t>
+              <a:t>・旺盛な設備投資を支え、日本を世界第2位の経済大国へ導いた。</a:t>
             </a:r>
           </a:p>
           <a:p>
@@ -7738,7 +7738,7 @@
               </a:defRPr>
             </a:pPr>
             <a:r>
-              <a:t>■ バブルの狂奔と崩壊（1990年前後）</a:t>
+              <a:t>■ バブル崩壊と「失われた30年」</a:t>
             </a:r>
           </a:p>
           <a:p>
@@ -7754,7 +7754,7 @@
               </a:defRPr>
             </a:pPr>
             <a:r>
-              <a:t>・過剰融資による不良債権問題。大規模な合併（メガバンク誕生）へ。</a:t>
+              <a:t>・1990年前後の狂奔と破綻。大規模な金融再編によりメガバンクが誕生。</a:t>
             </a:r>
           </a:p>
           <a:p>
@@ -7770,7 +7770,7 @@
               </a:defRPr>
             </a:pPr>
             <a:r>
-              <a:t>■ 異業種参入と再編</a:t>
+              <a:t>■ デジタル変革（2000s-現代）</a:t>
             </a:r>
           </a:p>
           <a:p>
@@ -7786,7 +7786,7 @@
               </a:defRPr>
             </a:pPr>
             <a:r>
-              <a:t>・金融ビッグバンを経て、店舗を持たないネット銀行なども台頭。</a:t>
+              <a:t>・インターネットバンキングの普及と、決済の脱銀行化が進展。</a:t>
             </a:r>
           </a:p>
         </p:txBody>
@@ -7952,7 +7952,7 @@
             <a:pPr algn="ctr">
               <a:defRPr sz="4000" b="1">
                 <a:solidFill>
-                  <a:srgbClr val="FEFEFE"/>
+                  <a:srgbClr val="FFFFFF"/>
                 </a:solidFill>
                 <a:latin typeface="Hiragino Sans"/>
               </a:defRPr>

</xml_diff>

<commit_message>
Fix image scaling logic to prevent overflow and ensure centering
</commit_message>
<xml_diff>
--- a/bank_industry_presentation.pptx
+++ b/bank_industry_presentation.pptx
@@ -4572,7 +4572,7 @@
               </a:defRPr>
             </a:pPr>
             <a:r>
-              <a:t>・預金と貸出を繰り返すことで、世の中の通貨量を増大させる。</a:t>
+              <a:t>・預金と貸出を繰り返すことで、世の日の中の通貨量を増大させる。</a:t>
             </a:r>
           </a:p>
           <a:p>
@@ -7179,8 +7179,8 @@
         </p:blipFill>
         <p:spPr>
           <a:xfrm>
-            <a:off x="548640" y="1463040"/>
-            <a:ext cx="11094415" cy="11094415"/>
+            <a:off x="3764127" y="1463040"/>
+            <a:ext cx="4663440" cy="4663440"/>
           </a:xfrm>
           <a:prstGeom prst="rect">
             <a:avLst/>

</xml_diff>

<commit_message>
Remove historical timeline visual slide based on user request
</commit_message>
<xml_diff>
--- a/bank_industry_presentation.pptx
+++ b/bank_industry_presentation.pptx
@@ -24,7 +24,6 @@
     <p:sldId id="272" r:id="rId23"/>
     <p:sldId id="273" r:id="rId24"/>
     <p:sldId id="274" r:id="rId25"/>
-    <p:sldId id="275" r:id="rId26"/>
   </p:sldIdLst>
   <p:sldSz cx="12191695" cy="6858000" type="screen4x3"/>
   <p:notesSz cx="6858000" cy="9144000"/>
@@ -3398,7 +3397,7 @@
               </a:defRPr>
             </a:pPr>
             <a:r>
-              <a:t>3. 銀行の種類：役割に応じた多様なプレイヤー</a:t>
+              <a:t>3. 銀行の種類（デジタル・専門特化）</a:t>
             </a:r>
           </a:p>
         </p:txBody>
@@ -3478,7 +3477,7 @@
               </a:defRPr>
             </a:pPr>
             <a:r>
-              <a:t>■ 日本銀行（中央銀行）</a:t>
+              <a:t>■ ネット銀行</a:t>
             </a:r>
           </a:p>
           <a:p>
@@ -3494,7 +3493,7 @@
               </a:defRPr>
             </a:pPr>
             <a:r>
-              <a:t>・「銀行の銀行」「政府の銀行」「発券銀行」。</a:t>
+              <a:t>・楽天、住信SBIなど。店舗を持たず利便性と低コストを追求。</a:t>
             </a:r>
           </a:p>
           <a:p>
@@ -3510,7 +3509,7 @@
               </a:defRPr>
             </a:pPr>
             <a:r>
-              <a:t>■ 都市銀行（メガバンク）</a:t>
+              <a:t>■ 信託銀行</a:t>
             </a:r>
           </a:p>
           <a:p>
@@ -3526,7 +3525,7 @@
               </a:defRPr>
             </a:pPr>
             <a:r>
-              <a:t>・三菱UFJ、三井住友、みずほ。巨大な資本力で国・世界を支える。</a:t>
+              <a:t>・遺言、不動産、年金など「管理」をコアとする専門性。</a:t>
             </a:r>
           </a:p>
           <a:p>
@@ -3542,7 +3541,7 @@
               </a:defRPr>
             </a:pPr>
             <a:r>
-              <a:t>■ 地方銀行・第二地銀</a:t>
+              <a:t>■ 信用金庫・信用組合</a:t>
             </a:r>
           </a:p>
           <a:p>
@@ -3558,7 +3557,7 @@
               </a:defRPr>
             </a:pPr>
             <a:r>
-              <a:t>・「地域密着」。地元企業との信頼関係（リレーションシップ）が命。</a:t>
+              <a:t>・地域の相互扶助。利益より地域貢献を優先する非営利組織。</a:t>
             </a:r>
           </a:p>
         </p:txBody>
@@ -3572,6 +3571,178 @@
 </file>
 
 <file path=ppt/slides/slide11.xml><?xml version="1.0" encoding="utf-8"?>
+<p:sld xmlns:a="http://schemas.openxmlformats.org/drawingml/2006/main" xmlns:p="http://schemas.openxmlformats.org/presentationml/2006/main" xmlns:r="http://schemas.openxmlformats.org/officeDocument/2006/relationships">
+  <p:cSld>
+    <p:spTree>
+      <p:nvGrpSpPr>
+        <p:cNvPr id="1" name=""/>
+        <p:cNvGrpSpPr/>
+        <p:nvPr/>
+      </p:nvGrpSpPr>
+      <p:grpSpPr/>
+      <p:sp>
+        <p:nvSpPr>
+          <p:cNvPr id="2" name="Rectangle 1"/>
+          <p:cNvSpPr/>
+          <p:nvPr/>
+        </p:nvSpPr>
+        <p:spPr>
+          <a:xfrm>
+            <a:off x="0" y="0"/>
+            <a:ext cx="12191695" cy="6858000"/>
+          </a:xfrm>
+          <a:prstGeom prst="rect">
+            <a:avLst/>
+          </a:prstGeom>
+          <a:solidFill>
+            <a:srgbClr val="143D98"/>
+          </a:solidFill>
+        </p:spPr>
+        <p:style>
+          <a:lnRef idx="1">
+            <a:schemeClr val="accent1"/>
+          </a:lnRef>
+          <a:fillRef idx="3">
+            <a:schemeClr val="accent1"/>
+          </a:fillRef>
+          <a:effectRef idx="2">
+            <a:schemeClr val="accent1"/>
+          </a:effectRef>
+          <a:fontRef idx="minor">
+            <a:schemeClr val="lt1"/>
+          </a:fontRef>
+        </p:style>
+        <p:txBody>
+          <a:bodyPr rtlCol="0" anchor="ctr"/>
+          <a:lstStyle/>
+          <a:p>
+            <a:pPr algn="ctr"/>
+          </a:p>
+        </p:txBody>
+      </p:sp>
+      <p:sp>
+        <p:nvSpPr>
+          <p:cNvPr id="3" name="TextBox 2"/>
+          <p:cNvSpPr txBox="1"/>
+          <p:nvPr/>
+        </p:nvSpPr>
+        <p:spPr>
+          <a:xfrm>
+            <a:off x="0" y="2011680"/>
+            <a:ext cx="12191695" cy="914400"/>
+          </a:xfrm>
+          <a:prstGeom prst="rect">
+            <a:avLst/>
+          </a:prstGeom>
+          <a:noFill/>
+        </p:spPr>
+        <p:txBody>
+          <a:bodyPr wrap="none">
+            <a:spAutoFit/>
+          </a:bodyPr>
+          <a:lstStyle/>
+          <a:p/>
+          <a:p>
+            <a:pPr algn="ctr">
+              <a:defRPr sz="2800">
+                <a:solidFill>
+                  <a:srgbClr val="E6D0A4"/>
+                </a:solidFill>
+                <a:latin typeface="Hiragino Sans"/>
+              </a:defRPr>
+            </a:pPr>
+            <a:r>
+              <a:t>Section 04</a:t>
+            </a:r>
+          </a:p>
+        </p:txBody>
+      </p:sp>
+      <p:sp>
+        <p:nvSpPr>
+          <p:cNvPr id="4" name="Rectangle 3"/>
+          <p:cNvSpPr/>
+          <p:nvPr/>
+        </p:nvSpPr>
+        <p:spPr>
+          <a:xfrm>
+            <a:off x="4876678" y="2926080"/>
+            <a:ext cx="2438339" cy="18288"/>
+          </a:xfrm>
+          <a:prstGeom prst="rect">
+            <a:avLst/>
+          </a:prstGeom>
+          <a:solidFill>
+            <a:srgbClr val="E6D0A4"/>
+          </a:solidFill>
+        </p:spPr>
+        <p:style>
+          <a:lnRef idx="1">
+            <a:schemeClr val="accent1"/>
+          </a:lnRef>
+          <a:fillRef idx="3">
+            <a:schemeClr val="accent1"/>
+          </a:fillRef>
+          <a:effectRef idx="2">
+            <a:schemeClr val="accent1"/>
+          </a:effectRef>
+          <a:fontRef idx="minor">
+            <a:schemeClr val="lt1"/>
+          </a:fontRef>
+        </p:style>
+        <p:txBody>
+          <a:bodyPr rtlCol="0" anchor="ctr"/>
+          <a:lstStyle/>
+          <a:p>
+            <a:pPr algn="ctr"/>
+          </a:p>
+        </p:txBody>
+      </p:sp>
+      <p:sp>
+        <p:nvSpPr>
+          <p:cNvPr id="5" name="TextBox 4"/>
+          <p:cNvSpPr txBox="1"/>
+          <p:nvPr/>
+        </p:nvSpPr>
+        <p:spPr>
+          <a:xfrm>
+            <a:off x="0" y="3291840"/>
+            <a:ext cx="12191695" cy="1371600"/>
+          </a:xfrm>
+          <a:prstGeom prst="rect">
+            <a:avLst/>
+          </a:prstGeom>
+          <a:noFill/>
+        </p:spPr>
+        <p:txBody>
+          <a:bodyPr wrap="none">
+            <a:spAutoFit/>
+          </a:bodyPr>
+          <a:lstStyle/>
+          <a:p/>
+          <a:p>
+            <a:pPr algn="ctr">
+              <a:defRPr sz="4000" b="1">
+                <a:solidFill>
+                  <a:srgbClr val="FFFFFF"/>
+                </a:solidFill>
+                <a:latin typeface="Hiragino Sans"/>
+              </a:defRPr>
+            </a:pPr>
+            <a:r>
+              <a:t>3大業務と銀行収益の仕組み</a:t>
+            </a:r>
+          </a:p>
+        </p:txBody>
+      </p:sp>
+    </p:spTree>
+  </p:cSld>
+  <p:clrMapOvr>
+    <a:masterClrMapping/>
+  </p:clrMapOvr>
+</p:sld>
+</file>
+
+<file path=ppt/slides/slide12.xml><?xml version="1.0" encoding="utf-8"?>
 <p:sld xmlns:a="http://schemas.openxmlformats.org/drawingml/2006/main" xmlns:p="http://schemas.openxmlformats.org/presentationml/2006/main" xmlns:r="http://schemas.openxmlformats.org/officeDocument/2006/relationships">
   <p:cSld>
     <p:bg>
@@ -3700,7 +3871,7 @@
               </a:defRPr>
             </a:pPr>
             <a:r>
-              <a:t>3. 銀行の種類（デジタル・専門特化）</a:t>
+              <a:t>4. 3大業務と銀行収益の仕組み</a:t>
             </a:r>
           </a:p>
         </p:txBody>
@@ -3780,7 +3951,23 @@
               </a:defRPr>
             </a:pPr>
             <a:r>
-              <a:t>■ ネット銀行</a:t>
+              <a:t>1. 預金業務：大切な資産を安全に預かる。</a:t>
+            </a:r>
+          </a:p>
+          <a:p>
+            <a:pPr>
+              <a:spcAft>
+                <a:spcPts val="2400"/>
+              </a:spcAft>
+              <a:defRPr sz="2200">
+                <a:solidFill>
+                  <a:srgbClr val="333333"/>
+                </a:solidFill>
+                <a:latin typeface="Hiragino Sans"/>
+              </a:defRPr>
+            </a:pPr>
+            <a:r>
+              <a:t>2. 貸出業務：成長を望む企業や個人へ資金を貸し付ける。</a:t>
             </a:r>
           </a:p>
           <a:p>
@@ -3796,7 +3983,7 @@
               </a:defRPr>
             </a:pPr>
             <a:r>
-              <a:t>・楽天、住信SBIなど。店舗を持たず利便性と低コストを追求。</a:t>
+              <a:t>・証書貸付、手形割引など。</a:t>
             </a:r>
           </a:p>
           <a:p>
@@ -3812,227 +3999,7 @@
               </a:defRPr>
             </a:pPr>
             <a:r>
-              <a:t>■ 信託銀行</a:t>
-            </a:r>
-          </a:p>
-          <a:p>
-            <a:pPr lvl="1">
-              <a:spcAft>
-                <a:spcPts val="2400"/>
-              </a:spcAft>
-              <a:defRPr sz="2200">
-                <a:solidFill>
-                  <a:srgbClr val="333333"/>
-                </a:solidFill>
-                <a:latin typeface="Hiragino Sans"/>
-              </a:defRPr>
-            </a:pPr>
-            <a:r>
-              <a:t>・遺言、不動産、年金など「管理」をコアとする専門性。</a:t>
-            </a:r>
-          </a:p>
-          <a:p>
-            <a:pPr>
-              <a:spcAft>
-                <a:spcPts val="2400"/>
-              </a:spcAft>
-              <a:defRPr sz="2200">
-                <a:solidFill>
-                  <a:srgbClr val="333333"/>
-                </a:solidFill>
-                <a:latin typeface="Hiragino Sans"/>
-              </a:defRPr>
-            </a:pPr>
-            <a:r>
-              <a:t>■ 信用金庫・信用組合</a:t>
-            </a:r>
-          </a:p>
-          <a:p>
-            <a:pPr lvl="1">
-              <a:spcAft>
-                <a:spcPts val="2400"/>
-              </a:spcAft>
-              <a:defRPr sz="2200">
-                <a:solidFill>
-                  <a:srgbClr val="333333"/>
-                </a:solidFill>
-                <a:latin typeface="Hiragino Sans"/>
-              </a:defRPr>
-            </a:pPr>
-            <a:r>
-              <a:t>・地域の相互扶助。利益より地域貢献を優先する非営利組織。</a:t>
-            </a:r>
-          </a:p>
-        </p:txBody>
-      </p:sp>
-    </p:spTree>
-  </p:cSld>
-  <p:clrMapOvr>
-    <a:masterClrMapping/>
-  </p:clrMapOvr>
-</p:sld>
-</file>
-
-<file path=ppt/slides/slide12.xml><?xml version="1.0" encoding="utf-8"?>
-<p:sld xmlns:a="http://schemas.openxmlformats.org/drawingml/2006/main" xmlns:p="http://schemas.openxmlformats.org/presentationml/2006/main" xmlns:r="http://schemas.openxmlformats.org/officeDocument/2006/relationships">
-  <p:cSld>
-    <p:spTree>
-      <p:nvGrpSpPr>
-        <p:cNvPr id="1" name=""/>
-        <p:cNvGrpSpPr/>
-        <p:nvPr/>
-      </p:nvGrpSpPr>
-      <p:grpSpPr/>
-      <p:sp>
-        <p:nvSpPr>
-          <p:cNvPr id="2" name="Rectangle 1"/>
-          <p:cNvSpPr/>
-          <p:nvPr/>
-        </p:nvSpPr>
-        <p:spPr>
-          <a:xfrm>
-            <a:off x="0" y="0"/>
-            <a:ext cx="12191695" cy="6858000"/>
-          </a:xfrm>
-          <a:prstGeom prst="rect">
-            <a:avLst/>
-          </a:prstGeom>
-          <a:solidFill>
-            <a:srgbClr val="143D98"/>
-          </a:solidFill>
-        </p:spPr>
-        <p:style>
-          <a:lnRef idx="1">
-            <a:schemeClr val="accent1"/>
-          </a:lnRef>
-          <a:fillRef idx="3">
-            <a:schemeClr val="accent1"/>
-          </a:fillRef>
-          <a:effectRef idx="2">
-            <a:schemeClr val="accent1"/>
-          </a:effectRef>
-          <a:fontRef idx="minor">
-            <a:schemeClr val="lt1"/>
-          </a:fontRef>
-        </p:style>
-        <p:txBody>
-          <a:bodyPr rtlCol="0" anchor="ctr"/>
-          <a:lstStyle/>
-          <a:p>
-            <a:pPr algn="ctr"/>
-          </a:p>
-        </p:txBody>
-      </p:sp>
-      <p:sp>
-        <p:nvSpPr>
-          <p:cNvPr id="3" name="TextBox 2"/>
-          <p:cNvSpPr txBox="1"/>
-          <p:nvPr/>
-        </p:nvSpPr>
-        <p:spPr>
-          <a:xfrm>
-            <a:off x="0" y="2011680"/>
-            <a:ext cx="12191695" cy="914400"/>
-          </a:xfrm>
-          <a:prstGeom prst="rect">
-            <a:avLst/>
-          </a:prstGeom>
-          <a:noFill/>
-        </p:spPr>
-        <p:txBody>
-          <a:bodyPr wrap="none">
-            <a:spAutoFit/>
-          </a:bodyPr>
-          <a:lstStyle/>
-          <a:p/>
-          <a:p>
-            <a:pPr algn="ctr">
-              <a:defRPr sz="2800">
-                <a:solidFill>
-                  <a:srgbClr val="E6D0A4"/>
-                </a:solidFill>
-                <a:latin typeface="Hiragino Sans"/>
-              </a:defRPr>
-            </a:pPr>
-            <a:r>
-              <a:t>Section 04</a:t>
-            </a:r>
-          </a:p>
-        </p:txBody>
-      </p:sp>
-      <p:sp>
-        <p:nvSpPr>
-          <p:cNvPr id="4" name="Rectangle 3"/>
-          <p:cNvSpPr/>
-          <p:nvPr/>
-        </p:nvSpPr>
-        <p:spPr>
-          <a:xfrm>
-            <a:off x="4876678" y="2926080"/>
-            <a:ext cx="2438339" cy="18288"/>
-          </a:xfrm>
-          <a:prstGeom prst="rect">
-            <a:avLst/>
-          </a:prstGeom>
-          <a:solidFill>
-            <a:srgbClr val="E6D0A4"/>
-          </a:solidFill>
-        </p:spPr>
-        <p:style>
-          <a:lnRef idx="1">
-            <a:schemeClr val="accent1"/>
-          </a:lnRef>
-          <a:fillRef idx="3">
-            <a:schemeClr val="accent1"/>
-          </a:fillRef>
-          <a:effectRef idx="2">
-            <a:schemeClr val="accent1"/>
-          </a:effectRef>
-          <a:fontRef idx="minor">
-            <a:schemeClr val="lt1"/>
-          </a:fontRef>
-        </p:style>
-        <p:txBody>
-          <a:bodyPr rtlCol="0" anchor="ctr"/>
-          <a:lstStyle/>
-          <a:p>
-            <a:pPr algn="ctr"/>
-          </a:p>
-        </p:txBody>
-      </p:sp>
-      <p:sp>
-        <p:nvSpPr>
-          <p:cNvPr id="5" name="TextBox 4"/>
-          <p:cNvSpPr txBox="1"/>
-          <p:nvPr/>
-        </p:nvSpPr>
-        <p:spPr>
-          <a:xfrm>
-            <a:off x="0" y="3291840"/>
-            <a:ext cx="12191695" cy="1371600"/>
-          </a:xfrm>
-          <a:prstGeom prst="rect">
-            <a:avLst/>
-          </a:prstGeom>
-          <a:noFill/>
-        </p:spPr>
-        <p:txBody>
-          <a:bodyPr wrap="none">
-            <a:spAutoFit/>
-          </a:bodyPr>
-          <a:lstStyle/>
-          <a:p/>
-          <a:p>
-            <a:pPr algn="ctr">
-              <a:defRPr sz="4000" b="1">
-                <a:solidFill>
-                  <a:srgbClr val="FFFFFF"/>
-                </a:solidFill>
-                <a:latin typeface="Hiragino Sans"/>
-              </a:defRPr>
-            </a:pPr>
-            <a:r>
-              <a:t>3大業務と銀行収益の仕組み</a:t>
+              <a:t>3. 為替業務：現金を運ばず、安全、迅速に決済を完了させる。</a:t>
             </a:r>
           </a:p>
         </p:txBody>
@@ -4174,7 +4141,7 @@
               </a:defRPr>
             </a:pPr>
             <a:r>
-              <a:t>4. 3大業務と銀行収益の仕組み</a:t>
+              <a:t>4. 収益の源泉：利ざやと信用創造</a:t>
             </a:r>
           </a:p>
         </p:txBody>
@@ -4254,7 +4221,23 @@
               </a:defRPr>
             </a:pPr>
             <a:r>
-              <a:t>1. 預金業務：大切な資産を安全に預かる。</a:t>
+              <a:t>■ 「利ざや」の仕組み</a:t>
+            </a:r>
+          </a:p>
+          <a:p>
+            <a:pPr lvl="1">
+              <a:spcAft>
+                <a:spcPts val="2400"/>
+              </a:spcAft>
+              <a:defRPr sz="2200">
+                <a:solidFill>
+                  <a:srgbClr val="333333"/>
+                </a:solidFill>
+                <a:latin typeface="Hiragino Sans"/>
+              </a:defRPr>
+            </a:pPr>
+            <a:r>
+              <a:t>・貸出金利（受取）と預金利息（支払）の差額こそが利益。</a:t>
             </a:r>
           </a:p>
           <a:p>
@@ -4270,7 +4253,7 @@
               </a:defRPr>
             </a:pPr>
             <a:r>
-              <a:t>2. 貸出業務：成長を望む企業や個人へ資金を貸し付ける。</a:t>
+              <a:t>■ 信用創造機能</a:t>
             </a:r>
           </a:p>
           <a:p>
@@ -4286,11 +4269,11 @@
               </a:defRPr>
             </a:pPr>
             <a:r>
-              <a:t>・証書貸付、手形割引など。</a:t>
-            </a:r>
-          </a:p>
-          <a:p>
-            <a:pPr>
+              <a:t>・預金と貸出を繰り返すことで、世の日の中の通貨量を増大させる。</a:t>
+            </a:r>
+          </a:p>
+          <a:p>
+            <a:pPr lvl="1">
               <a:spcAft>
                 <a:spcPts val="2400"/>
               </a:spcAft>
@@ -4302,7 +4285,7 @@
               </a:defRPr>
             </a:pPr>
             <a:r>
-              <a:t>3. 為替業務：現金を運ばず、安全、迅速に決済を完了させる。</a:t>
+              <a:t>・経済を膨らませ、社会の成長を加速させる独自の機能。</a:t>
             </a:r>
           </a:p>
         </p:txBody>
@@ -4316,6 +4299,178 @@
 </file>
 
 <file path=ppt/slides/slide14.xml><?xml version="1.0" encoding="utf-8"?>
+<p:sld xmlns:a="http://schemas.openxmlformats.org/drawingml/2006/main" xmlns:p="http://schemas.openxmlformats.org/presentationml/2006/main" xmlns:r="http://schemas.openxmlformats.org/officeDocument/2006/relationships">
+  <p:cSld>
+    <p:spTree>
+      <p:nvGrpSpPr>
+        <p:cNvPr id="1" name=""/>
+        <p:cNvGrpSpPr/>
+        <p:nvPr/>
+      </p:nvGrpSpPr>
+      <p:grpSpPr/>
+      <p:sp>
+        <p:nvSpPr>
+          <p:cNvPr id="2" name="Rectangle 1"/>
+          <p:cNvSpPr/>
+          <p:nvPr/>
+        </p:nvSpPr>
+        <p:spPr>
+          <a:xfrm>
+            <a:off x="0" y="0"/>
+            <a:ext cx="12191695" cy="6858000"/>
+          </a:xfrm>
+          <a:prstGeom prst="rect">
+            <a:avLst/>
+          </a:prstGeom>
+          <a:solidFill>
+            <a:srgbClr val="143D98"/>
+          </a:solidFill>
+        </p:spPr>
+        <p:style>
+          <a:lnRef idx="1">
+            <a:schemeClr val="accent1"/>
+          </a:lnRef>
+          <a:fillRef idx="3">
+            <a:schemeClr val="accent1"/>
+          </a:fillRef>
+          <a:effectRef idx="2">
+            <a:schemeClr val="accent1"/>
+          </a:effectRef>
+          <a:fontRef idx="minor">
+            <a:schemeClr val="lt1"/>
+          </a:fontRef>
+        </p:style>
+        <p:txBody>
+          <a:bodyPr rtlCol="0" anchor="ctr"/>
+          <a:lstStyle/>
+          <a:p>
+            <a:pPr algn="ctr"/>
+          </a:p>
+        </p:txBody>
+      </p:sp>
+      <p:sp>
+        <p:nvSpPr>
+          <p:cNvPr id="3" name="TextBox 2"/>
+          <p:cNvSpPr txBox="1"/>
+          <p:nvPr/>
+        </p:nvSpPr>
+        <p:spPr>
+          <a:xfrm>
+            <a:off x="0" y="2011680"/>
+            <a:ext cx="12191695" cy="914400"/>
+          </a:xfrm>
+          <a:prstGeom prst="rect">
+            <a:avLst/>
+          </a:prstGeom>
+          <a:noFill/>
+        </p:spPr>
+        <p:txBody>
+          <a:bodyPr wrap="none">
+            <a:spAutoFit/>
+          </a:bodyPr>
+          <a:lstStyle/>
+          <a:p/>
+          <a:p>
+            <a:pPr algn="ctr">
+              <a:defRPr sz="2800">
+                <a:solidFill>
+                  <a:srgbClr val="E6D0A4"/>
+                </a:solidFill>
+                <a:latin typeface="Hiragino Sans"/>
+              </a:defRPr>
+            </a:pPr>
+            <a:r>
+              <a:t>Section 05</a:t>
+            </a:r>
+          </a:p>
+        </p:txBody>
+      </p:sp>
+      <p:sp>
+        <p:nvSpPr>
+          <p:cNvPr id="4" name="Rectangle 3"/>
+          <p:cNvSpPr/>
+          <p:nvPr/>
+        </p:nvSpPr>
+        <p:spPr>
+          <a:xfrm>
+            <a:off x="4876678" y="2926080"/>
+            <a:ext cx="2438339" cy="18288"/>
+          </a:xfrm>
+          <a:prstGeom prst="rect">
+            <a:avLst/>
+          </a:prstGeom>
+          <a:solidFill>
+            <a:srgbClr val="E6D0A4"/>
+          </a:solidFill>
+        </p:spPr>
+        <p:style>
+          <a:lnRef idx="1">
+            <a:schemeClr val="accent1"/>
+          </a:lnRef>
+          <a:fillRef idx="3">
+            <a:schemeClr val="accent1"/>
+          </a:fillRef>
+          <a:effectRef idx="2">
+            <a:schemeClr val="accent1"/>
+          </a:effectRef>
+          <a:fontRef idx="minor">
+            <a:schemeClr val="lt1"/>
+          </a:fontRef>
+        </p:style>
+        <p:txBody>
+          <a:bodyPr rtlCol="0" anchor="ctr"/>
+          <a:lstStyle/>
+          <a:p>
+            <a:pPr algn="ctr"/>
+          </a:p>
+        </p:txBody>
+      </p:sp>
+      <p:sp>
+        <p:nvSpPr>
+          <p:cNvPr id="5" name="TextBox 4"/>
+          <p:cNvSpPr txBox="1"/>
+          <p:nvPr/>
+        </p:nvSpPr>
+        <p:spPr>
+          <a:xfrm>
+            <a:off x="0" y="3291840"/>
+            <a:ext cx="12191695" cy="1371600"/>
+          </a:xfrm>
+          <a:prstGeom prst="rect">
+            <a:avLst/>
+          </a:prstGeom>
+          <a:noFill/>
+        </p:spPr>
+        <p:txBody>
+          <a:bodyPr wrap="none">
+            <a:spAutoFit/>
+          </a:bodyPr>
+          <a:lstStyle/>
+          <a:p/>
+          <a:p>
+            <a:pPr algn="ctr">
+              <a:defRPr sz="4000" b="1">
+                <a:solidFill>
+                  <a:srgbClr val="FFFFFF"/>
+                </a:solidFill>
+                <a:latin typeface="Hiragino Sans"/>
+              </a:defRPr>
+            </a:pPr>
+            <a:r>
+              <a:t>業界を取り巻く現状と直面する課題</a:t>
+            </a:r>
+          </a:p>
+        </p:txBody>
+      </p:sp>
+    </p:spTree>
+  </p:cSld>
+  <p:clrMapOvr>
+    <a:masterClrMapping/>
+  </p:clrMapOvr>
+</p:sld>
+</file>
+
+<file path=ppt/slides/slide15.xml><?xml version="1.0" encoding="utf-8"?>
 <p:sld xmlns:a="http://schemas.openxmlformats.org/drawingml/2006/main" xmlns:p="http://schemas.openxmlformats.org/presentationml/2006/main" xmlns:r="http://schemas.openxmlformats.org/officeDocument/2006/relationships">
   <p:cSld>
     <p:bg>
@@ -4444,7 +4599,7 @@
               </a:defRPr>
             </a:pPr>
             <a:r>
-              <a:t>4. 収益の源泉：利ざやと信用創造</a:t>
+              <a:t>5. 業界を取り巻く現状と直面する課題</a:t>
             </a:r>
           </a:p>
         </p:txBody>
@@ -4524,7 +4679,7 @@
               </a:defRPr>
             </a:pPr>
             <a:r>
-              <a:t>■ 「利ざや」の仕組み</a:t>
+              <a:t>■ 超低金利環境の長期化</a:t>
             </a:r>
           </a:p>
           <a:p>
@@ -4540,7 +4695,7 @@
               </a:defRPr>
             </a:pPr>
             <a:r>
-              <a:t>・貸出金利（受取）と預金利息（支払）の差額こそが利益。</a:t>
+              <a:t>・利ざやの縮小により、旧来の預貸モデルの限界が露呈。</a:t>
             </a:r>
           </a:p>
           <a:p>
@@ -4556,7 +4711,7 @@
               </a:defRPr>
             </a:pPr>
             <a:r>
-              <a:t>■ 信用創造機能</a:t>
+              <a:t>■ プラットフォーマーとの競争</a:t>
             </a:r>
           </a:p>
           <a:p>
@@ -4572,7 +4727,23 @@
               </a:defRPr>
             </a:pPr>
             <a:r>
-              <a:t>・預金と貸出を繰り返すことで、世の日の中の通貨量を増大させる。</a:t>
+              <a:t>・PayPayや楽天ポイントなど、銀行を通さない経済圏の拡大。</a:t>
+            </a:r>
+          </a:p>
+          <a:p>
+            <a:pPr>
+              <a:spcAft>
+                <a:spcPts val="2400"/>
+              </a:spcAft>
+              <a:defRPr sz="2200">
+                <a:solidFill>
+                  <a:srgbClr val="333333"/>
+                </a:solidFill>
+                <a:latin typeface="Hiragino Sans"/>
+              </a:defRPr>
+            </a:pPr>
+            <a:r>
+              <a:t>■ 更なる代替手段の脅威</a:t>
             </a:r>
           </a:p>
           <a:p>
@@ -4588,7 +4759,7 @@
               </a:defRPr>
             </a:pPr>
             <a:r>
-              <a:t>・経済を膨らませ、社会の成長を加速させる独自の機能。</a:t>
+              <a:t>・ステーブルコインや中央銀行デジタル通貨</a:t>
             </a:r>
           </a:p>
         </p:txBody>
@@ -4601,7 +4772,7 @@
 </p:sld>
 </file>
 
-<file path=ppt/slides/slide15.xml><?xml version="1.0" encoding="utf-8"?>
+<file path=ppt/slides/slide16.xml><?xml version="1.0" encoding="utf-8"?>
 <p:sld xmlns:a="http://schemas.openxmlformats.org/drawingml/2006/main" xmlns:p="http://schemas.openxmlformats.org/presentationml/2006/main" xmlns:r="http://schemas.openxmlformats.org/officeDocument/2006/relationships">
   <p:cSld>
     <p:spTree>
@@ -4683,7 +4854,7 @@
               </a:defRPr>
             </a:pPr>
             <a:r>
-              <a:t>Section 05</a:t>
+              <a:t>Section 06</a:t>
             </a:r>
           </a:p>
         </p:txBody>
@@ -4760,7 +4931,7 @@
               </a:defRPr>
             </a:pPr>
             <a:r>
-              <a:t>業界を取り巻く現状と直面する課題</a:t>
+              <a:t>未来への展望：DXと新たな金融の形</a:t>
             </a:r>
           </a:p>
         </p:txBody>
@@ -4773,7 +4944,7 @@
 </p:sld>
 </file>
 
-<file path=ppt/slides/slide16.xml><?xml version="1.0" encoding="utf-8"?>
+<file path=ppt/slides/slide17.xml><?xml version="1.0" encoding="utf-8"?>
 <p:sld xmlns:a="http://schemas.openxmlformats.org/drawingml/2006/main" xmlns:p="http://schemas.openxmlformats.org/presentationml/2006/main" xmlns:r="http://schemas.openxmlformats.org/officeDocument/2006/relationships">
   <p:cSld>
     <p:bg>
@@ -4902,7 +5073,7 @@
               </a:defRPr>
             </a:pPr>
             <a:r>
-              <a:t>5. 業界を取り巻く現状と直面する課題</a:t>
+              <a:t>6. 未来への展望：DXと新たな金融の形</a:t>
             </a:r>
           </a:p>
         </p:txBody>
@@ -4982,7 +5153,7 @@
               </a:defRPr>
             </a:pPr>
             <a:r>
-              <a:t>■ 超低金利環境の長期化</a:t>
+              <a:t>■ バンキング・アズ・ア・サービス(BaaS)</a:t>
             </a:r>
           </a:p>
           <a:p>
@@ -4998,7 +5169,7 @@
               </a:defRPr>
             </a:pPr>
             <a:r>
-              <a:t>・利ざやの縮小により、旧来の預貸モデルの限界が露呈。</a:t>
+              <a:t>・金融機能をパーツとして他業種に提供するプラットフォーム化。</a:t>
             </a:r>
           </a:p>
           <a:p>
@@ -5014,7 +5185,7 @@
               </a:defRPr>
             </a:pPr>
             <a:r>
-              <a:t>■ プラットフォーマーとの競争</a:t>
+              <a:t>■ 融合するテクノロジー：Olive、デジタル通貨</a:t>
             </a:r>
           </a:p>
           <a:p>
@@ -5030,7 +5201,7 @@
               </a:defRPr>
             </a:pPr>
             <a:r>
-              <a:t>・PayPayや楽天ポイントなど、銀行を通さない経済圏の拡大。</a:t>
+              <a:t>・銀行口座と決済アプリの完全統合。さらにCBDC（デジタル円）の可能性。</a:t>
             </a:r>
           </a:p>
           <a:p>
@@ -5046,7 +5217,7 @@
               </a:defRPr>
             </a:pPr>
             <a:r>
-              <a:t>■ 更なる代替手段の脅威</a:t>
+              <a:t>■ コンサルタントへの進化</a:t>
             </a:r>
           </a:p>
           <a:p>
@@ -5062,179 +5233,7 @@
               </a:defRPr>
             </a:pPr>
             <a:r>
-              <a:t>・ステーブルコインや中央銀行デジタル通貨</a:t>
-            </a:r>
-          </a:p>
-        </p:txBody>
-      </p:sp>
-    </p:spTree>
-  </p:cSld>
-  <p:clrMapOvr>
-    <a:masterClrMapping/>
-  </p:clrMapOvr>
-</p:sld>
-</file>
-
-<file path=ppt/slides/slide17.xml><?xml version="1.0" encoding="utf-8"?>
-<p:sld xmlns:a="http://schemas.openxmlformats.org/drawingml/2006/main" xmlns:p="http://schemas.openxmlformats.org/presentationml/2006/main" xmlns:r="http://schemas.openxmlformats.org/officeDocument/2006/relationships">
-  <p:cSld>
-    <p:spTree>
-      <p:nvGrpSpPr>
-        <p:cNvPr id="1" name=""/>
-        <p:cNvGrpSpPr/>
-        <p:nvPr/>
-      </p:nvGrpSpPr>
-      <p:grpSpPr/>
-      <p:sp>
-        <p:nvSpPr>
-          <p:cNvPr id="2" name="Rectangle 1"/>
-          <p:cNvSpPr/>
-          <p:nvPr/>
-        </p:nvSpPr>
-        <p:spPr>
-          <a:xfrm>
-            <a:off x="0" y="0"/>
-            <a:ext cx="12191695" cy="6858000"/>
-          </a:xfrm>
-          <a:prstGeom prst="rect">
-            <a:avLst/>
-          </a:prstGeom>
-          <a:solidFill>
-            <a:srgbClr val="143D98"/>
-          </a:solidFill>
-        </p:spPr>
-        <p:style>
-          <a:lnRef idx="1">
-            <a:schemeClr val="accent1"/>
-          </a:lnRef>
-          <a:fillRef idx="3">
-            <a:schemeClr val="accent1"/>
-          </a:fillRef>
-          <a:effectRef idx="2">
-            <a:schemeClr val="accent1"/>
-          </a:effectRef>
-          <a:fontRef idx="minor">
-            <a:schemeClr val="lt1"/>
-          </a:fontRef>
-        </p:style>
-        <p:txBody>
-          <a:bodyPr rtlCol="0" anchor="ctr"/>
-          <a:lstStyle/>
-          <a:p>
-            <a:pPr algn="ctr"/>
-          </a:p>
-        </p:txBody>
-      </p:sp>
-      <p:sp>
-        <p:nvSpPr>
-          <p:cNvPr id="3" name="TextBox 2"/>
-          <p:cNvSpPr txBox="1"/>
-          <p:nvPr/>
-        </p:nvSpPr>
-        <p:spPr>
-          <a:xfrm>
-            <a:off x="0" y="2011680"/>
-            <a:ext cx="12191695" cy="914400"/>
-          </a:xfrm>
-          <a:prstGeom prst="rect">
-            <a:avLst/>
-          </a:prstGeom>
-          <a:noFill/>
-        </p:spPr>
-        <p:txBody>
-          <a:bodyPr wrap="none">
-            <a:spAutoFit/>
-          </a:bodyPr>
-          <a:lstStyle/>
-          <a:p/>
-          <a:p>
-            <a:pPr algn="ctr">
-              <a:defRPr sz="2800">
-                <a:solidFill>
-                  <a:srgbClr val="E6D0A4"/>
-                </a:solidFill>
-                <a:latin typeface="Hiragino Sans"/>
-              </a:defRPr>
-            </a:pPr>
-            <a:r>
-              <a:t>Section 06</a:t>
-            </a:r>
-          </a:p>
-        </p:txBody>
-      </p:sp>
-      <p:sp>
-        <p:nvSpPr>
-          <p:cNvPr id="4" name="Rectangle 3"/>
-          <p:cNvSpPr/>
-          <p:nvPr/>
-        </p:nvSpPr>
-        <p:spPr>
-          <a:xfrm>
-            <a:off x="4876678" y="2926080"/>
-            <a:ext cx="2438339" cy="18288"/>
-          </a:xfrm>
-          <a:prstGeom prst="rect">
-            <a:avLst/>
-          </a:prstGeom>
-          <a:solidFill>
-            <a:srgbClr val="E6D0A4"/>
-          </a:solidFill>
-        </p:spPr>
-        <p:style>
-          <a:lnRef idx="1">
-            <a:schemeClr val="accent1"/>
-          </a:lnRef>
-          <a:fillRef idx="3">
-            <a:schemeClr val="accent1"/>
-          </a:fillRef>
-          <a:effectRef idx="2">
-            <a:schemeClr val="accent1"/>
-          </a:effectRef>
-          <a:fontRef idx="minor">
-            <a:schemeClr val="lt1"/>
-          </a:fontRef>
-        </p:style>
-        <p:txBody>
-          <a:bodyPr rtlCol="0" anchor="ctr"/>
-          <a:lstStyle/>
-          <a:p>
-            <a:pPr algn="ctr"/>
-          </a:p>
-        </p:txBody>
-      </p:sp>
-      <p:sp>
-        <p:nvSpPr>
-          <p:cNvPr id="5" name="TextBox 4"/>
-          <p:cNvSpPr txBox="1"/>
-          <p:nvPr/>
-        </p:nvSpPr>
-        <p:spPr>
-          <a:xfrm>
-            <a:off x="0" y="3291840"/>
-            <a:ext cx="12191695" cy="1371600"/>
-          </a:xfrm>
-          <a:prstGeom prst="rect">
-            <a:avLst/>
-          </a:prstGeom>
-          <a:noFill/>
-        </p:spPr>
-        <p:txBody>
-          <a:bodyPr wrap="none">
-            <a:spAutoFit/>
-          </a:bodyPr>
-          <a:lstStyle/>
-          <a:p/>
-          <a:p>
-            <a:pPr algn="ctr">
-              <a:defRPr sz="4000" b="1">
-                <a:solidFill>
-                  <a:srgbClr val="FFFFFF"/>
-                </a:solidFill>
-                <a:latin typeface="Hiragino Sans"/>
-              </a:defRPr>
-            </a:pPr>
-            <a:r>
-              <a:t>未来への展望：DXと新たな金融の形</a:t>
+              <a:t>・「金貸し」から、顧客の経営課題を解決するパートナーへ。</a:t>
             </a:r>
           </a:p>
         </p:txBody>
@@ -5376,7 +5375,7 @@
               </a:defRPr>
             </a:pPr>
             <a:r>
-              <a:t>6. 未来への展望：DXと新たな金融の形</a:t>
+              <a:t>まとめ：信頼を基盤に、未来を創る</a:t>
             </a:r>
           </a:p>
         </p:txBody>
@@ -5456,23 +5455,7 @@
               </a:defRPr>
             </a:pPr>
             <a:r>
-              <a:t>■ バンキング・アズ・ア・サービス(BaaS)</a:t>
-            </a:r>
-          </a:p>
-          <a:p>
-            <a:pPr lvl="1">
-              <a:spcAft>
-                <a:spcPts val="2400"/>
-              </a:spcAft>
-              <a:defRPr sz="2200">
-                <a:solidFill>
-                  <a:srgbClr val="333333"/>
-                </a:solidFill>
-                <a:latin typeface="Hiragino Sans"/>
-              </a:defRPr>
-            </a:pPr>
-            <a:r>
-              <a:t>・金融機能をパーツとして他業種に提供するプラットフォーム化。</a:t>
+              <a:t>・銀行は社会の「心臓」であり、血液（資金）を循環させる責務がある。</a:t>
             </a:r>
           </a:p>
           <a:p>
@@ -5488,23 +5471,7 @@
               </a:defRPr>
             </a:pPr>
             <a:r>
-              <a:t>■ 融合するテクノロジー：Olive、デジタル通貨</a:t>
-            </a:r>
-          </a:p>
-          <a:p>
-            <a:pPr lvl="1">
-              <a:spcAft>
-                <a:spcPts val="2400"/>
-              </a:spcAft>
-              <a:defRPr sz="2200">
-                <a:solidFill>
-                  <a:srgbClr val="333333"/>
-                </a:solidFill>
-                <a:latin typeface="Hiragino Sans"/>
-              </a:defRPr>
-            </a:pPr>
-            <a:r>
-              <a:t>・銀行口座と決済アプリの完全統合。さらにCBDC（デジタル円）の可能性。</a:t>
+              <a:t>・伝統的なモデルからの脱却と、デジタルとの融合が不可避である。</a:t>
             </a:r>
           </a:p>
           <a:p>
@@ -5520,11 +5487,11 @@
               </a:defRPr>
             </a:pPr>
             <a:r>
-              <a:t>■ コンサルタントへの進化</a:t>
-            </a:r>
-          </a:p>
-          <a:p>
-            <a:pPr lvl="1">
+              <a:t>・「信頼」という最大の無形資産を、どうテックと掛け合わせるか。</a:t>
+            </a:r>
+          </a:p>
+          <a:p>
+            <a:pPr>
               <a:spcAft>
                 <a:spcPts val="2400"/>
               </a:spcAft>
@@ -5536,7 +5503,7 @@
               </a:defRPr>
             </a:pPr>
             <a:r>
-              <a:t>・「金貸し」から、顧客の経営課題を解決するパートナーへ。</a:t>
+              <a:t>・本日の学びが、金融の未来を考えるきっかけになれば幸いです。</a:t>
             </a:r>
           </a:p>
         </p:txBody>
@@ -5678,7 +5645,7 @@
               </a:defRPr>
             </a:pPr>
             <a:r>
-              <a:t>まとめ：信頼を基盤に、未来を創る</a:t>
+              <a:t>参考一覧</a:t>
             </a:r>
           </a:p>
         </p:txBody>
@@ -5758,55 +5725,7 @@
               </a:defRPr>
             </a:pPr>
             <a:r>
-              <a:t>・銀行は社会の「心臓」であり、血液（資金）を循環させる責務がある。</a:t>
-            </a:r>
-          </a:p>
-          <a:p>
-            <a:pPr>
-              <a:spcAft>
-                <a:spcPts val="2400"/>
-              </a:spcAft>
-              <a:defRPr sz="2200">
-                <a:solidFill>
-                  <a:srgbClr val="333333"/>
-                </a:solidFill>
-                <a:latin typeface="Hiragino Sans"/>
-              </a:defRPr>
-            </a:pPr>
-            <a:r>
-              <a:t>・伝統的なモデルからの脱却と、デジタルとの融合が不可避である。</a:t>
-            </a:r>
-          </a:p>
-          <a:p>
-            <a:pPr>
-              <a:spcAft>
-                <a:spcPts val="2400"/>
-              </a:spcAft>
-              <a:defRPr sz="2200">
-                <a:solidFill>
-                  <a:srgbClr val="333333"/>
-                </a:solidFill>
-                <a:latin typeface="Hiragino Sans"/>
-              </a:defRPr>
-            </a:pPr>
-            <a:r>
-              <a:t>・「信頼」という最大の無形資産を、どうテックと掛け合わせるか。</a:t>
-            </a:r>
-          </a:p>
-          <a:p>
-            <a:pPr>
-              <a:spcAft>
-                <a:spcPts val="2400"/>
-              </a:spcAft>
-              <a:defRPr sz="2200">
-                <a:solidFill>
-                  <a:srgbClr val="333333"/>
-                </a:solidFill>
-                <a:latin typeface="Hiragino Sans"/>
-              </a:defRPr>
-            </a:pPr>
-            <a:r>
-              <a:t>・本日の学びが、金融の未来を考えるきっかけになれば幸いです。</a:t>
+              <a:t>（ここに参考資料・Webサイトのリンク等を追記）</a:t>
             </a:r>
           </a:p>
         </p:txBody>
@@ -6121,228 +6040,6 @@
 </p:sld>
 </file>
 
-<file path=ppt/slides/slide20.xml><?xml version="1.0" encoding="utf-8"?>
-<p:sld xmlns:a="http://schemas.openxmlformats.org/drawingml/2006/main" xmlns:p="http://schemas.openxmlformats.org/presentationml/2006/main" xmlns:r="http://schemas.openxmlformats.org/officeDocument/2006/relationships">
-  <p:cSld>
-    <p:bg>
-      <p:bgPr>
-        <a:solidFill>
-          <a:srgbClr val="FFFFFF"/>
-        </a:solidFill>
-        <a:effectLst/>
-      </p:bgPr>
-    </p:bg>
-    <p:spTree>
-      <p:nvGrpSpPr>
-        <p:cNvPr id="1" name=""/>
-        <p:cNvGrpSpPr/>
-        <p:nvPr/>
-      </p:nvGrpSpPr>
-      <p:grpSpPr/>
-      <p:sp>
-        <p:nvSpPr>
-          <p:cNvPr id="2" name="Rectangle 1"/>
-          <p:cNvSpPr/>
-          <p:nvPr/>
-        </p:nvSpPr>
-        <p:spPr>
-          <a:xfrm>
-            <a:off x="0" y="0"/>
-            <a:ext cx="12191695" cy="45720"/>
-          </a:xfrm>
-          <a:prstGeom prst="rect">
-            <a:avLst/>
-          </a:prstGeom>
-          <a:solidFill>
-            <a:srgbClr val="143D98"/>
-          </a:solidFill>
-        </p:spPr>
-        <p:style>
-          <a:lnRef idx="1">
-            <a:schemeClr val="accent1"/>
-          </a:lnRef>
-          <a:fillRef idx="3">
-            <a:schemeClr val="accent1"/>
-          </a:fillRef>
-          <a:effectRef idx="2">
-            <a:schemeClr val="accent1"/>
-          </a:effectRef>
-          <a:fontRef idx="minor">
-            <a:schemeClr val="lt1"/>
-          </a:fontRef>
-        </p:style>
-        <p:txBody>
-          <a:bodyPr rtlCol="0" anchor="ctr"/>
-          <a:lstStyle/>
-          <a:p>
-            <a:pPr algn="ctr"/>
-          </a:p>
-        </p:txBody>
-      </p:sp>
-      <p:sp>
-        <p:nvSpPr>
-          <p:cNvPr id="3" name="Rectangle 2"/>
-          <p:cNvSpPr/>
-          <p:nvPr/>
-        </p:nvSpPr>
-        <p:spPr>
-          <a:xfrm>
-            <a:off x="457200" y="6492240"/>
-            <a:ext cx="11277295" cy="9144"/>
-          </a:xfrm>
-          <a:prstGeom prst="rect">
-            <a:avLst/>
-          </a:prstGeom>
-          <a:solidFill>
-            <a:srgbClr val="143D98"/>
-          </a:solidFill>
-        </p:spPr>
-        <p:style>
-          <a:lnRef idx="1">
-            <a:schemeClr val="accent1"/>
-          </a:lnRef>
-          <a:fillRef idx="3">
-            <a:schemeClr val="accent1"/>
-          </a:fillRef>
-          <a:effectRef idx="2">
-            <a:schemeClr val="accent1"/>
-          </a:effectRef>
-          <a:fontRef idx="minor">
-            <a:schemeClr val="lt1"/>
-          </a:fontRef>
-        </p:style>
-        <p:txBody>
-          <a:bodyPr rtlCol="0" anchor="ctr"/>
-          <a:lstStyle/>
-          <a:p>
-            <a:pPr algn="ctr"/>
-          </a:p>
-        </p:txBody>
-      </p:sp>
-      <p:sp>
-        <p:nvSpPr>
-          <p:cNvPr id="4" name="TextBox 3"/>
-          <p:cNvSpPr txBox="1"/>
-          <p:nvPr/>
-        </p:nvSpPr>
-        <p:spPr>
-          <a:xfrm>
-            <a:off x="457200" y="365760"/>
-            <a:ext cx="10972800" cy="914400"/>
-          </a:xfrm>
-          <a:prstGeom prst="rect">
-            <a:avLst/>
-          </a:prstGeom>
-          <a:noFill/>
-        </p:spPr>
-        <p:txBody>
-          <a:bodyPr wrap="none">
-            <a:spAutoFit/>
-          </a:bodyPr>
-          <a:lstStyle/>
-          <a:p>
-            <a:pPr algn="l">
-              <a:defRPr sz="3200" b="1">
-                <a:solidFill>
-                  <a:srgbClr val="143D98"/>
-                </a:solidFill>
-                <a:latin typeface="Hiragino Sans"/>
-              </a:defRPr>
-            </a:pPr>
-            <a:r>
-              <a:t>参考一覧</a:t>
-            </a:r>
-          </a:p>
-        </p:txBody>
-      </p:sp>
-      <p:sp>
-        <p:nvSpPr>
-          <p:cNvPr id="5" name="Rectangle 4"/>
-          <p:cNvSpPr/>
-          <p:nvPr/>
-        </p:nvSpPr>
-        <p:spPr>
-          <a:xfrm>
-            <a:off x="457200" y="1188720"/>
-            <a:ext cx="1371600" cy="45720"/>
-          </a:xfrm>
-          <a:prstGeom prst="rect">
-            <a:avLst/>
-          </a:prstGeom>
-          <a:solidFill>
-            <a:srgbClr val="E6D0A4"/>
-          </a:solidFill>
-        </p:spPr>
-        <p:style>
-          <a:lnRef idx="1">
-            <a:schemeClr val="accent1"/>
-          </a:lnRef>
-          <a:fillRef idx="3">
-            <a:schemeClr val="accent1"/>
-          </a:fillRef>
-          <a:effectRef idx="2">
-            <a:schemeClr val="accent1"/>
-          </a:effectRef>
-          <a:fontRef idx="minor">
-            <a:schemeClr val="lt1"/>
-          </a:fontRef>
-        </p:style>
-        <p:txBody>
-          <a:bodyPr rtlCol="0" anchor="ctr"/>
-          <a:lstStyle/>
-          <a:p>
-            <a:pPr algn="ctr"/>
-          </a:p>
-        </p:txBody>
-      </p:sp>
-      <p:sp>
-        <p:nvSpPr>
-          <p:cNvPr id="6" name="TextBox 5"/>
-          <p:cNvSpPr txBox="1"/>
-          <p:nvPr/>
-        </p:nvSpPr>
-        <p:spPr>
-          <a:xfrm>
-            <a:off x="731520" y="1463040"/>
-            <a:ext cx="10728655" cy="4754880"/>
-          </a:xfrm>
-          <a:prstGeom prst="rect">
-            <a:avLst/>
-          </a:prstGeom>
-          <a:noFill/>
-        </p:spPr>
-        <p:txBody>
-          <a:bodyPr wrap="square" anchor="ctr">
-            <a:spAutoFit/>
-          </a:bodyPr>
-          <a:lstStyle/>
-          <a:p/>
-          <a:p>
-            <a:pPr>
-              <a:spcAft>
-                <a:spcPts val="2400"/>
-              </a:spcAft>
-              <a:defRPr sz="2200">
-                <a:solidFill>
-                  <a:srgbClr val="333333"/>
-                </a:solidFill>
-                <a:latin typeface="Hiragino Sans"/>
-              </a:defRPr>
-            </a:pPr>
-            <a:r>
-              <a:t>（ここに参考資料・Webサイトのリンク等を追記）</a:t>
-            </a:r>
-          </a:p>
-        </p:txBody>
-      </p:sp>
-    </p:spTree>
-  </p:cSld>
-  <p:clrMapOvr>
-    <a:masterClrMapping/>
-  </p:clrMapOvr>
-</p:sld>
-</file>
-
 <file path=ppt/slides/slide3.xml><?xml version="1.0" encoding="utf-8"?>
 <p:sld xmlns:a="http://schemas.openxmlformats.org/drawingml/2006/main" xmlns:p="http://schemas.openxmlformats.org/presentationml/2006/main" xmlns:r="http://schemas.openxmlformats.org/officeDocument/2006/relationships">
   <p:cSld>
@@ -7118,7 +6815,7 @@
               </a:defRPr>
             </a:pPr>
             <a:r>
-              <a:t>2. 銀行の歴史（変遷のタイムライン）</a:t>
+              <a:t>2. 銀行の歴史（欧州の起源と近代制度）</a:t>
             </a:r>
           </a:p>
         </p:txBody>
@@ -7163,30 +6860,126 @@
           </a:p>
         </p:txBody>
       </p:sp>
-      <p:pic>
-        <p:nvPicPr>
-          <p:cNvPr id="6" name="Picture 5" descr="history_timeline.png"/>
-          <p:cNvPicPr>
-            <a:picLocks noChangeAspect="1"/>
-          </p:cNvPicPr>
-          <p:nvPr/>
-        </p:nvPicPr>
-        <p:blipFill>
-          <a:blip r:embed="rId2"/>
-          <a:stretch>
-            <a:fillRect/>
-          </a:stretch>
-        </p:blipFill>
-        <p:spPr>
-          <a:xfrm>
-            <a:off x="3764127" y="1463040"/>
-            <a:ext cx="4663440" cy="4663440"/>
-          </a:xfrm>
-          <a:prstGeom prst="rect">
-            <a:avLst/>
-          </a:prstGeom>
-        </p:spPr>
-      </p:pic>
+      <p:sp>
+        <p:nvSpPr>
+          <p:cNvPr id="6" name="TextBox 5"/>
+          <p:cNvSpPr txBox="1"/>
+          <p:nvPr/>
+        </p:nvSpPr>
+        <p:spPr>
+          <a:xfrm>
+            <a:off x="731520" y="1463040"/>
+            <a:ext cx="10728655" cy="4754880"/>
+          </a:xfrm>
+          <a:prstGeom prst="rect">
+            <a:avLst/>
+          </a:prstGeom>
+          <a:noFill/>
+        </p:spPr>
+        <p:txBody>
+          <a:bodyPr wrap="square" anchor="ctr">
+            <a:spAutoFit/>
+          </a:bodyPr>
+          <a:lstStyle/>
+          <a:p/>
+          <a:p>
+            <a:pPr>
+              <a:spcAft>
+                <a:spcPts val="2400"/>
+              </a:spcAft>
+              <a:defRPr sz="2200">
+                <a:solidFill>
+                  <a:srgbClr val="333333"/>
+                </a:solidFill>
+                <a:latin typeface="Hiragino Sans"/>
+              </a:defRPr>
+            </a:pPr>
+            <a:r>
+              <a:t>■ ヨーロッパの起源</a:t>
+            </a:r>
+          </a:p>
+          <a:p>
+            <a:pPr lvl="1">
+              <a:spcAft>
+                <a:spcPts val="2400"/>
+              </a:spcAft>
+              <a:defRPr sz="2200">
+                <a:solidFill>
+                  <a:srgbClr val="333333"/>
+                </a:solidFill>
+                <a:latin typeface="Hiragino Sans"/>
+              </a:defRPr>
+            </a:pPr>
+            <a:r>
+              <a:t>・中世の両替商や、1694年のイングランド銀行設立が近代銀行の礎に。</a:t>
+            </a:r>
+          </a:p>
+          <a:p>
+            <a:pPr>
+              <a:spcAft>
+                <a:spcPts val="2400"/>
+              </a:spcAft>
+              <a:defRPr sz="2200">
+                <a:solidFill>
+                  <a:srgbClr val="333333"/>
+                </a:solidFill>
+                <a:latin typeface="Hiragino Sans"/>
+              </a:defRPr>
+            </a:pPr>
+            <a:r>
+              <a:t>■ 日本銀行の設立（1882年）</a:t>
+            </a:r>
+          </a:p>
+          <a:p>
+            <a:pPr lvl="1">
+              <a:spcAft>
+                <a:spcPts val="2400"/>
+              </a:spcAft>
+              <a:defRPr sz="2200">
+                <a:solidFill>
+                  <a:srgbClr val="333333"/>
+                </a:solidFill>
+                <a:latin typeface="Hiragino Sans"/>
+              </a:defRPr>
+            </a:pPr>
+            <a:r>
+              <a:t>・松方デフレを経て、通貨の番人としての中央銀行が誕生。</a:t>
+            </a:r>
+          </a:p>
+          <a:p>
+            <a:pPr>
+              <a:spcAft>
+                <a:spcPts val="2400"/>
+              </a:spcAft>
+              <a:defRPr sz="2200">
+                <a:solidFill>
+                  <a:srgbClr val="333333"/>
+                </a:solidFill>
+                <a:latin typeface="Hiragino Sans"/>
+              </a:defRPr>
+            </a:pPr>
+            <a:r>
+              <a:t>■ 第一国立銀行（1873年）</a:t>
+            </a:r>
+          </a:p>
+          <a:p>
+            <a:pPr lvl="1">
+              <a:spcAft>
+                <a:spcPts val="2400"/>
+              </a:spcAft>
+              <a:defRPr sz="2200">
+                <a:solidFill>
+                  <a:srgbClr val="333333"/>
+                </a:solidFill>
+                <a:latin typeface="Hiragino Sans"/>
+              </a:defRPr>
+            </a:pPr>
+            <a:r>
+              <a:t>・渋沢栄一により設立された日本初の民間銀行。殖産興業を支えた。</a:t>
+            </a:r>
+          </a:p>
+        </p:txBody>
+      </p:sp>
     </p:spTree>
   </p:cSld>
   <p:clrMapOvr>
@@ -7324,7 +7117,7 @@
               </a:defRPr>
             </a:pPr>
             <a:r>
-              <a:t>2. 銀行の歴史（欧州の起源と近代制度）</a:t>
+              <a:t>2. 銀行の歴史（高度成長〜平成再編）</a:t>
             </a:r>
           </a:p>
         </p:txBody>
@@ -7404,7 +7197,7 @@
               </a:defRPr>
             </a:pPr>
             <a:r>
-              <a:t>■ ヨーロッパの起源</a:t>
+              <a:t>■ 高度経済成長期（1950s-70s）</a:t>
             </a:r>
           </a:p>
           <a:p>
@@ -7420,7 +7213,7 @@
               </a:defRPr>
             </a:pPr>
             <a:r>
-              <a:t>・中世の両替商や、1694年のイングランド銀行設立が近代銀行の礎に。</a:t>
+              <a:t>・旺盛な設備投資を支え、日本を世界第2位の経済大国へ導いた。</a:t>
             </a:r>
           </a:p>
           <a:p>
@@ -7436,7 +7229,7 @@
               </a:defRPr>
             </a:pPr>
             <a:r>
-              <a:t>■ 日本銀行の設立（1882年）</a:t>
+              <a:t>■ バブル崩壊と「失われた30年」</a:t>
             </a:r>
           </a:p>
           <a:p>
@@ -7452,7 +7245,7 @@
               </a:defRPr>
             </a:pPr>
             <a:r>
-              <a:t>・松方デフレを経て、通貨の番人としての中央銀行が誕生。</a:t>
+              <a:t>・1990年前後の狂奔と破綻。大規模な金融再編によりメガバンクが誕生。</a:t>
             </a:r>
           </a:p>
           <a:p>
@@ -7468,7 +7261,7 @@
               </a:defRPr>
             </a:pPr>
             <a:r>
-              <a:t>■ 第一国立銀行（1873年）</a:t>
+              <a:t>■ デジタル変革（2000s-現代）</a:t>
             </a:r>
           </a:p>
           <a:p>
@@ -7484,7 +7277,7 @@
               </a:defRPr>
             </a:pPr>
             <a:r>
-              <a:t>・渋沢栄一により設立された日本初の民間銀行。殖産興業を支えた。</a:t>
+              <a:t>・インターネットバンキングの普及と、決済の脱銀行化が進展。</a:t>
             </a:r>
           </a:p>
         </p:txBody>
@@ -7498,6 +7291,178 @@
 </file>
 
 <file path=ppt/slides/slide8.xml><?xml version="1.0" encoding="utf-8"?>
+<p:sld xmlns:a="http://schemas.openxmlformats.org/drawingml/2006/main" xmlns:p="http://schemas.openxmlformats.org/presentationml/2006/main" xmlns:r="http://schemas.openxmlformats.org/officeDocument/2006/relationships">
+  <p:cSld>
+    <p:spTree>
+      <p:nvGrpSpPr>
+        <p:cNvPr id="1" name=""/>
+        <p:cNvGrpSpPr/>
+        <p:nvPr/>
+      </p:nvGrpSpPr>
+      <p:grpSpPr/>
+      <p:sp>
+        <p:nvSpPr>
+          <p:cNvPr id="2" name="Rectangle 1"/>
+          <p:cNvSpPr/>
+          <p:nvPr/>
+        </p:nvSpPr>
+        <p:spPr>
+          <a:xfrm>
+            <a:off x="0" y="0"/>
+            <a:ext cx="12191695" cy="6858000"/>
+          </a:xfrm>
+          <a:prstGeom prst="rect">
+            <a:avLst/>
+          </a:prstGeom>
+          <a:solidFill>
+            <a:srgbClr val="143D98"/>
+          </a:solidFill>
+        </p:spPr>
+        <p:style>
+          <a:lnRef idx="1">
+            <a:schemeClr val="accent1"/>
+          </a:lnRef>
+          <a:fillRef idx="3">
+            <a:schemeClr val="accent1"/>
+          </a:fillRef>
+          <a:effectRef idx="2">
+            <a:schemeClr val="accent1"/>
+          </a:effectRef>
+          <a:fontRef idx="minor">
+            <a:schemeClr val="lt1"/>
+          </a:fontRef>
+        </p:style>
+        <p:txBody>
+          <a:bodyPr rtlCol="0" anchor="ctr"/>
+          <a:lstStyle/>
+          <a:p>
+            <a:pPr algn="ctr"/>
+          </a:p>
+        </p:txBody>
+      </p:sp>
+      <p:sp>
+        <p:nvSpPr>
+          <p:cNvPr id="3" name="TextBox 2"/>
+          <p:cNvSpPr txBox="1"/>
+          <p:nvPr/>
+        </p:nvSpPr>
+        <p:spPr>
+          <a:xfrm>
+            <a:off x="0" y="2011680"/>
+            <a:ext cx="12191695" cy="914400"/>
+          </a:xfrm>
+          <a:prstGeom prst="rect">
+            <a:avLst/>
+          </a:prstGeom>
+          <a:noFill/>
+        </p:spPr>
+        <p:txBody>
+          <a:bodyPr wrap="none">
+            <a:spAutoFit/>
+          </a:bodyPr>
+          <a:lstStyle/>
+          <a:p/>
+          <a:p>
+            <a:pPr algn="ctr">
+              <a:defRPr sz="2800">
+                <a:solidFill>
+                  <a:srgbClr val="E6D0A4"/>
+                </a:solidFill>
+                <a:latin typeface="Hiragino Sans"/>
+              </a:defRPr>
+            </a:pPr>
+            <a:r>
+              <a:t>Section 03</a:t>
+            </a:r>
+          </a:p>
+        </p:txBody>
+      </p:sp>
+      <p:sp>
+        <p:nvSpPr>
+          <p:cNvPr id="4" name="Rectangle 3"/>
+          <p:cNvSpPr/>
+          <p:nvPr/>
+        </p:nvSpPr>
+        <p:spPr>
+          <a:xfrm>
+            <a:off x="4876678" y="2926080"/>
+            <a:ext cx="2438339" cy="18288"/>
+          </a:xfrm>
+          <a:prstGeom prst="rect">
+            <a:avLst/>
+          </a:prstGeom>
+          <a:solidFill>
+            <a:srgbClr val="E6D0A4"/>
+          </a:solidFill>
+        </p:spPr>
+        <p:style>
+          <a:lnRef idx="1">
+            <a:schemeClr val="accent1"/>
+          </a:lnRef>
+          <a:fillRef idx="3">
+            <a:schemeClr val="accent1"/>
+          </a:fillRef>
+          <a:effectRef idx="2">
+            <a:schemeClr val="accent1"/>
+          </a:effectRef>
+          <a:fontRef idx="minor">
+            <a:schemeClr val="lt1"/>
+          </a:fontRef>
+        </p:style>
+        <p:txBody>
+          <a:bodyPr rtlCol="0" anchor="ctr"/>
+          <a:lstStyle/>
+          <a:p>
+            <a:pPr algn="ctr"/>
+          </a:p>
+        </p:txBody>
+      </p:sp>
+      <p:sp>
+        <p:nvSpPr>
+          <p:cNvPr id="5" name="TextBox 4"/>
+          <p:cNvSpPr txBox="1"/>
+          <p:nvPr/>
+        </p:nvSpPr>
+        <p:spPr>
+          <a:xfrm>
+            <a:off x="0" y="3291840"/>
+            <a:ext cx="12191695" cy="1371600"/>
+          </a:xfrm>
+          <a:prstGeom prst="rect">
+            <a:avLst/>
+          </a:prstGeom>
+          <a:noFill/>
+        </p:spPr>
+        <p:txBody>
+          <a:bodyPr wrap="none">
+            <a:spAutoFit/>
+          </a:bodyPr>
+          <a:lstStyle/>
+          <a:p/>
+          <a:p>
+            <a:pPr algn="ctr">
+              <a:defRPr sz="4000" b="1">
+                <a:solidFill>
+                  <a:srgbClr val="FFFFFF"/>
+                </a:solidFill>
+                <a:latin typeface="Hiragino Sans"/>
+              </a:defRPr>
+            </a:pPr>
+            <a:r>
+              <a:t>銀行の種類：役割に応じた多様なプレイヤー</a:t>
+            </a:r>
+          </a:p>
+        </p:txBody>
+      </p:sp>
+    </p:spTree>
+  </p:cSld>
+  <p:clrMapOvr>
+    <a:masterClrMapping/>
+  </p:clrMapOvr>
+</p:sld>
+</file>
+
+<file path=ppt/slides/slide9.xml><?xml version="1.0" encoding="utf-8"?>
 <p:sld xmlns:a="http://schemas.openxmlformats.org/drawingml/2006/main" xmlns:p="http://schemas.openxmlformats.org/presentationml/2006/main" xmlns:r="http://schemas.openxmlformats.org/officeDocument/2006/relationships">
   <p:cSld>
     <p:bg>
@@ -7626,7 +7591,7 @@
               </a:defRPr>
             </a:pPr>
             <a:r>
-              <a:t>2. 銀行の歴史（高度成長〜平成再編）</a:t>
+              <a:t>3. 銀行の種類：役割に応じた多様なプレイヤー</a:t>
             </a:r>
           </a:p>
         </p:txBody>
@@ -7706,7 +7671,7 @@
               </a:defRPr>
             </a:pPr>
             <a:r>
-              <a:t>■ 高度経済成長期（1950s-70s）</a:t>
+              <a:t>■ 日本銀行（中央銀行）</a:t>
             </a:r>
           </a:p>
           <a:p>
@@ -7722,7 +7687,7 @@
               </a:defRPr>
             </a:pPr>
             <a:r>
-              <a:t>・旺盛な設備投資を支え、日本を世界第2位の経済大国へ導いた。</a:t>
+              <a:t>・「銀行の銀行」「政府の銀行」「発券銀行」。</a:t>
             </a:r>
           </a:p>
           <a:p>
@@ -7738,7 +7703,7 @@
               </a:defRPr>
             </a:pPr>
             <a:r>
-              <a:t>■ バブル崩壊と「失われた30年」</a:t>
+              <a:t>■ 都市銀行（メガバンク）</a:t>
             </a:r>
           </a:p>
           <a:p>
@@ -7754,7 +7719,7 @@
               </a:defRPr>
             </a:pPr>
             <a:r>
-              <a:t>・1990年前後の狂奔と破綻。大規模な金融再編によりメガバンクが誕生。</a:t>
+              <a:t>・三菱UFJ、三井住友、みずほ。巨大な資本力で国・世界を支える。</a:t>
             </a:r>
           </a:p>
           <a:p>
@@ -7770,7 +7735,7 @@
               </a:defRPr>
             </a:pPr>
             <a:r>
-              <a:t>■ デジタル変革（2000s-現代）</a:t>
+              <a:t>■ 地方銀行・第二地銀</a:t>
             </a:r>
           </a:p>
           <a:p>
@@ -7786,179 +7751,7 @@
               </a:defRPr>
             </a:pPr>
             <a:r>
-              <a:t>・インターネットバンキングの普及と、決済の脱銀行化が進展。</a:t>
-            </a:r>
-          </a:p>
-        </p:txBody>
-      </p:sp>
-    </p:spTree>
-  </p:cSld>
-  <p:clrMapOvr>
-    <a:masterClrMapping/>
-  </p:clrMapOvr>
-</p:sld>
-</file>
-
-<file path=ppt/slides/slide9.xml><?xml version="1.0" encoding="utf-8"?>
-<p:sld xmlns:a="http://schemas.openxmlformats.org/drawingml/2006/main" xmlns:p="http://schemas.openxmlformats.org/presentationml/2006/main" xmlns:r="http://schemas.openxmlformats.org/officeDocument/2006/relationships">
-  <p:cSld>
-    <p:spTree>
-      <p:nvGrpSpPr>
-        <p:cNvPr id="1" name=""/>
-        <p:cNvGrpSpPr/>
-        <p:nvPr/>
-      </p:nvGrpSpPr>
-      <p:grpSpPr/>
-      <p:sp>
-        <p:nvSpPr>
-          <p:cNvPr id="2" name="Rectangle 1"/>
-          <p:cNvSpPr/>
-          <p:nvPr/>
-        </p:nvSpPr>
-        <p:spPr>
-          <a:xfrm>
-            <a:off x="0" y="0"/>
-            <a:ext cx="12191695" cy="6858000"/>
-          </a:xfrm>
-          <a:prstGeom prst="rect">
-            <a:avLst/>
-          </a:prstGeom>
-          <a:solidFill>
-            <a:srgbClr val="143D98"/>
-          </a:solidFill>
-        </p:spPr>
-        <p:style>
-          <a:lnRef idx="1">
-            <a:schemeClr val="accent1"/>
-          </a:lnRef>
-          <a:fillRef idx="3">
-            <a:schemeClr val="accent1"/>
-          </a:fillRef>
-          <a:effectRef idx="2">
-            <a:schemeClr val="accent1"/>
-          </a:effectRef>
-          <a:fontRef idx="minor">
-            <a:schemeClr val="lt1"/>
-          </a:fontRef>
-        </p:style>
-        <p:txBody>
-          <a:bodyPr rtlCol="0" anchor="ctr"/>
-          <a:lstStyle/>
-          <a:p>
-            <a:pPr algn="ctr"/>
-          </a:p>
-        </p:txBody>
-      </p:sp>
-      <p:sp>
-        <p:nvSpPr>
-          <p:cNvPr id="3" name="TextBox 2"/>
-          <p:cNvSpPr txBox="1"/>
-          <p:nvPr/>
-        </p:nvSpPr>
-        <p:spPr>
-          <a:xfrm>
-            <a:off x="0" y="2011680"/>
-            <a:ext cx="12191695" cy="914400"/>
-          </a:xfrm>
-          <a:prstGeom prst="rect">
-            <a:avLst/>
-          </a:prstGeom>
-          <a:noFill/>
-        </p:spPr>
-        <p:txBody>
-          <a:bodyPr wrap="none">
-            <a:spAutoFit/>
-          </a:bodyPr>
-          <a:lstStyle/>
-          <a:p/>
-          <a:p>
-            <a:pPr algn="ctr">
-              <a:defRPr sz="2800">
-                <a:solidFill>
-                  <a:srgbClr val="E6D0A4"/>
-                </a:solidFill>
-                <a:latin typeface="Hiragino Sans"/>
-              </a:defRPr>
-            </a:pPr>
-            <a:r>
-              <a:t>Section 03</a:t>
-            </a:r>
-          </a:p>
-        </p:txBody>
-      </p:sp>
-      <p:sp>
-        <p:nvSpPr>
-          <p:cNvPr id="4" name="Rectangle 3"/>
-          <p:cNvSpPr/>
-          <p:nvPr/>
-        </p:nvSpPr>
-        <p:spPr>
-          <a:xfrm>
-            <a:off x="4876678" y="2926080"/>
-            <a:ext cx="2438339" cy="18288"/>
-          </a:xfrm>
-          <a:prstGeom prst="rect">
-            <a:avLst/>
-          </a:prstGeom>
-          <a:solidFill>
-            <a:srgbClr val="E6D0A4"/>
-          </a:solidFill>
-        </p:spPr>
-        <p:style>
-          <a:lnRef idx="1">
-            <a:schemeClr val="accent1"/>
-          </a:lnRef>
-          <a:fillRef idx="3">
-            <a:schemeClr val="accent1"/>
-          </a:fillRef>
-          <a:effectRef idx="2">
-            <a:schemeClr val="accent1"/>
-          </a:effectRef>
-          <a:fontRef idx="minor">
-            <a:schemeClr val="lt1"/>
-          </a:fontRef>
-        </p:style>
-        <p:txBody>
-          <a:bodyPr rtlCol="0" anchor="ctr"/>
-          <a:lstStyle/>
-          <a:p>
-            <a:pPr algn="ctr"/>
-          </a:p>
-        </p:txBody>
-      </p:sp>
-      <p:sp>
-        <p:nvSpPr>
-          <p:cNvPr id="5" name="TextBox 4"/>
-          <p:cNvSpPr txBox="1"/>
-          <p:nvPr/>
-        </p:nvSpPr>
-        <p:spPr>
-          <a:xfrm>
-            <a:off x="0" y="3291840"/>
-            <a:ext cx="12191695" cy="1371600"/>
-          </a:xfrm>
-          <a:prstGeom prst="rect">
-            <a:avLst/>
-          </a:prstGeom>
-          <a:noFill/>
-        </p:spPr>
-        <p:txBody>
-          <a:bodyPr wrap="none">
-            <a:spAutoFit/>
-          </a:bodyPr>
-          <a:lstStyle/>
-          <a:p/>
-          <a:p>
-            <a:pPr algn="ctr">
-              <a:defRPr sz="4000" b="1">
-                <a:solidFill>
-                  <a:srgbClr val="FFFFFF"/>
-                </a:solidFill>
-                <a:latin typeface="Hiragino Sans"/>
-              </a:defRPr>
-            </a:pPr>
-            <a:r>
-              <a:t>銀行の種類：役割に応じた多様なプレイヤー</a:t>
+              <a:t>・「地域密着」。地元企業との信頼関係（リレーションシップ）が命。</a:t>
             </a:r>
           </a:p>
         </p:txBody>

</xml_diff>